<commit_message>
adding files to repo as part of progress report 3
</commit_message>
<xml_diff>
--- a/docs/coursework/review-2026-09-22/FixProof - Video III - Recording Deck.pptx
+++ b/docs/coursework/review-2026-09-22/FixProof - Video III - Recording Deck.pptx
@@ -115,11 +115,6 @@
       </a:defRPr>
     </a:lvl9pPr>
   </p:defaultTextStyle>
-  <p:extLst>
-    <p:ext uri="{EFAFB233-063F-42B5-8137-9DF3F51BA10A}">
-      <p15:sldGuideLst xmlns:p15="http://schemas.microsoft.com/office/powerpoint/2012/main"/>
-    </p:ext>
-  </p:extLst>
 </p:presentation>
 </file>
 
@@ -203,9 +198,9 @@
             </a:lvl1pPr>
           </a:lstStyle>
           <a:p>
-            <a:fld id="{F4215DA3-A0FD-4D03-ACD8-6074782139ED}" type="datetimeFigureOut">
+            <a:fld id="{934A0148-9966-4AB0-8C8D-9FD9BAFA14F6}" type="datetimeFigureOut">
               <a:rPr lang="en-US" smtClean="0"/>
-              <a:t>9/23/2026</a:t>
+              <a:t>9/24/2026</a:t>
             </a:fld>
             <a:endParaRPr lang="en-US"/>
           </a:p>
@@ -361,7 +356,7 @@
             </a:lvl1pPr>
           </a:lstStyle>
           <a:p>
-            <a:fld id="{5EEDF32E-F362-4FFE-B0C4-823C480C3B43}" type="slidenum">
+            <a:fld id="{2B633430-4F69-4C9A-9580-5A9D9A40C5BC}" type="slidenum">
               <a:rPr lang="en-US" smtClean="0"/>
               <a:t>‹#›</a:t>
             </a:fld>
@@ -372,7 +367,7 @@
     </p:spTree>
     <p:extLst>
       <p:ext uri="{BB962C8B-B14F-4D97-AF65-F5344CB8AC3E}">
-        <p14:creationId xmlns:p14="http://schemas.microsoft.com/office/powerpoint/2010/main" val="820616099"/>
+        <p14:creationId xmlns:p14="http://schemas.microsoft.com/office/powerpoint/2010/main" val="412452389"/>
       </p:ext>
     </p:extLst>
   </p:cSld>
@@ -540,7 +535,7 @@
           <a:bodyPr/>
           <a:lstStyle/>
           <a:p>
-            <a:fld id="{5EEDF32E-F362-4FFE-B0C4-823C480C3B43}" type="slidenum">
+            <a:fld id="{2B633430-4F69-4C9A-9580-5A9D9A40C5BC}" type="slidenum">
               <a:rPr lang="en-US" smtClean="0"/>
               <a:t>1</a:t>
             </a:fld>
@@ -551,7 +546,7 @@
     </p:spTree>
     <p:extLst>
       <p:ext uri="{BB962C8B-B14F-4D97-AF65-F5344CB8AC3E}">
-        <p14:creationId xmlns:p14="http://schemas.microsoft.com/office/powerpoint/2010/main" val="2554869773"/>
+        <p14:creationId xmlns:p14="http://schemas.microsoft.com/office/powerpoint/2010/main" val="952957121"/>
       </p:ext>
     </p:extLst>
   </p:cSld>
@@ -629,7 +624,7 @@
           <a:bodyPr/>
           <a:lstStyle/>
           <a:p>
-            <a:fld id="{5EEDF32E-F362-4FFE-B0C4-823C480C3B43}" type="slidenum">
+            <a:fld id="{2B633430-4F69-4C9A-9580-5A9D9A40C5BC}" type="slidenum">
               <a:rPr lang="en-US" smtClean="0"/>
               <a:t>2</a:t>
             </a:fld>
@@ -640,7 +635,7 @@
     </p:spTree>
     <p:extLst>
       <p:ext uri="{BB962C8B-B14F-4D97-AF65-F5344CB8AC3E}">
-        <p14:creationId xmlns:p14="http://schemas.microsoft.com/office/powerpoint/2010/main" val="1801851285"/>
+        <p14:creationId xmlns:p14="http://schemas.microsoft.com/office/powerpoint/2010/main" val="3220154649"/>
       </p:ext>
     </p:extLst>
   </p:cSld>
@@ -718,7 +713,7 @@
           <a:bodyPr/>
           <a:lstStyle/>
           <a:p>
-            <a:fld id="{5EEDF32E-F362-4FFE-B0C4-823C480C3B43}" type="slidenum">
+            <a:fld id="{2B633430-4F69-4C9A-9580-5A9D9A40C5BC}" type="slidenum">
               <a:rPr lang="en-US" smtClean="0"/>
               <a:t>3</a:t>
             </a:fld>
@@ -729,7 +724,7 @@
     </p:spTree>
     <p:extLst>
       <p:ext uri="{BB962C8B-B14F-4D97-AF65-F5344CB8AC3E}">
-        <p14:creationId xmlns:p14="http://schemas.microsoft.com/office/powerpoint/2010/main" val="3569755687"/>
+        <p14:creationId xmlns:p14="http://schemas.microsoft.com/office/powerpoint/2010/main" val="2296464327"/>
       </p:ext>
     </p:extLst>
   </p:cSld>
@@ -807,7 +802,7 @@
           <a:bodyPr/>
           <a:lstStyle/>
           <a:p>
-            <a:fld id="{5EEDF32E-F362-4FFE-B0C4-823C480C3B43}" type="slidenum">
+            <a:fld id="{2B633430-4F69-4C9A-9580-5A9D9A40C5BC}" type="slidenum">
               <a:rPr lang="en-US" smtClean="0"/>
               <a:t>4</a:t>
             </a:fld>
@@ -818,7 +813,7 @@
     </p:spTree>
     <p:extLst>
       <p:ext uri="{BB962C8B-B14F-4D97-AF65-F5344CB8AC3E}">
-        <p14:creationId xmlns:p14="http://schemas.microsoft.com/office/powerpoint/2010/main" val="4251199733"/>
+        <p14:creationId xmlns:p14="http://schemas.microsoft.com/office/powerpoint/2010/main" val="2607306434"/>
       </p:ext>
     </p:extLst>
   </p:cSld>
@@ -896,7 +891,7 @@
           <a:bodyPr/>
           <a:lstStyle/>
           <a:p>
-            <a:fld id="{5EEDF32E-F362-4FFE-B0C4-823C480C3B43}" type="slidenum">
+            <a:fld id="{2B633430-4F69-4C9A-9580-5A9D9A40C5BC}" type="slidenum">
               <a:rPr lang="en-US" smtClean="0"/>
               <a:t>5</a:t>
             </a:fld>
@@ -907,7 +902,7 @@
     </p:spTree>
     <p:extLst>
       <p:ext uri="{BB962C8B-B14F-4D97-AF65-F5344CB8AC3E}">
-        <p14:creationId xmlns:p14="http://schemas.microsoft.com/office/powerpoint/2010/main" val="719250085"/>
+        <p14:creationId xmlns:p14="http://schemas.microsoft.com/office/powerpoint/2010/main" val="325600826"/>
       </p:ext>
     </p:extLst>
   </p:cSld>
@@ -965,7 +960,7 @@
               <a:rPr lang="en-US">
                 <a:latin typeface="Aptos" panose="020B0004020202020204" pitchFamily="34" charset="0"/>
               </a:rPr>
-              <a:t>Switch from slides to the backend. First show the frozen trial plan fields. Then show the primary dashboard or primary report for XSS 03 and 04. Open the two candidate patches side by side and highlight only String(value) versus String(value ?? ""). Finally, show XSS-P01 in the two saved supplemental result files and the later XSS 04 follow-up verdict. Keep each file on screen only long enough to point to the relevant lines.</a:t>
+              <a:t>Switch to https://fixproof.netlify.app/. Explain that this is a sanitized, read-only presentation layer over the saved evidence. Filter to Reflected XSS and open XSS 04. Point to the frozen primary result, the XSS-P01 parity failure, the original and later human records, and the patch excerpt. Then compare XSS 03 if time permits. For a technical audience, open one raw saved patch or JSON result as a backup; do not run a new model experiment or imply that the public site performs testing.</a:t>
             </a:r>
           </a:p>
         </p:txBody>
@@ -985,7 +980,7 @@
           <a:bodyPr/>
           <a:lstStyle/>
           <a:p>
-            <a:fld id="{5EEDF32E-F362-4FFE-B0C4-823C480C3B43}" type="slidenum">
+            <a:fld id="{2B633430-4F69-4C9A-9580-5A9D9A40C5BC}" type="slidenum">
               <a:rPr lang="en-US" smtClean="0"/>
               <a:t>6</a:t>
             </a:fld>
@@ -996,7 +991,7 @@
     </p:spTree>
     <p:extLst>
       <p:ext uri="{BB962C8B-B14F-4D97-AF65-F5344CB8AC3E}">
-        <p14:creationId xmlns:p14="http://schemas.microsoft.com/office/powerpoint/2010/main" val="4039325976"/>
+        <p14:creationId xmlns:p14="http://schemas.microsoft.com/office/powerpoint/2010/main" val="2160768521"/>
       </p:ext>
     </p:extLst>
   </p:cSld>
@@ -1074,7 +1069,7 @@
           <a:bodyPr/>
           <a:lstStyle/>
           <a:p>
-            <a:fld id="{5EEDF32E-F362-4FFE-B0C4-823C480C3B43}" type="slidenum">
+            <a:fld id="{2B633430-4F69-4C9A-9580-5A9D9A40C5BC}" type="slidenum">
               <a:rPr lang="en-US" smtClean="0"/>
               <a:t>7</a:t>
             </a:fld>
@@ -1085,7 +1080,7 @@
     </p:spTree>
     <p:extLst>
       <p:ext uri="{BB962C8B-B14F-4D97-AF65-F5344CB8AC3E}">
-        <p14:creationId xmlns:p14="http://schemas.microsoft.com/office/powerpoint/2010/main" val="693475462"/>
+        <p14:creationId xmlns:p14="http://schemas.microsoft.com/office/powerpoint/2010/main" val="2292338558"/>
       </p:ext>
     </p:extLst>
   </p:cSld>
@@ -1143,7 +1138,7 @@
               <a:rPr lang="en-US">
                 <a:latin typeface="Aptos" panose="020B0004020202020204" pitchFamily="34" charset="0"/>
               </a:rPr>
-              <a:t>The original ten reviews and the later fourteen records are separate evidence layers. The later decisions include five rejections, five bounded SQLi acceptances, and four traversal requests for more testing. End by stating the limits explicitly and asking one focused design question. Mention that Progress Report 3 is due October 4, Video III posts October 6, and peer feedback is due October 11. Close with the course AI-use disclosure: Codex and ChatGPT assisted implementation, analysis, and presentation preparation; separate saved OpenAI API calls proposed experimental repairs; I made the recorded human decisions and remain responsible for the claims.</a:t>
+              <a:t>The original ten reviews and the later fourteen records are separate evidence layers. The later decisions include five rejections, five bounded SQLi acceptances, and four traversal requests for more testing. Tell students that https://fixproof.netlify.app/ is a read-only reference for all 15 candidates, tests, and rationales, and invite questions through the course discussion channel. End by stating the limits explicitly and asking one focused design question. Mention that Progress Report 3 is due October 4, Video III posts October 6, and peer feedback is due October 11. Close with the course AI-use disclosure: Codex and ChatGPT assisted implementation, analysis, and presentation preparation; separate saved OpenAI API calls proposed experimental repairs; I made the recorded human decisions and remain responsible for the claims.</a:t>
             </a:r>
           </a:p>
         </p:txBody>
@@ -1163,7 +1158,7 @@
           <a:bodyPr/>
           <a:lstStyle/>
           <a:p>
-            <a:fld id="{5EEDF32E-F362-4FFE-B0C4-823C480C3B43}" type="slidenum">
+            <a:fld id="{2B633430-4F69-4C9A-9580-5A9D9A40C5BC}" type="slidenum">
               <a:rPr lang="en-US" smtClean="0"/>
               <a:t>8</a:t>
             </a:fld>
@@ -1174,7 +1169,7 @@
     </p:spTree>
     <p:extLst>
       <p:ext uri="{BB962C8B-B14F-4D97-AF65-F5344CB8AC3E}">
-        <p14:creationId xmlns:p14="http://schemas.microsoft.com/office/powerpoint/2010/main" val="1030561812"/>
+        <p14:creationId xmlns:p14="http://schemas.microsoft.com/office/powerpoint/2010/main" val="2677881691"/>
       </p:ext>
     </p:extLst>
   </p:cSld>
@@ -1252,7 +1247,7 @@
           <a:bodyPr/>
           <a:lstStyle/>
           <a:p>
-            <a:fld id="{5EEDF32E-F362-4FFE-B0C4-823C480C3B43}" type="slidenum">
+            <a:fld id="{2B633430-4F69-4C9A-9580-5A9D9A40C5BC}" type="slidenum">
               <a:rPr lang="en-US" smtClean="0"/>
               <a:t>9</a:t>
             </a:fld>
@@ -1263,7 +1258,7 @@
     </p:spTree>
     <p:extLst>
       <p:ext uri="{BB962C8B-B14F-4D97-AF65-F5344CB8AC3E}">
-        <p14:creationId xmlns:p14="http://schemas.microsoft.com/office/powerpoint/2010/main" val="3243542878"/>
+        <p14:creationId xmlns:p14="http://schemas.microsoft.com/office/powerpoint/2010/main" val="1296576924"/>
       </p:ext>
     </p:extLst>
   </p:cSld>
@@ -1295,7 +1290,7 @@
           <p:cNvPr id="2" name="Title 1">
             <a:extLst>
               <a:ext uri="{FF2B5EF4-FFF2-40B4-BE49-F238E27FC236}">
-                <a16:creationId xmlns:a16="http://schemas.microsoft.com/office/drawing/2014/main" id="{68E6415B-A1AA-7F70-432F-C2E89D7F3601}"/>
+                <a16:creationId xmlns:a16="http://schemas.microsoft.com/office/drawing/2014/main" id="{96BFCF08-AD8B-A503-44E6-94290D91F2AE}"/>
               </a:ext>
             </a:extLst>
           </p:cNvPr>
@@ -1332,7 +1327,7 @@
           <p:cNvPr id="3" name="Subtitle 2">
             <a:extLst>
               <a:ext uri="{FF2B5EF4-FFF2-40B4-BE49-F238E27FC236}">
-                <a16:creationId xmlns:a16="http://schemas.microsoft.com/office/drawing/2014/main" id="{CAB61557-57E3-8527-C6AB-1EE64B353C38}"/>
+                <a16:creationId xmlns:a16="http://schemas.microsoft.com/office/drawing/2014/main" id="{BAFBFE05-5CAD-936E-70C5-53F10AF4EE86}"/>
               </a:ext>
             </a:extLst>
           </p:cNvPr>
@@ -1402,7 +1397,7 @@
           <p:cNvPr id="4" name="Date Placeholder 3">
             <a:extLst>
               <a:ext uri="{FF2B5EF4-FFF2-40B4-BE49-F238E27FC236}">
-                <a16:creationId xmlns:a16="http://schemas.microsoft.com/office/drawing/2014/main" id="{6487BF99-A7F8-4531-E7BD-D44B8976E441}"/>
+                <a16:creationId xmlns:a16="http://schemas.microsoft.com/office/drawing/2014/main" id="{9F2476CD-20D7-1745-992B-AA6F59549E20}"/>
               </a:ext>
             </a:extLst>
           </p:cNvPr>
@@ -1418,9 +1413,9 @@
           <a:bodyPr/>
           <a:lstStyle/>
           <a:p>
-            <a:fld id="{BC98AB12-F31E-423D-87B6-2A6226D342DE}" type="datetimeFigureOut">
+            <a:fld id="{0DB9C7C9-7A34-4ADA-9761-18A9B8AD7481}" type="datetimeFigureOut">
               <a:rPr lang="en-US" smtClean="0"/>
-              <a:t>9/23/2026</a:t>
+              <a:t>9/24/2026</a:t>
             </a:fld>
             <a:endParaRPr lang="en-US"/>
           </a:p>
@@ -1431,7 +1426,7 @@
           <p:cNvPr id="5" name="Footer Placeholder 4">
             <a:extLst>
               <a:ext uri="{FF2B5EF4-FFF2-40B4-BE49-F238E27FC236}">
-                <a16:creationId xmlns:a16="http://schemas.microsoft.com/office/drawing/2014/main" id="{93767CD1-055D-5F12-4871-ADAF39DC1D7C}"/>
+                <a16:creationId xmlns:a16="http://schemas.microsoft.com/office/drawing/2014/main" id="{7CDC604E-36B1-C22F-8D75-3394549F0FB5}"/>
               </a:ext>
             </a:extLst>
           </p:cNvPr>
@@ -1456,7 +1451,7 @@
           <p:cNvPr id="6" name="Slide Number Placeholder 5">
             <a:extLst>
               <a:ext uri="{FF2B5EF4-FFF2-40B4-BE49-F238E27FC236}">
-                <a16:creationId xmlns:a16="http://schemas.microsoft.com/office/drawing/2014/main" id="{CE527EE0-CBD1-64A2-1031-6A48B34BB834}"/>
+                <a16:creationId xmlns:a16="http://schemas.microsoft.com/office/drawing/2014/main" id="{39846953-1C1D-D6EA-A2C4-D6F06D684FDD}"/>
               </a:ext>
             </a:extLst>
           </p:cNvPr>
@@ -1472,7 +1467,7 @@
           <a:bodyPr/>
           <a:lstStyle/>
           <a:p>
-            <a:fld id="{14168FE9-9AB0-46E6-BF94-FA8822E7A1CF}" type="slidenum">
+            <a:fld id="{0E90BA7C-6A98-4F12-A50D-3D5C8A272CFD}" type="slidenum">
               <a:rPr lang="en-US" smtClean="0"/>
               <a:t>‹#›</a:t>
             </a:fld>
@@ -1483,7 +1478,7 @@
     </p:spTree>
     <p:extLst>
       <p:ext uri="{BB962C8B-B14F-4D97-AF65-F5344CB8AC3E}">
-        <p14:creationId xmlns:p14="http://schemas.microsoft.com/office/powerpoint/2010/main" val="3220625599"/>
+        <p14:creationId xmlns:p14="http://schemas.microsoft.com/office/powerpoint/2010/main" val="1188975395"/>
       </p:ext>
     </p:extLst>
   </p:cSld>
@@ -1515,7 +1510,7 @@
           <p:cNvPr id="2" name="Title 1">
             <a:extLst>
               <a:ext uri="{FF2B5EF4-FFF2-40B4-BE49-F238E27FC236}">
-                <a16:creationId xmlns:a16="http://schemas.microsoft.com/office/drawing/2014/main" id="{2DBF9967-8648-B710-7EC1-55BE252F2DB9}"/>
+                <a16:creationId xmlns:a16="http://schemas.microsoft.com/office/drawing/2014/main" id="{7E6B97E1-40D8-009D-4DB1-91869BEC7B75}"/>
               </a:ext>
             </a:extLst>
           </p:cNvPr>
@@ -1543,7 +1538,7 @@
           <p:cNvPr id="3" name="Vertical Text Placeholder 2">
             <a:extLst>
               <a:ext uri="{FF2B5EF4-FFF2-40B4-BE49-F238E27FC236}">
-                <a16:creationId xmlns:a16="http://schemas.microsoft.com/office/drawing/2014/main" id="{692423E1-B9DF-70DB-F964-CB971BFA2416}"/>
+                <a16:creationId xmlns:a16="http://schemas.microsoft.com/office/drawing/2014/main" id="{763E245B-32F4-BE63-56DD-E45FD2A84E75}"/>
               </a:ext>
             </a:extLst>
           </p:cNvPr>
@@ -1600,7 +1595,7 @@
           <p:cNvPr id="4" name="Date Placeholder 3">
             <a:extLst>
               <a:ext uri="{FF2B5EF4-FFF2-40B4-BE49-F238E27FC236}">
-                <a16:creationId xmlns:a16="http://schemas.microsoft.com/office/drawing/2014/main" id="{ED57698F-EE24-F450-3D06-0BAFAD8C4DCB}"/>
+                <a16:creationId xmlns:a16="http://schemas.microsoft.com/office/drawing/2014/main" id="{BEC7EE8E-28EB-D30F-722F-F251E9761859}"/>
               </a:ext>
             </a:extLst>
           </p:cNvPr>
@@ -1616,9 +1611,9 @@
           <a:bodyPr/>
           <a:lstStyle/>
           <a:p>
-            <a:fld id="{BC98AB12-F31E-423D-87B6-2A6226D342DE}" type="datetimeFigureOut">
+            <a:fld id="{0DB9C7C9-7A34-4ADA-9761-18A9B8AD7481}" type="datetimeFigureOut">
               <a:rPr lang="en-US" smtClean="0"/>
-              <a:t>9/23/2026</a:t>
+              <a:t>9/24/2026</a:t>
             </a:fld>
             <a:endParaRPr lang="en-US"/>
           </a:p>
@@ -1629,7 +1624,7 @@
           <p:cNvPr id="5" name="Footer Placeholder 4">
             <a:extLst>
               <a:ext uri="{FF2B5EF4-FFF2-40B4-BE49-F238E27FC236}">
-                <a16:creationId xmlns:a16="http://schemas.microsoft.com/office/drawing/2014/main" id="{DCB39FD8-04D3-4B3C-96DB-BCDF24B7EF83}"/>
+                <a16:creationId xmlns:a16="http://schemas.microsoft.com/office/drawing/2014/main" id="{6DAD406B-BAAF-8554-E0CD-4931A7D62587}"/>
               </a:ext>
             </a:extLst>
           </p:cNvPr>
@@ -1654,7 +1649,7 @@
           <p:cNvPr id="6" name="Slide Number Placeholder 5">
             <a:extLst>
               <a:ext uri="{FF2B5EF4-FFF2-40B4-BE49-F238E27FC236}">
-                <a16:creationId xmlns:a16="http://schemas.microsoft.com/office/drawing/2014/main" id="{B3B756BD-A68D-D1CF-77CD-260DD117480F}"/>
+                <a16:creationId xmlns:a16="http://schemas.microsoft.com/office/drawing/2014/main" id="{AFA52B3D-8535-D1D0-7220-9FD08A99739C}"/>
               </a:ext>
             </a:extLst>
           </p:cNvPr>
@@ -1670,7 +1665,7 @@
           <a:bodyPr/>
           <a:lstStyle/>
           <a:p>
-            <a:fld id="{14168FE9-9AB0-46E6-BF94-FA8822E7A1CF}" type="slidenum">
+            <a:fld id="{0E90BA7C-6A98-4F12-A50D-3D5C8A272CFD}" type="slidenum">
               <a:rPr lang="en-US" smtClean="0"/>
               <a:t>‹#›</a:t>
             </a:fld>
@@ -1681,7 +1676,7 @@
     </p:spTree>
     <p:extLst>
       <p:ext uri="{BB962C8B-B14F-4D97-AF65-F5344CB8AC3E}">
-        <p14:creationId xmlns:p14="http://schemas.microsoft.com/office/powerpoint/2010/main" val="2071461082"/>
+        <p14:creationId xmlns:p14="http://schemas.microsoft.com/office/powerpoint/2010/main" val="3760124984"/>
       </p:ext>
     </p:extLst>
   </p:cSld>
@@ -1713,7 +1708,7 @@
           <p:cNvPr id="2" name="Vertical Title 1">
             <a:extLst>
               <a:ext uri="{FF2B5EF4-FFF2-40B4-BE49-F238E27FC236}">
-                <a16:creationId xmlns:a16="http://schemas.microsoft.com/office/drawing/2014/main" id="{BBC68CB7-62CF-9ADC-A6EB-1DC563787E6C}"/>
+                <a16:creationId xmlns:a16="http://schemas.microsoft.com/office/drawing/2014/main" id="{88449C9C-DFCE-D82F-77BB-E5FACAABB356}"/>
               </a:ext>
             </a:extLst>
           </p:cNvPr>
@@ -1746,7 +1741,7 @@
           <p:cNvPr id="3" name="Vertical Text Placeholder 2">
             <a:extLst>
               <a:ext uri="{FF2B5EF4-FFF2-40B4-BE49-F238E27FC236}">
-                <a16:creationId xmlns:a16="http://schemas.microsoft.com/office/drawing/2014/main" id="{FC8004D9-376B-5246-7BE4-FE777D12A501}"/>
+                <a16:creationId xmlns:a16="http://schemas.microsoft.com/office/drawing/2014/main" id="{A7C799BD-D2E2-C57B-0ABE-B0CC9B93F795}"/>
               </a:ext>
             </a:extLst>
           </p:cNvPr>
@@ -1808,7 +1803,7 @@
           <p:cNvPr id="4" name="Date Placeholder 3">
             <a:extLst>
               <a:ext uri="{FF2B5EF4-FFF2-40B4-BE49-F238E27FC236}">
-                <a16:creationId xmlns:a16="http://schemas.microsoft.com/office/drawing/2014/main" id="{6A4BDAC9-6F15-F7BB-C434-4F581DEA53A3}"/>
+                <a16:creationId xmlns:a16="http://schemas.microsoft.com/office/drawing/2014/main" id="{90917AD8-5208-8EF6-7072-3615822D3616}"/>
               </a:ext>
             </a:extLst>
           </p:cNvPr>
@@ -1824,9 +1819,9 @@
           <a:bodyPr/>
           <a:lstStyle/>
           <a:p>
-            <a:fld id="{BC98AB12-F31E-423D-87B6-2A6226D342DE}" type="datetimeFigureOut">
+            <a:fld id="{0DB9C7C9-7A34-4ADA-9761-18A9B8AD7481}" type="datetimeFigureOut">
               <a:rPr lang="en-US" smtClean="0"/>
-              <a:t>9/23/2026</a:t>
+              <a:t>9/24/2026</a:t>
             </a:fld>
             <a:endParaRPr lang="en-US"/>
           </a:p>
@@ -1837,7 +1832,7 @@
           <p:cNvPr id="5" name="Footer Placeholder 4">
             <a:extLst>
               <a:ext uri="{FF2B5EF4-FFF2-40B4-BE49-F238E27FC236}">
-                <a16:creationId xmlns:a16="http://schemas.microsoft.com/office/drawing/2014/main" id="{F1876109-AD77-8615-0CCA-6E9D5CA19A8A}"/>
+                <a16:creationId xmlns:a16="http://schemas.microsoft.com/office/drawing/2014/main" id="{125D1D0D-6FEF-F472-2D2A-E7116B992AD3}"/>
               </a:ext>
             </a:extLst>
           </p:cNvPr>
@@ -1862,7 +1857,7 @@
           <p:cNvPr id="6" name="Slide Number Placeholder 5">
             <a:extLst>
               <a:ext uri="{FF2B5EF4-FFF2-40B4-BE49-F238E27FC236}">
-                <a16:creationId xmlns:a16="http://schemas.microsoft.com/office/drawing/2014/main" id="{59707F8D-C172-B17B-4A93-245A9328FACA}"/>
+                <a16:creationId xmlns:a16="http://schemas.microsoft.com/office/drawing/2014/main" id="{0157CF78-A9D5-27D0-F1E5-549B24833C13}"/>
               </a:ext>
             </a:extLst>
           </p:cNvPr>
@@ -1878,7 +1873,7 @@
           <a:bodyPr/>
           <a:lstStyle/>
           <a:p>
-            <a:fld id="{14168FE9-9AB0-46E6-BF94-FA8822E7A1CF}" type="slidenum">
+            <a:fld id="{0E90BA7C-6A98-4F12-A50D-3D5C8A272CFD}" type="slidenum">
               <a:rPr lang="en-US" smtClean="0"/>
               <a:t>‹#›</a:t>
             </a:fld>
@@ -1889,7 +1884,7 @@
     </p:spTree>
     <p:extLst>
       <p:ext uri="{BB962C8B-B14F-4D97-AF65-F5344CB8AC3E}">
-        <p14:creationId xmlns:p14="http://schemas.microsoft.com/office/powerpoint/2010/main" val="790632171"/>
+        <p14:creationId xmlns:p14="http://schemas.microsoft.com/office/powerpoint/2010/main" val="3032579145"/>
       </p:ext>
     </p:extLst>
   </p:cSld>
@@ -1921,7 +1916,7 @@
           <p:cNvPr id="2" name="Title 1">
             <a:extLst>
               <a:ext uri="{FF2B5EF4-FFF2-40B4-BE49-F238E27FC236}">
-                <a16:creationId xmlns:a16="http://schemas.microsoft.com/office/drawing/2014/main" id="{5DCF7BFB-3EE6-0ADA-6B08-D5E9447FAF1E}"/>
+                <a16:creationId xmlns:a16="http://schemas.microsoft.com/office/drawing/2014/main" id="{CBB90994-CE90-A093-CD9D-6313029D579F}"/>
               </a:ext>
             </a:extLst>
           </p:cNvPr>
@@ -1949,7 +1944,7 @@
           <p:cNvPr id="3" name="Content Placeholder 2">
             <a:extLst>
               <a:ext uri="{FF2B5EF4-FFF2-40B4-BE49-F238E27FC236}">
-                <a16:creationId xmlns:a16="http://schemas.microsoft.com/office/drawing/2014/main" id="{E437BBC6-D20C-4244-B51E-779643B2CBFD}"/>
+                <a16:creationId xmlns:a16="http://schemas.microsoft.com/office/drawing/2014/main" id="{9F7DE0EF-583E-DC62-9D3B-39A63A63F6E1}"/>
               </a:ext>
             </a:extLst>
           </p:cNvPr>
@@ -2006,7 +2001,7 @@
           <p:cNvPr id="4" name="Date Placeholder 3">
             <a:extLst>
               <a:ext uri="{FF2B5EF4-FFF2-40B4-BE49-F238E27FC236}">
-                <a16:creationId xmlns:a16="http://schemas.microsoft.com/office/drawing/2014/main" id="{3A757CB8-A0B9-070F-5AAD-A851BD1C4140}"/>
+                <a16:creationId xmlns:a16="http://schemas.microsoft.com/office/drawing/2014/main" id="{92C48C40-53F3-3610-9465-9BAEB8A196FF}"/>
               </a:ext>
             </a:extLst>
           </p:cNvPr>
@@ -2022,9 +2017,9 @@
           <a:bodyPr/>
           <a:lstStyle/>
           <a:p>
-            <a:fld id="{BC98AB12-F31E-423D-87B6-2A6226D342DE}" type="datetimeFigureOut">
+            <a:fld id="{0DB9C7C9-7A34-4ADA-9761-18A9B8AD7481}" type="datetimeFigureOut">
               <a:rPr lang="en-US" smtClean="0"/>
-              <a:t>9/23/2026</a:t>
+              <a:t>9/24/2026</a:t>
             </a:fld>
             <a:endParaRPr lang="en-US"/>
           </a:p>
@@ -2035,7 +2030,7 @@
           <p:cNvPr id="5" name="Footer Placeholder 4">
             <a:extLst>
               <a:ext uri="{FF2B5EF4-FFF2-40B4-BE49-F238E27FC236}">
-                <a16:creationId xmlns:a16="http://schemas.microsoft.com/office/drawing/2014/main" id="{DA2F5DBD-D5AA-21D7-F5CE-8AE7F0D3A72F}"/>
+                <a16:creationId xmlns:a16="http://schemas.microsoft.com/office/drawing/2014/main" id="{C5058BD4-A6F1-D28B-B9B7-849565833DB7}"/>
               </a:ext>
             </a:extLst>
           </p:cNvPr>
@@ -2060,7 +2055,7 @@
           <p:cNvPr id="6" name="Slide Number Placeholder 5">
             <a:extLst>
               <a:ext uri="{FF2B5EF4-FFF2-40B4-BE49-F238E27FC236}">
-                <a16:creationId xmlns:a16="http://schemas.microsoft.com/office/drawing/2014/main" id="{0E5FBD3D-114E-0366-EB41-681B5DC3ACAB}"/>
+                <a16:creationId xmlns:a16="http://schemas.microsoft.com/office/drawing/2014/main" id="{C5BF9209-2B2E-F715-DFD4-9AE273EAEDFE}"/>
               </a:ext>
             </a:extLst>
           </p:cNvPr>
@@ -2076,7 +2071,7 @@
           <a:bodyPr/>
           <a:lstStyle/>
           <a:p>
-            <a:fld id="{14168FE9-9AB0-46E6-BF94-FA8822E7A1CF}" type="slidenum">
+            <a:fld id="{0E90BA7C-6A98-4F12-A50D-3D5C8A272CFD}" type="slidenum">
               <a:rPr lang="en-US" smtClean="0"/>
               <a:t>‹#›</a:t>
             </a:fld>
@@ -2087,7 +2082,7 @@
     </p:spTree>
     <p:extLst>
       <p:ext uri="{BB962C8B-B14F-4D97-AF65-F5344CB8AC3E}">
-        <p14:creationId xmlns:p14="http://schemas.microsoft.com/office/powerpoint/2010/main" val="3672731384"/>
+        <p14:creationId xmlns:p14="http://schemas.microsoft.com/office/powerpoint/2010/main" val="3593931239"/>
       </p:ext>
     </p:extLst>
   </p:cSld>
@@ -2119,7 +2114,7 @@
           <p:cNvPr id="2" name="Title 1">
             <a:extLst>
               <a:ext uri="{FF2B5EF4-FFF2-40B4-BE49-F238E27FC236}">
-                <a16:creationId xmlns:a16="http://schemas.microsoft.com/office/drawing/2014/main" id="{7757238C-52AF-3AAD-72E5-A3ACDE8FB5A6}"/>
+                <a16:creationId xmlns:a16="http://schemas.microsoft.com/office/drawing/2014/main" id="{C83F2483-CEA6-0492-8FFB-90D8506C7C23}"/>
               </a:ext>
             </a:extLst>
           </p:cNvPr>
@@ -2156,7 +2151,7 @@
           <p:cNvPr id="3" name="Text Placeholder 2">
             <a:extLst>
               <a:ext uri="{FF2B5EF4-FFF2-40B4-BE49-F238E27FC236}">
-                <a16:creationId xmlns:a16="http://schemas.microsoft.com/office/drawing/2014/main" id="{BB0B9B1D-F4E2-D5F4-DEFA-B3B36E8978D1}"/>
+                <a16:creationId xmlns:a16="http://schemas.microsoft.com/office/drawing/2014/main" id="{E47F4EDD-5406-94C3-FCB2-E416D0B3429E}"/>
               </a:ext>
             </a:extLst>
           </p:cNvPr>
@@ -2281,7 +2276,7 @@
           <p:cNvPr id="4" name="Date Placeholder 3">
             <a:extLst>
               <a:ext uri="{FF2B5EF4-FFF2-40B4-BE49-F238E27FC236}">
-                <a16:creationId xmlns:a16="http://schemas.microsoft.com/office/drawing/2014/main" id="{DA0CD98E-F026-B2DD-7F56-9105770BF9AA}"/>
+                <a16:creationId xmlns:a16="http://schemas.microsoft.com/office/drawing/2014/main" id="{5990EA26-D080-9D5A-5565-574FDF9B5FC2}"/>
               </a:ext>
             </a:extLst>
           </p:cNvPr>
@@ -2297,9 +2292,9 @@
           <a:bodyPr/>
           <a:lstStyle/>
           <a:p>
-            <a:fld id="{BC98AB12-F31E-423D-87B6-2A6226D342DE}" type="datetimeFigureOut">
+            <a:fld id="{0DB9C7C9-7A34-4ADA-9761-18A9B8AD7481}" type="datetimeFigureOut">
               <a:rPr lang="en-US" smtClean="0"/>
-              <a:t>9/23/2026</a:t>
+              <a:t>9/24/2026</a:t>
             </a:fld>
             <a:endParaRPr lang="en-US"/>
           </a:p>
@@ -2310,7 +2305,7 @@
           <p:cNvPr id="5" name="Footer Placeholder 4">
             <a:extLst>
               <a:ext uri="{FF2B5EF4-FFF2-40B4-BE49-F238E27FC236}">
-                <a16:creationId xmlns:a16="http://schemas.microsoft.com/office/drawing/2014/main" id="{54545A0F-615B-E4BA-053F-051583840E06}"/>
+                <a16:creationId xmlns:a16="http://schemas.microsoft.com/office/drawing/2014/main" id="{94257B6F-B5F7-F59B-1ACE-C26E2007C94A}"/>
               </a:ext>
             </a:extLst>
           </p:cNvPr>
@@ -2335,7 +2330,7 @@
           <p:cNvPr id="6" name="Slide Number Placeholder 5">
             <a:extLst>
               <a:ext uri="{FF2B5EF4-FFF2-40B4-BE49-F238E27FC236}">
-                <a16:creationId xmlns:a16="http://schemas.microsoft.com/office/drawing/2014/main" id="{76A8B37D-31C2-2C71-D2CF-E3E2AF52DA93}"/>
+                <a16:creationId xmlns:a16="http://schemas.microsoft.com/office/drawing/2014/main" id="{A2264D5D-36FB-B0FA-7D41-B477B5224326}"/>
               </a:ext>
             </a:extLst>
           </p:cNvPr>
@@ -2351,7 +2346,7 @@
           <a:bodyPr/>
           <a:lstStyle/>
           <a:p>
-            <a:fld id="{14168FE9-9AB0-46E6-BF94-FA8822E7A1CF}" type="slidenum">
+            <a:fld id="{0E90BA7C-6A98-4F12-A50D-3D5C8A272CFD}" type="slidenum">
               <a:rPr lang="en-US" smtClean="0"/>
               <a:t>‹#›</a:t>
             </a:fld>
@@ -2362,7 +2357,7 @@
     </p:spTree>
     <p:extLst>
       <p:ext uri="{BB962C8B-B14F-4D97-AF65-F5344CB8AC3E}">
-        <p14:creationId xmlns:p14="http://schemas.microsoft.com/office/powerpoint/2010/main" val="3896996161"/>
+        <p14:creationId xmlns:p14="http://schemas.microsoft.com/office/powerpoint/2010/main" val="2649998098"/>
       </p:ext>
     </p:extLst>
   </p:cSld>
@@ -2394,7 +2389,7 @@
           <p:cNvPr id="2" name="Title 1">
             <a:extLst>
               <a:ext uri="{FF2B5EF4-FFF2-40B4-BE49-F238E27FC236}">
-                <a16:creationId xmlns:a16="http://schemas.microsoft.com/office/drawing/2014/main" id="{FEE721F3-C6F6-979B-AE94-03499115373E}"/>
+                <a16:creationId xmlns:a16="http://schemas.microsoft.com/office/drawing/2014/main" id="{F4DFEC6A-18D4-C422-2D98-42C7F976F9B5}"/>
               </a:ext>
             </a:extLst>
           </p:cNvPr>
@@ -2422,7 +2417,7 @@
           <p:cNvPr id="3" name="Content Placeholder 2">
             <a:extLst>
               <a:ext uri="{FF2B5EF4-FFF2-40B4-BE49-F238E27FC236}">
-                <a16:creationId xmlns:a16="http://schemas.microsoft.com/office/drawing/2014/main" id="{64FED2D8-6D44-5B60-D894-BC283C868171}"/>
+                <a16:creationId xmlns:a16="http://schemas.microsoft.com/office/drawing/2014/main" id="{C5523865-CBDC-56E7-00F0-C46CD723ACEA}"/>
               </a:ext>
             </a:extLst>
           </p:cNvPr>
@@ -2484,7 +2479,7 @@
           <p:cNvPr id="4" name="Content Placeholder 3">
             <a:extLst>
               <a:ext uri="{FF2B5EF4-FFF2-40B4-BE49-F238E27FC236}">
-                <a16:creationId xmlns:a16="http://schemas.microsoft.com/office/drawing/2014/main" id="{58F742B5-E210-0756-D48A-A3DDA42FFBAF}"/>
+                <a16:creationId xmlns:a16="http://schemas.microsoft.com/office/drawing/2014/main" id="{1EA904EC-EB4C-80F1-8D6F-5B0D74299236}"/>
               </a:ext>
             </a:extLst>
           </p:cNvPr>
@@ -2546,7 +2541,7 @@
           <p:cNvPr id="5" name="Date Placeholder 4">
             <a:extLst>
               <a:ext uri="{FF2B5EF4-FFF2-40B4-BE49-F238E27FC236}">
-                <a16:creationId xmlns:a16="http://schemas.microsoft.com/office/drawing/2014/main" id="{E4340119-5821-F27C-1872-42DE4BD31ACC}"/>
+                <a16:creationId xmlns:a16="http://schemas.microsoft.com/office/drawing/2014/main" id="{EBDA5934-A2E5-3B5A-C368-3BF425981DC9}"/>
               </a:ext>
             </a:extLst>
           </p:cNvPr>
@@ -2562,9 +2557,9 @@
           <a:bodyPr/>
           <a:lstStyle/>
           <a:p>
-            <a:fld id="{BC98AB12-F31E-423D-87B6-2A6226D342DE}" type="datetimeFigureOut">
+            <a:fld id="{0DB9C7C9-7A34-4ADA-9761-18A9B8AD7481}" type="datetimeFigureOut">
               <a:rPr lang="en-US" smtClean="0"/>
-              <a:t>9/23/2026</a:t>
+              <a:t>9/24/2026</a:t>
             </a:fld>
             <a:endParaRPr lang="en-US"/>
           </a:p>
@@ -2575,7 +2570,7 @@
           <p:cNvPr id="6" name="Footer Placeholder 5">
             <a:extLst>
               <a:ext uri="{FF2B5EF4-FFF2-40B4-BE49-F238E27FC236}">
-                <a16:creationId xmlns:a16="http://schemas.microsoft.com/office/drawing/2014/main" id="{75B6923C-F553-C347-C572-22EB47B0CD32}"/>
+                <a16:creationId xmlns:a16="http://schemas.microsoft.com/office/drawing/2014/main" id="{D4EB7093-3A61-A47A-3B9A-581C773E0324}"/>
               </a:ext>
             </a:extLst>
           </p:cNvPr>
@@ -2600,7 +2595,7 @@
           <p:cNvPr id="7" name="Slide Number Placeholder 6">
             <a:extLst>
               <a:ext uri="{FF2B5EF4-FFF2-40B4-BE49-F238E27FC236}">
-                <a16:creationId xmlns:a16="http://schemas.microsoft.com/office/drawing/2014/main" id="{5C503430-3137-AF49-5EA0-1F90ACED47E9}"/>
+                <a16:creationId xmlns:a16="http://schemas.microsoft.com/office/drawing/2014/main" id="{59AF47EC-FAAC-A373-DA84-0C08C31C2692}"/>
               </a:ext>
             </a:extLst>
           </p:cNvPr>
@@ -2616,7 +2611,7 @@
           <a:bodyPr/>
           <a:lstStyle/>
           <a:p>
-            <a:fld id="{14168FE9-9AB0-46E6-BF94-FA8822E7A1CF}" type="slidenum">
+            <a:fld id="{0E90BA7C-6A98-4F12-A50D-3D5C8A272CFD}" type="slidenum">
               <a:rPr lang="en-US" smtClean="0"/>
               <a:t>‹#›</a:t>
             </a:fld>
@@ -2627,7 +2622,7 @@
     </p:spTree>
     <p:extLst>
       <p:ext uri="{BB962C8B-B14F-4D97-AF65-F5344CB8AC3E}">
-        <p14:creationId xmlns:p14="http://schemas.microsoft.com/office/powerpoint/2010/main" val="531391027"/>
+        <p14:creationId xmlns:p14="http://schemas.microsoft.com/office/powerpoint/2010/main" val="3243583577"/>
       </p:ext>
     </p:extLst>
   </p:cSld>
@@ -2659,7 +2654,7 @@
           <p:cNvPr id="2" name="Title 1">
             <a:extLst>
               <a:ext uri="{FF2B5EF4-FFF2-40B4-BE49-F238E27FC236}">
-                <a16:creationId xmlns:a16="http://schemas.microsoft.com/office/drawing/2014/main" id="{34E63639-A46F-1D8E-A163-D881999B7C12}"/>
+                <a16:creationId xmlns:a16="http://schemas.microsoft.com/office/drawing/2014/main" id="{9E49A65B-7DC7-6A27-3A8F-BBBAEBDBB5BE}"/>
               </a:ext>
             </a:extLst>
           </p:cNvPr>
@@ -2692,7 +2687,7 @@
           <p:cNvPr id="3" name="Text Placeholder 2">
             <a:extLst>
               <a:ext uri="{FF2B5EF4-FFF2-40B4-BE49-F238E27FC236}">
-                <a16:creationId xmlns:a16="http://schemas.microsoft.com/office/drawing/2014/main" id="{DDC7741E-0BD7-C3C4-A3C8-CF3D874D9394}"/>
+                <a16:creationId xmlns:a16="http://schemas.microsoft.com/office/drawing/2014/main" id="{3776071C-13FD-E7F7-C05C-4246FB888E42}"/>
               </a:ext>
             </a:extLst>
           </p:cNvPr>
@@ -2763,7 +2758,7 @@
           <p:cNvPr id="4" name="Content Placeholder 3">
             <a:extLst>
               <a:ext uri="{FF2B5EF4-FFF2-40B4-BE49-F238E27FC236}">
-                <a16:creationId xmlns:a16="http://schemas.microsoft.com/office/drawing/2014/main" id="{42DC4895-078B-6DEE-067C-08E8CB0D8705}"/>
+                <a16:creationId xmlns:a16="http://schemas.microsoft.com/office/drawing/2014/main" id="{60F4BF58-5A82-0FB3-661C-8601EA832480}"/>
               </a:ext>
             </a:extLst>
           </p:cNvPr>
@@ -2825,7 +2820,7 @@
           <p:cNvPr id="5" name="Text Placeholder 4">
             <a:extLst>
               <a:ext uri="{FF2B5EF4-FFF2-40B4-BE49-F238E27FC236}">
-                <a16:creationId xmlns:a16="http://schemas.microsoft.com/office/drawing/2014/main" id="{EA0A164C-A6F4-A5FA-B906-49EFF20C2933}"/>
+                <a16:creationId xmlns:a16="http://schemas.microsoft.com/office/drawing/2014/main" id="{C092ED7A-8BC4-9EF6-E5BD-8F082E4B6DAB}"/>
               </a:ext>
             </a:extLst>
           </p:cNvPr>
@@ -2896,7 +2891,7 @@
           <p:cNvPr id="6" name="Content Placeholder 5">
             <a:extLst>
               <a:ext uri="{FF2B5EF4-FFF2-40B4-BE49-F238E27FC236}">
-                <a16:creationId xmlns:a16="http://schemas.microsoft.com/office/drawing/2014/main" id="{0DF2C8B0-7DDE-B472-4839-169D5207D3A3}"/>
+                <a16:creationId xmlns:a16="http://schemas.microsoft.com/office/drawing/2014/main" id="{40F0C154-8175-3B18-CBCB-7A05A60BA845}"/>
               </a:ext>
             </a:extLst>
           </p:cNvPr>
@@ -2958,7 +2953,7 @@
           <p:cNvPr id="7" name="Date Placeholder 6">
             <a:extLst>
               <a:ext uri="{FF2B5EF4-FFF2-40B4-BE49-F238E27FC236}">
-                <a16:creationId xmlns:a16="http://schemas.microsoft.com/office/drawing/2014/main" id="{58297705-E640-9A48-6514-3AE195B157EB}"/>
+                <a16:creationId xmlns:a16="http://schemas.microsoft.com/office/drawing/2014/main" id="{6C29B297-9522-1475-1B7A-79FF3241B3E3}"/>
               </a:ext>
             </a:extLst>
           </p:cNvPr>
@@ -2974,9 +2969,9 @@
           <a:bodyPr/>
           <a:lstStyle/>
           <a:p>
-            <a:fld id="{BC98AB12-F31E-423D-87B6-2A6226D342DE}" type="datetimeFigureOut">
+            <a:fld id="{0DB9C7C9-7A34-4ADA-9761-18A9B8AD7481}" type="datetimeFigureOut">
               <a:rPr lang="en-US" smtClean="0"/>
-              <a:t>9/23/2026</a:t>
+              <a:t>9/24/2026</a:t>
             </a:fld>
             <a:endParaRPr lang="en-US"/>
           </a:p>
@@ -2987,7 +2982,7 @@
           <p:cNvPr id="8" name="Footer Placeholder 7">
             <a:extLst>
               <a:ext uri="{FF2B5EF4-FFF2-40B4-BE49-F238E27FC236}">
-                <a16:creationId xmlns:a16="http://schemas.microsoft.com/office/drawing/2014/main" id="{2CE9F2D8-8AB1-5FA0-F7EF-6AECF74361DD}"/>
+                <a16:creationId xmlns:a16="http://schemas.microsoft.com/office/drawing/2014/main" id="{A8387045-247A-5403-54D1-25AEE544ACB8}"/>
               </a:ext>
             </a:extLst>
           </p:cNvPr>
@@ -3012,7 +3007,7 @@
           <p:cNvPr id="9" name="Slide Number Placeholder 8">
             <a:extLst>
               <a:ext uri="{FF2B5EF4-FFF2-40B4-BE49-F238E27FC236}">
-                <a16:creationId xmlns:a16="http://schemas.microsoft.com/office/drawing/2014/main" id="{970E83E0-828D-DC03-4725-63CE668F3F39}"/>
+                <a16:creationId xmlns:a16="http://schemas.microsoft.com/office/drawing/2014/main" id="{662628B2-CE92-901D-5C37-1366A6EB7ADE}"/>
               </a:ext>
             </a:extLst>
           </p:cNvPr>
@@ -3028,7 +3023,7 @@
           <a:bodyPr/>
           <a:lstStyle/>
           <a:p>
-            <a:fld id="{14168FE9-9AB0-46E6-BF94-FA8822E7A1CF}" type="slidenum">
+            <a:fld id="{0E90BA7C-6A98-4F12-A50D-3D5C8A272CFD}" type="slidenum">
               <a:rPr lang="en-US" smtClean="0"/>
               <a:t>‹#›</a:t>
             </a:fld>
@@ -3039,7 +3034,7 @@
     </p:spTree>
     <p:extLst>
       <p:ext uri="{BB962C8B-B14F-4D97-AF65-F5344CB8AC3E}">
-        <p14:creationId xmlns:p14="http://schemas.microsoft.com/office/powerpoint/2010/main" val="1910468060"/>
+        <p14:creationId xmlns:p14="http://schemas.microsoft.com/office/powerpoint/2010/main" val="1183231573"/>
       </p:ext>
     </p:extLst>
   </p:cSld>
@@ -3071,7 +3066,7 @@
           <p:cNvPr id="2" name="Title 1">
             <a:extLst>
               <a:ext uri="{FF2B5EF4-FFF2-40B4-BE49-F238E27FC236}">
-                <a16:creationId xmlns:a16="http://schemas.microsoft.com/office/drawing/2014/main" id="{4FE6D46F-ABAB-A975-2699-45A945245865}"/>
+                <a16:creationId xmlns:a16="http://schemas.microsoft.com/office/drawing/2014/main" id="{6DCD504A-2043-05BE-310F-DB5384A0775B}"/>
               </a:ext>
             </a:extLst>
           </p:cNvPr>
@@ -3099,7 +3094,7 @@
           <p:cNvPr id="3" name="Date Placeholder 2">
             <a:extLst>
               <a:ext uri="{FF2B5EF4-FFF2-40B4-BE49-F238E27FC236}">
-                <a16:creationId xmlns:a16="http://schemas.microsoft.com/office/drawing/2014/main" id="{4CA1104D-CFA2-5E8C-6E52-BFCFEEA8D5B8}"/>
+                <a16:creationId xmlns:a16="http://schemas.microsoft.com/office/drawing/2014/main" id="{E6425041-2CAF-A867-6D62-05ED25A87C8A}"/>
               </a:ext>
             </a:extLst>
           </p:cNvPr>
@@ -3115,9 +3110,9 @@
           <a:bodyPr/>
           <a:lstStyle/>
           <a:p>
-            <a:fld id="{BC98AB12-F31E-423D-87B6-2A6226D342DE}" type="datetimeFigureOut">
+            <a:fld id="{0DB9C7C9-7A34-4ADA-9761-18A9B8AD7481}" type="datetimeFigureOut">
               <a:rPr lang="en-US" smtClean="0"/>
-              <a:t>9/23/2026</a:t>
+              <a:t>9/24/2026</a:t>
             </a:fld>
             <a:endParaRPr lang="en-US"/>
           </a:p>
@@ -3128,7 +3123,7 @@
           <p:cNvPr id="4" name="Footer Placeholder 3">
             <a:extLst>
               <a:ext uri="{FF2B5EF4-FFF2-40B4-BE49-F238E27FC236}">
-                <a16:creationId xmlns:a16="http://schemas.microsoft.com/office/drawing/2014/main" id="{281234A4-21F1-A97E-3C64-BD089F8B65CE}"/>
+                <a16:creationId xmlns:a16="http://schemas.microsoft.com/office/drawing/2014/main" id="{C404C01C-C159-1534-5FF5-4A640D005445}"/>
               </a:ext>
             </a:extLst>
           </p:cNvPr>
@@ -3153,7 +3148,7 @@
           <p:cNvPr id="5" name="Slide Number Placeholder 4">
             <a:extLst>
               <a:ext uri="{FF2B5EF4-FFF2-40B4-BE49-F238E27FC236}">
-                <a16:creationId xmlns:a16="http://schemas.microsoft.com/office/drawing/2014/main" id="{EC23A9D3-1442-76F5-F0CF-8D96D47D2585}"/>
+                <a16:creationId xmlns:a16="http://schemas.microsoft.com/office/drawing/2014/main" id="{5876E5F2-85BC-1DCD-C108-7F168C21508D}"/>
               </a:ext>
             </a:extLst>
           </p:cNvPr>
@@ -3169,7 +3164,7 @@
           <a:bodyPr/>
           <a:lstStyle/>
           <a:p>
-            <a:fld id="{14168FE9-9AB0-46E6-BF94-FA8822E7A1CF}" type="slidenum">
+            <a:fld id="{0E90BA7C-6A98-4F12-A50D-3D5C8A272CFD}" type="slidenum">
               <a:rPr lang="en-US" smtClean="0"/>
               <a:t>‹#›</a:t>
             </a:fld>
@@ -3180,7 +3175,7 @@
     </p:spTree>
     <p:extLst>
       <p:ext uri="{BB962C8B-B14F-4D97-AF65-F5344CB8AC3E}">
-        <p14:creationId xmlns:p14="http://schemas.microsoft.com/office/powerpoint/2010/main" val="62405526"/>
+        <p14:creationId xmlns:p14="http://schemas.microsoft.com/office/powerpoint/2010/main" val="2178380629"/>
       </p:ext>
     </p:extLst>
   </p:cSld>
@@ -3212,7 +3207,7 @@
           <p:cNvPr id="2" name="Date Placeholder 1">
             <a:extLst>
               <a:ext uri="{FF2B5EF4-FFF2-40B4-BE49-F238E27FC236}">
-                <a16:creationId xmlns:a16="http://schemas.microsoft.com/office/drawing/2014/main" id="{E3AD18DF-EC34-DB1D-12A1-50C4F270CF09}"/>
+                <a16:creationId xmlns:a16="http://schemas.microsoft.com/office/drawing/2014/main" id="{30E50F73-BC52-2A07-7E21-2FABD34D294B}"/>
               </a:ext>
             </a:extLst>
           </p:cNvPr>
@@ -3228,9 +3223,9 @@
           <a:bodyPr/>
           <a:lstStyle/>
           <a:p>
-            <a:fld id="{BC98AB12-F31E-423D-87B6-2A6226D342DE}" type="datetimeFigureOut">
+            <a:fld id="{0DB9C7C9-7A34-4ADA-9761-18A9B8AD7481}" type="datetimeFigureOut">
               <a:rPr lang="en-US" smtClean="0"/>
-              <a:t>9/23/2026</a:t>
+              <a:t>9/24/2026</a:t>
             </a:fld>
             <a:endParaRPr lang="en-US"/>
           </a:p>
@@ -3241,7 +3236,7 @@
           <p:cNvPr id="3" name="Footer Placeholder 2">
             <a:extLst>
               <a:ext uri="{FF2B5EF4-FFF2-40B4-BE49-F238E27FC236}">
-                <a16:creationId xmlns:a16="http://schemas.microsoft.com/office/drawing/2014/main" id="{C137F650-7621-E5D5-4C5B-5D15D23476F2}"/>
+                <a16:creationId xmlns:a16="http://schemas.microsoft.com/office/drawing/2014/main" id="{FBF83E7B-3CE4-3470-2B4A-D14B09B99B76}"/>
               </a:ext>
             </a:extLst>
           </p:cNvPr>
@@ -3266,7 +3261,7 @@
           <p:cNvPr id="4" name="Slide Number Placeholder 3">
             <a:extLst>
               <a:ext uri="{FF2B5EF4-FFF2-40B4-BE49-F238E27FC236}">
-                <a16:creationId xmlns:a16="http://schemas.microsoft.com/office/drawing/2014/main" id="{4BFF4C89-611F-F20B-F595-35B473D8150B}"/>
+                <a16:creationId xmlns:a16="http://schemas.microsoft.com/office/drawing/2014/main" id="{A4C71C21-EFF8-A97F-74F2-8E99EF2BF887}"/>
               </a:ext>
             </a:extLst>
           </p:cNvPr>
@@ -3282,7 +3277,7 @@
           <a:bodyPr/>
           <a:lstStyle/>
           <a:p>
-            <a:fld id="{14168FE9-9AB0-46E6-BF94-FA8822E7A1CF}" type="slidenum">
+            <a:fld id="{0E90BA7C-6A98-4F12-A50D-3D5C8A272CFD}" type="slidenum">
               <a:rPr lang="en-US" smtClean="0"/>
               <a:t>‹#›</a:t>
             </a:fld>
@@ -3293,7 +3288,7 @@
     </p:spTree>
     <p:extLst>
       <p:ext uri="{BB962C8B-B14F-4D97-AF65-F5344CB8AC3E}">
-        <p14:creationId xmlns:p14="http://schemas.microsoft.com/office/powerpoint/2010/main" val="1810387649"/>
+        <p14:creationId xmlns:p14="http://schemas.microsoft.com/office/powerpoint/2010/main" val="1448891125"/>
       </p:ext>
     </p:extLst>
   </p:cSld>
@@ -3325,7 +3320,7 @@
           <p:cNvPr id="2" name="Title 1">
             <a:extLst>
               <a:ext uri="{FF2B5EF4-FFF2-40B4-BE49-F238E27FC236}">
-                <a16:creationId xmlns:a16="http://schemas.microsoft.com/office/drawing/2014/main" id="{E48403C0-17F6-AFDE-39F0-C735B17121B0}"/>
+                <a16:creationId xmlns:a16="http://schemas.microsoft.com/office/drawing/2014/main" id="{206A1CF6-595B-8130-53DA-579C6586CD63}"/>
               </a:ext>
             </a:extLst>
           </p:cNvPr>
@@ -3362,7 +3357,7 @@
           <p:cNvPr id="3" name="Content Placeholder 2">
             <a:extLst>
               <a:ext uri="{FF2B5EF4-FFF2-40B4-BE49-F238E27FC236}">
-                <a16:creationId xmlns:a16="http://schemas.microsoft.com/office/drawing/2014/main" id="{A666DB93-9458-D080-4210-0E61402CB13F}"/>
+                <a16:creationId xmlns:a16="http://schemas.microsoft.com/office/drawing/2014/main" id="{067ADAC4-A9C4-6B97-2F14-26640BC69942}"/>
               </a:ext>
             </a:extLst>
           </p:cNvPr>
@@ -3452,7 +3447,7 @@
           <p:cNvPr id="4" name="Text Placeholder 3">
             <a:extLst>
               <a:ext uri="{FF2B5EF4-FFF2-40B4-BE49-F238E27FC236}">
-                <a16:creationId xmlns:a16="http://schemas.microsoft.com/office/drawing/2014/main" id="{0636BE8C-8BDE-43D2-ADDD-9B8620D26A0E}"/>
+                <a16:creationId xmlns:a16="http://schemas.microsoft.com/office/drawing/2014/main" id="{C03AD355-0945-9AEB-8181-0A1F4ECBA72B}"/>
               </a:ext>
             </a:extLst>
           </p:cNvPr>
@@ -3523,7 +3518,7 @@
           <p:cNvPr id="5" name="Date Placeholder 4">
             <a:extLst>
               <a:ext uri="{FF2B5EF4-FFF2-40B4-BE49-F238E27FC236}">
-                <a16:creationId xmlns:a16="http://schemas.microsoft.com/office/drawing/2014/main" id="{0EA082BC-FBDF-BEA3-5B4E-782E3C0D8370}"/>
+                <a16:creationId xmlns:a16="http://schemas.microsoft.com/office/drawing/2014/main" id="{F19D2CC1-B283-D62E-7D7E-7BACA76C939F}"/>
               </a:ext>
             </a:extLst>
           </p:cNvPr>
@@ -3539,9 +3534,9 @@
           <a:bodyPr/>
           <a:lstStyle/>
           <a:p>
-            <a:fld id="{BC98AB12-F31E-423D-87B6-2A6226D342DE}" type="datetimeFigureOut">
+            <a:fld id="{0DB9C7C9-7A34-4ADA-9761-18A9B8AD7481}" type="datetimeFigureOut">
               <a:rPr lang="en-US" smtClean="0"/>
-              <a:t>9/23/2026</a:t>
+              <a:t>9/24/2026</a:t>
             </a:fld>
             <a:endParaRPr lang="en-US"/>
           </a:p>
@@ -3552,7 +3547,7 @@
           <p:cNvPr id="6" name="Footer Placeholder 5">
             <a:extLst>
               <a:ext uri="{FF2B5EF4-FFF2-40B4-BE49-F238E27FC236}">
-                <a16:creationId xmlns:a16="http://schemas.microsoft.com/office/drawing/2014/main" id="{62B98A8B-AFAF-FD54-94E2-7C9A08077E5E}"/>
+                <a16:creationId xmlns:a16="http://schemas.microsoft.com/office/drawing/2014/main" id="{8425DD1A-B34E-8255-98C6-F636B3CAC7C5}"/>
               </a:ext>
             </a:extLst>
           </p:cNvPr>
@@ -3577,7 +3572,7 @@
           <p:cNvPr id="7" name="Slide Number Placeholder 6">
             <a:extLst>
               <a:ext uri="{FF2B5EF4-FFF2-40B4-BE49-F238E27FC236}">
-                <a16:creationId xmlns:a16="http://schemas.microsoft.com/office/drawing/2014/main" id="{FCFBD339-3D21-6D48-7A0C-F3F8CA314A95}"/>
+                <a16:creationId xmlns:a16="http://schemas.microsoft.com/office/drawing/2014/main" id="{3F051D0E-9697-D9BA-41DA-E81209976473}"/>
               </a:ext>
             </a:extLst>
           </p:cNvPr>
@@ -3593,7 +3588,7 @@
           <a:bodyPr/>
           <a:lstStyle/>
           <a:p>
-            <a:fld id="{14168FE9-9AB0-46E6-BF94-FA8822E7A1CF}" type="slidenum">
+            <a:fld id="{0E90BA7C-6A98-4F12-A50D-3D5C8A272CFD}" type="slidenum">
               <a:rPr lang="en-US" smtClean="0"/>
               <a:t>‹#›</a:t>
             </a:fld>
@@ -3604,7 +3599,7 @@
     </p:spTree>
     <p:extLst>
       <p:ext uri="{BB962C8B-B14F-4D97-AF65-F5344CB8AC3E}">
-        <p14:creationId xmlns:p14="http://schemas.microsoft.com/office/powerpoint/2010/main" val="748070585"/>
+        <p14:creationId xmlns:p14="http://schemas.microsoft.com/office/powerpoint/2010/main" val="463824837"/>
       </p:ext>
     </p:extLst>
   </p:cSld>
@@ -3636,7 +3631,7 @@
           <p:cNvPr id="2" name="Title 1">
             <a:extLst>
               <a:ext uri="{FF2B5EF4-FFF2-40B4-BE49-F238E27FC236}">
-                <a16:creationId xmlns:a16="http://schemas.microsoft.com/office/drawing/2014/main" id="{7D3F491E-6328-DC9A-4B08-7171D6A445AB}"/>
+                <a16:creationId xmlns:a16="http://schemas.microsoft.com/office/drawing/2014/main" id="{5824A4C9-22F7-DAE2-B113-CADC7214438C}"/>
               </a:ext>
             </a:extLst>
           </p:cNvPr>
@@ -3673,7 +3668,7 @@
           <p:cNvPr id="3" name="Picture Placeholder 2">
             <a:extLst>
               <a:ext uri="{FF2B5EF4-FFF2-40B4-BE49-F238E27FC236}">
-                <a16:creationId xmlns:a16="http://schemas.microsoft.com/office/drawing/2014/main" id="{CF726635-1ED8-50DE-623E-4C4DDEED80E7}"/>
+                <a16:creationId xmlns:a16="http://schemas.microsoft.com/office/drawing/2014/main" id="{654A8DBA-2E7B-85A9-0569-35552B4683EE}"/>
               </a:ext>
             </a:extLst>
           </p:cNvPr>
@@ -3740,7 +3735,7 @@
           <p:cNvPr id="4" name="Text Placeholder 3">
             <a:extLst>
               <a:ext uri="{FF2B5EF4-FFF2-40B4-BE49-F238E27FC236}">
-                <a16:creationId xmlns:a16="http://schemas.microsoft.com/office/drawing/2014/main" id="{9A4A2006-21FD-A0A1-82FF-8F005D9FA49C}"/>
+                <a16:creationId xmlns:a16="http://schemas.microsoft.com/office/drawing/2014/main" id="{74C5EA76-37CC-CF87-CD77-AFA15D31782E}"/>
               </a:ext>
             </a:extLst>
           </p:cNvPr>
@@ -3811,7 +3806,7 @@
           <p:cNvPr id="5" name="Date Placeholder 4">
             <a:extLst>
               <a:ext uri="{FF2B5EF4-FFF2-40B4-BE49-F238E27FC236}">
-                <a16:creationId xmlns:a16="http://schemas.microsoft.com/office/drawing/2014/main" id="{B40DB288-A0D4-DA62-890C-6C1BC7748122}"/>
+                <a16:creationId xmlns:a16="http://schemas.microsoft.com/office/drawing/2014/main" id="{20650BA2-F16D-B7F4-5517-11D9D658BAF5}"/>
               </a:ext>
             </a:extLst>
           </p:cNvPr>
@@ -3827,9 +3822,9 @@
           <a:bodyPr/>
           <a:lstStyle/>
           <a:p>
-            <a:fld id="{BC98AB12-F31E-423D-87B6-2A6226D342DE}" type="datetimeFigureOut">
+            <a:fld id="{0DB9C7C9-7A34-4ADA-9761-18A9B8AD7481}" type="datetimeFigureOut">
               <a:rPr lang="en-US" smtClean="0"/>
-              <a:t>9/23/2026</a:t>
+              <a:t>9/24/2026</a:t>
             </a:fld>
             <a:endParaRPr lang="en-US"/>
           </a:p>
@@ -3840,7 +3835,7 @@
           <p:cNvPr id="6" name="Footer Placeholder 5">
             <a:extLst>
               <a:ext uri="{FF2B5EF4-FFF2-40B4-BE49-F238E27FC236}">
-                <a16:creationId xmlns:a16="http://schemas.microsoft.com/office/drawing/2014/main" id="{6F6B2622-1ABE-EAAF-CFF7-17ED16094A77}"/>
+                <a16:creationId xmlns:a16="http://schemas.microsoft.com/office/drawing/2014/main" id="{F3011F4E-2CA2-30CC-702E-941EE902937E}"/>
               </a:ext>
             </a:extLst>
           </p:cNvPr>
@@ -3865,7 +3860,7 @@
           <p:cNvPr id="7" name="Slide Number Placeholder 6">
             <a:extLst>
               <a:ext uri="{FF2B5EF4-FFF2-40B4-BE49-F238E27FC236}">
-                <a16:creationId xmlns:a16="http://schemas.microsoft.com/office/drawing/2014/main" id="{881095A3-F1A7-3774-C204-159B31045034}"/>
+                <a16:creationId xmlns:a16="http://schemas.microsoft.com/office/drawing/2014/main" id="{DF657EED-C9E8-E9C2-6499-4121390252C0}"/>
               </a:ext>
             </a:extLst>
           </p:cNvPr>
@@ -3881,7 +3876,7 @@
           <a:bodyPr/>
           <a:lstStyle/>
           <a:p>
-            <a:fld id="{14168FE9-9AB0-46E6-BF94-FA8822E7A1CF}" type="slidenum">
+            <a:fld id="{0E90BA7C-6A98-4F12-A50D-3D5C8A272CFD}" type="slidenum">
               <a:rPr lang="en-US" smtClean="0"/>
               <a:t>‹#›</a:t>
             </a:fld>
@@ -3892,7 +3887,7 @@
     </p:spTree>
     <p:extLst>
       <p:ext uri="{BB962C8B-B14F-4D97-AF65-F5344CB8AC3E}">
-        <p14:creationId xmlns:p14="http://schemas.microsoft.com/office/powerpoint/2010/main" val="1788202436"/>
+        <p14:creationId xmlns:p14="http://schemas.microsoft.com/office/powerpoint/2010/main" val="1349116733"/>
       </p:ext>
     </p:extLst>
   </p:cSld>
@@ -3929,7 +3924,7 @@
           <p:cNvPr id="2" name="Title Placeholder 1">
             <a:extLst>
               <a:ext uri="{FF2B5EF4-FFF2-40B4-BE49-F238E27FC236}">
-                <a16:creationId xmlns:a16="http://schemas.microsoft.com/office/drawing/2014/main" id="{1E395E87-5D60-A924-AD6E-59FE918BF916}"/>
+                <a16:creationId xmlns:a16="http://schemas.microsoft.com/office/drawing/2014/main" id="{746A8166-D2E3-ECB8-9483-155AF4050554}"/>
               </a:ext>
             </a:extLst>
           </p:cNvPr>
@@ -3967,7 +3962,7 @@
           <p:cNvPr id="3" name="Text Placeholder 2">
             <a:extLst>
               <a:ext uri="{FF2B5EF4-FFF2-40B4-BE49-F238E27FC236}">
-                <a16:creationId xmlns:a16="http://schemas.microsoft.com/office/drawing/2014/main" id="{6FA40924-E68B-6E65-F1CD-ACA4987FF78E}"/>
+                <a16:creationId xmlns:a16="http://schemas.microsoft.com/office/drawing/2014/main" id="{7CB54FAD-5401-CC8D-8D24-502F0C78F53A}"/>
               </a:ext>
             </a:extLst>
           </p:cNvPr>
@@ -4034,7 +4029,7 @@
           <p:cNvPr id="4" name="Date Placeholder 3">
             <a:extLst>
               <a:ext uri="{FF2B5EF4-FFF2-40B4-BE49-F238E27FC236}">
-                <a16:creationId xmlns:a16="http://schemas.microsoft.com/office/drawing/2014/main" id="{A5DA3502-2FCE-ECA1-0CD4-B47E0490674D}"/>
+                <a16:creationId xmlns:a16="http://schemas.microsoft.com/office/drawing/2014/main" id="{CDADB7A6-703B-2743-A465-99FDEE7C3E24}"/>
               </a:ext>
             </a:extLst>
           </p:cNvPr>
@@ -4068,9 +4063,9 @@
             </a:lvl1pPr>
           </a:lstStyle>
           <a:p>
-            <a:fld id="{BC98AB12-F31E-423D-87B6-2A6226D342DE}" type="datetimeFigureOut">
+            <a:fld id="{0DB9C7C9-7A34-4ADA-9761-18A9B8AD7481}" type="datetimeFigureOut">
               <a:rPr lang="en-US" smtClean="0"/>
-              <a:t>9/23/2026</a:t>
+              <a:t>9/24/2026</a:t>
             </a:fld>
             <a:endParaRPr lang="en-US"/>
           </a:p>
@@ -4081,7 +4076,7 @@
           <p:cNvPr id="5" name="Footer Placeholder 4">
             <a:extLst>
               <a:ext uri="{FF2B5EF4-FFF2-40B4-BE49-F238E27FC236}">
-                <a16:creationId xmlns:a16="http://schemas.microsoft.com/office/drawing/2014/main" id="{71F0BA15-E687-5436-AB3B-8C43F25D332C}"/>
+                <a16:creationId xmlns:a16="http://schemas.microsoft.com/office/drawing/2014/main" id="{99257176-39D6-3407-4343-36752D88C353}"/>
               </a:ext>
             </a:extLst>
           </p:cNvPr>
@@ -4124,7 +4119,7 @@
           <p:cNvPr id="6" name="Slide Number Placeholder 5">
             <a:extLst>
               <a:ext uri="{FF2B5EF4-FFF2-40B4-BE49-F238E27FC236}">
-                <a16:creationId xmlns:a16="http://schemas.microsoft.com/office/drawing/2014/main" id="{E2CB88F9-DA8B-4305-3529-F29ACDE5369A}"/>
+                <a16:creationId xmlns:a16="http://schemas.microsoft.com/office/drawing/2014/main" id="{F644A64B-C7C1-33A1-5A96-941C65C3B40E}"/>
               </a:ext>
             </a:extLst>
           </p:cNvPr>
@@ -4158,7 +4153,7 @@
             </a:lvl1pPr>
           </a:lstStyle>
           <a:p>
-            <a:fld id="{14168FE9-9AB0-46E6-BF94-FA8822E7A1CF}" type="slidenum">
+            <a:fld id="{0E90BA7C-6A98-4F12-A50D-3D5C8A272CFD}" type="slidenum">
               <a:rPr lang="en-US" smtClean="0"/>
               <a:t>‹#›</a:t>
             </a:fld>
@@ -4169,7 +4164,7 @@
     </p:spTree>
     <p:extLst>
       <p:ext uri="{BB962C8B-B14F-4D97-AF65-F5344CB8AC3E}">
-        <p14:creationId xmlns:p14="http://schemas.microsoft.com/office/powerpoint/2010/main" val="185638563"/>
+        <p14:creationId xmlns:p14="http://schemas.microsoft.com/office/powerpoint/2010/main" val="3432823365"/>
       </p:ext>
     </p:extLst>
   </p:cSld>
@@ -4500,7 +4495,7 @@
           <p:cNvPr id="2" name="Rectangle 1">
             <a:extLst>
               <a:ext uri="{FF2B5EF4-FFF2-40B4-BE49-F238E27FC236}">
-                <a16:creationId xmlns:a16="http://schemas.microsoft.com/office/drawing/2014/main" id="{D5150DF7-3915-CF4F-6CEF-69B372621BCB}"/>
+                <a16:creationId xmlns:a16="http://schemas.microsoft.com/office/drawing/2014/main" id="{2195C3D9-B280-299F-AFD3-3A4414CC515E}"/>
               </a:ext>
             </a:extLst>
           </p:cNvPr>
@@ -4568,7 +4563,7 @@
           <p:cNvPr id="3" name="Rectangle: Rounded Corners 2">
             <a:extLst>
               <a:ext uri="{FF2B5EF4-FFF2-40B4-BE49-F238E27FC236}">
-                <a16:creationId xmlns:a16="http://schemas.microsoft.com/office/drawing/2014/main" id="{E1F4547C-31E5-39BC-8D0B-67C1BD0B325D}"/>
+                <a16:creationId xmlns:a16="http://schemas.microsoft.com/office/drawing/2014/main" id="{9F9AEA10-7E4C-FBFD-227E-8F66098ECF3C}"/>
               </a:ext>
             </a:extLst>
           </p:cNvPr>
@@ -4622,7 +4617,7 @@
           <p:cNvPr id="4" name="TextBox 3">
             <a:extLst>
               <a:ext uri="{FF2B5EF4-FFF2-40B4-BE49-F238E27FC236}">
-                <a16:creationId xmlns:a16="http://schemas.microsoft.com/office/drawing/2014/main" id="{D78EEE44-FB1F-D15A-7971-FD0B4879D234}"/>
+                <a16:creationId xmlns:a16="http://schemas.microsoft.com/office/drawing/2014/main" id="{0FBA0ED0-A4AC-4593-2F31-66A49BF2513F}"/>
               </a:ext>
             </a:extLst>
           </p:cNvPr>
@@ -4663,7 +4658,7 @@
           <p:cNvPr id="5" name="TextBox 4">
             <a:extLst>
               <a:ext uri="{FF2B5EF4-FFF2-40B4-BE49-F238E27FC236}">
-                <a16:creationId xmlns:a16="http://schemas.microsoft.com/office/drawing/2014/main" id="{6528869B-73E7-9142-8315-DA3BD272F134}"/>
+                <a16:creationId xmlns:a16="http://schemas.microsoft.com/office/drawing/2014/main" id="{E23C76C0-98BD-AA55-5D5C-AD45C330B8D5}"/>
               </a:ext>
             </a:extLst>
           </p:cNvPr>
@@ -4703,7 +4698,7 @@
           <p:cNvPr id="6" name="TextBox 5">
             <a:extLst>
               <a:ext uri="{FF2B5EF4-FFF2-40B4-BE49-F238E27FC236}">
-                <a16:creationId xmlns:a16="http://schemas.microsoft.com/office/drawing/2014/main" id="{4BEA3014-F082-5C39-7868-84899CD06722}"/>
+                <a16:creationId xmlns:a16="http://schemas.microsoft.com/office/drawing/2014/main" id="{8D453255-D07B-09BB-3D26-93F1FD1088B8}"/>
               </a:ext>
             </a:extLst>
           </p:cNvPr>
@@ -4743,7 +4738,7 @@
           <p:cNvPr id="7" name="TextBox 6">
             <a:extLst>
               <a:ext uri="{FF2B5EF4-FFF2-40B4-BE49-F238E27FC236}">
-                <a16:creationId xmlns:a16="http://schemas.microsoft.com/office/drawing/2014/main" id="{D7F97DE4-730A-26FC-3DCA-A95DE9B1D58E}"/>
+                <a16:creationId xmlns:a16="http://schemas.microsoft.com/office/drawing/2014/main" id="{833F1633-41D7-1948-A01B-FA72BD983976}"/>
               </a:ext>
             </a:extLst>
           </p:cNvPr>
@@ -4783,7 +4778,7 @@
           <p:cNvPr id="8" name="Rectangle: Rounded Corners 7">
             <a:extLst>
               <a:ext uri="{FF2B5EF4-FFF2-40B4-BE49-F238E27FC236}">
-                <a16:creationId xmlns:a16="http://schemas.microsoft.com/office/drawing/2014/main" id="{9F4943B8-E423-485D-D9B2-A3574D7911C5}"/>
+                <a16:creationId xmlns:a16="http://schemas.microsoft.com/office/drawing/2014/main" id="{FC6F7B36-D81F-B623-A348-70C4C1A30229}"/>
               </a:ext>
             </a:extLst>
           </p:cNvPr>
@@ -4837,7 +4832,7 @@
           <p:cNvPr id="9" name="TextBox 8">
             <a:extLst>
               <a:ext uri="{FF2B5EF4-FFF2-40B4-BE49-F238E27FC236}">
-                <a16:creationId xmlns:a16="http://schemas.microsoft.com/office/drawing/2014/main" id="{672799FA-AC67-F5E0-92BB-0455C4465549}"/>
+                <a16:creationId xmlns:a16="http://schemas.microsoft.com/office/drawing/2014/main" id="{FE94B534-506F-9687-08C3-40D38B3CC228}"/>
               </a:ext>
             </a:extLst>
           </p:cNvPr>
@@ -4877,7 +4872,7 @@
           <p:cNvPr id="10" name="TextBox 9">
             <a:extLst>
               <a:ext uri="{FF2B5EF4-FFF2-40B4-BE49-F238E27FC236}">
-                <a16:creationId xmlns:a16="http://schemas.microsoft.com/office/drawing/2014/main" id="{14B19AA7-F00E-FF93-C0CD-8B3C55CAA786}"/>
+                <a16:creationId xmlns:a16="http://schemas.microsoft.com/office/drawing/2014/main" id="{8728175A-4D44-BC48-C12F-8DC953CA8265}"/>
               </a:ext>
             </a:extLst>
           </p:cNvPr>
@@ -4917,7 +4912,7 @@
           <p:cNvPr id="11" name="TextBox 10">
             <a:extLst>
               <a:ext uri="{FF2B5EF4-FFF2-40B4-BE49-F238E27FC236}">
-                <a16:creationId xmlns:a16="http://schemas.microsoft.com/office/drawing/2014/main" id="{92486317-2B7B-3AB0-0661-26A31D480B15}"/>
+                <a16:creationId xmlns:a16="http://schemas.microsoft.com/office/drawing/2014/main" id="{A89866D1-B6AA-BDC5-D6B6-BC3E85BF6A83}"/>
               </a:ext>
             </a:extLst>
           </p:cNvPr>
@@ -4957,7 +4952,7 @@
     </p:spTree>
     <p:extLst>
       <p:ext uri="{BB962C8B-B14F-4D97-AF65-F5344CB8AC3E}">
-        <p14:creationId xmlns:p14="http://schemas.microsoft.com/office/powerpoint/2010/main" val="90129257"/>
+        <p14:creationId xmlns:p14="http://schemas.microsoft.com/office/powerpoint/2010/main" val="4280047517"/>
       </p:ext>
     </p:extLst>
   </p:cSld>
@@ -4997,7 +4992,7 @@
           <p:cNvPr id="2" name="TextBox 1">
             <a:extLst>
               <a:ext uri="{FF2B5EF4-FFF2-40B4-BE49-F238E27FC236}">
-                <a16:creationId xmlns:a16="http://schemas.microsoft.com/office/drawing/2014/main" id="{D5F2A906-18C4-3479-00D8-9EC399E6715A}"/>
+                <a16:creationId xmlns:a16="http://schemas.microsoft.com/office/drawing/2014/main" id="{F1DB1777-852F-78A9-DCA5-DEAC2E2B1AE3}"/>
               </a:ext>
             </a:extLst>
           </p:cNvPr>
@@ -5037,7 +5032,7 @@
           <p:cNvPr id="3" name="TextBox 2">
             <a:extLst>
               <a:ext uri="{FF2B5EF4-FFF2-40B4-BE49-F238E27FC236}">
-                <a16:creationId xmlns:a16="http://schemas.microsoft.com/office/drawing/2014/main" id="{D9C7A0C1-E0E7-3265-B5FD-47FB33D5DEF7}"/>
+                <a16:creationId xmlns:a16="http://schemas.microsoft.com/office/drawing/2014/main" id="{0F27A942-AAC4-CCF3-5656-4BBF1D9A4184}"/>
               </a:ext>
             </a:extLst>
           </p:cNvPr>
@@ -5077,7 +5072,7 @@
           <p:cNvPr id="4" name="Straight Connector 3">
             <a:extLst>
               <a:ext uri="{FF2B5EF4-FFF2-40B4-BE49-F238E27FC236}">
-                <a16:creationId xmlns:a16="http://schemas.microsoft.com/office/drawing/2014/main" id="{CCB5025C-EF03-F5A1-851D-132A05B362CC}"/>
+                <a16:creationId xmlns:a16="http://schemas.microsoft.com/office/drawing/2014/main" id="{7B7A1482-36F9-9AE7-C710-DB81FF27D5B0}"/>
               </a:ext>
             </a:extLst>
           </p:cNvPr>
@@ -5118,7 +5113,7 @@
           <p:cNvPr id="5" name="Rectangle: Rounded Corners 4">
             <a:extLst>
               <a:ext uri="{FF2B5EF4-FFF2-40B4-BE49-F238E27FC236}">
-                <a16:creationId xmlns:a16="http://schemas.microsoft.com/office/drawing/2014/main" id="{96104D5F-4E94-976D-6834-419D4133E0C9}"/>
+                <a16:creationId xmlns:a16="http://schemas.microsoft.com/office/drawing/2014/main" id="{D300B519-D7F0-B501-3FF6-DD7C63AE2252}"/>
               </a:ext>
             </a:extLst>
           </p:cNvPr>
@@ -5172,7 +5167,7 @@
           <p:cNvPr id="6" name="TextBox 5">
             <a:extLst>
               <a:ext uri="{FF2B5EF4-FFF2-40B4-BE49-F238E27FC236}">
-                <a16:creationId xmlns:a16="http://schemas.microsoft.com/office/drawing/2014/main" id="{08F1F443-1186-015B-90CF-490860F0635B}"/>
+                <a16:creationId xmlns:a16="http://schemas.microsoft.com/office/drawing/2014/main" id="{C5C2F52B-680E-0596-BE1C-9EE970372986}"/>
               </a:ext>
             </a:extLst>
           </p:cNvPr>
@@ -5212,7 +5207,7 @@
           <p:cNvPr id="7" name="TextBox 6">
             <a:extLst>
               <a:ext uri="{FF2B5EF4-FFF2-40B4-BE49-F238E27FC236}">
-                <a16:creationId xmlns:a16="http://schemas.microsoft.com/office/drawing/2014/main" id="{93EDF299-AFD5-1C30-E0F0-C48FCEFFB1FB}"/>
+                <a16:creationId xmlns:a16="http://schemas.microsoft.com/office/drawing/2014/main" id="{9B88E852-765C-75F1-FF61-E8619189C59B}"/>
               </a:ext>
             </a:extLst>
           </p:cNvPr>
@@ -5252,7 +5247,7 @@
           <p:cNvPr id="8" name="Rectangle: Rounded Corners 7">
             <a:extLst>
               <a:ext uri="{FF2B5EF4-FFF2-40B4-BE49-F238E27FC236}">
-                <a16:creationId xmlns:a16="http://schemas.microsoft.com/office/drawing/2014/main" id="{AA0B35FE-D39C-F322-8B4C-32F9F3FC885D}"/>
+                <a16:creationId xmlns:a16="http://schemas.microsoft.com/office/drawing/2014/main" id="{47F4EC24-4823-27F9-A093-05B9CC095272}"/>
               </a:ext>
             </a:extLst>
           </p:cNvPr>
@@ -5306,7 +5301,7 @@
           <p:cNvPr id="9" name="TextBox 8">
             <a:extLst>
               <a:ext uri="{FF2B5EF4-FFF2-40B4-BE49-F238E27FC236}">
-                <a16:creationId xmlns:a16="http://schemas.microsoft.com/office/drawing/2014/main" id="{FC0A137C-9B64-EAB0-501F-5BB09185EAF0}"/>
+                <a16:creationId xmlns:a16="http://schemas.microsoft.com/office/drawing/2014/main" id="{0CE2D6BA-8672-B321-630B-82E8A3C8A3BB}"/>
               </a:ext>
             </a:extLst>
           </p:cNvPr>
@@ -5346,7 +5341,7 @@
           <p:cNvPr id="10" name="TextBox 9">
             <a:extLst>
               <a:ext uri="{FF2B5EF4-FFF2-40B4-BE49-F238E27FC236}">
-                <a16:creationId xmlns:a16="http://schemas.microsoft.com/office/drawing/2014/main" id="{F4450D93-056B-B6AA-D41C-384797C814CA}"/>
+                <a16:creationId xmlns:a16="http://schemas.microsoft.com/office/drawing/2014/main" id="{6D47727B-2F1C-3ACE-56F1-1F83CD1D3CE2}"/>
               </a:ext>
             </a:extLst>
           </p:cNvPr>
@@ -5386,7 +5381,7 @@
           <p:cNvPr id="11" name="Rectangle: Rounded Corners 10">
             <a:extLst>
               <a:ext uri="{FF2B5EF4-FFF2-40B4-BE49-F238E27FC236}">
-                <a16:creationId xmlns:a16="http://schemas.microsoft.com/office/drawing/2014/main" id="{2EB0ACED-0C4E-A9FA-BF86-430960C26C69}"/>
+                <a16:creationId xmlns:a16="http://schemas.microsoft.com/office/drawing/2014/main" id="{B4E55D49-FC7B-56D6-02FD-B8BED3D24054}"/>
               </a:ext>
             </a:extLst>
           </p:cNvPr>
@@ -5440,7 +5435,7 @@
           <p:cNvPr id="12" name="TextBox 11">
             <a:extLst>
               <a:ext uri="{FF2B5EF4-FFF2-40B4-BE49-F238E27FC236}">
-                <a16:creationId xmlns:a16="http://schemas.microsoft.com/office/drawing/2014/main" id="{2B069DA9-6966-9EB5-7898-5B4719105402}"/>
+                <a16:creationId xmlns:a16="http://schemas.microsoft.com/office/drawing/2014/main" id="{107BE32A-23CF-D3A9-C870-D10D84C640E9}"/>
               </a:ext>
             </a:extLst>
           </p:cNvPr>
@@ -5480,7 +5475,7 @@
           <p:cNvPr id="13" name="TextBox 12">
             <a:extLst>
               <a:ext uri="{FF2B5EF4-FFF2-40B4-BE49-F238E27FC236}">
-                <a16:creationId xmlns:a16="http://schemas.microsoft.com/office/drawing/2014/main" id="{D7520C8E-51EB-0028-2345-91B930FF9901}"/>
+                <a16:creationId xmlns:a16="http://schemas.microsoft.com/office/drawing/2014/main" id="{C3CBDC15-1FD3-C9DC-5410-978E148CB239}"/>
               </a:ext>
             </a:extLst>
           </p:cNvPr>
@@ -5522,7 +5517,7 @@
           <p:cNvPr id="14" name="Rectangle: Rounded Corners 13">
             <a:extLst>
               <a:ext uri="{FF2B5EF4-FFF2-40B4-BE49-F238E27FC236}">
-                <a16:creationId xmlns:a16="http://schemas.microsoft.com/office/drawing/2014/main" id="{BDBB64F3-7798-4F4D-3309-365B45556F6B}"/>
+                <a16:creationId xmlns:a16="http://schemas.microsoft.com/office/drawing/2014/main" id="{A67114B7-93C8-8710-D5C0-C6ACD3AAC613}"/>
               </a:ext>
             </a:extLst>
           </p:cNvPr>
@@ -5576,7 +5571,7 @@
           <p:cNvPr id="15" name="TextBox 14">
             <a:extLst>
               <a:ext uri="{FF2B5EF4-FFF2-40B4-BE49-F238E27FC236}">
-                <a16:creationId xmlns:a16="http://schemas.microsoft.com/office/drawing/2014/main" id="{CC5DD296-0E47-4B51-578D-4F1FD41E6403}"/>
+                <a16:creationId xmlns:a16="http://schemas.microsoft.com/office/drawing/2014/main" id="{BA2899E5-78AE-48CD-7528-E632DE1E911C}"/>
               </a:ext>
             </a:extLst>
           </p:cNvPr>
@@ -5616,7 +5611,7 @@
           <p:cNvPr id="16" name="TextBox 15">
             <a:extLst>
               <a:ext uri="{FF2B5EF4-FFF2-40B4-BE49-F238E27FC236}">
-                <a16:creationId xmlns:a16="http://schemas.microsoft.com/office/drawing/2014/main" id="{0515718F-5713-9CEF-0487-889C29BE0B80}"/>
+                <a16:creationId xmlns:a16="http://schemas.microsoft.com/office/drawing/2014/main" id="{EFC5521A-BE9F-7561-1F24-B712C86EF2A0}"/>
               </a:ext>
             </a:extLst>
           </p:cNvPr>
@@ -5658,7 +5653,7 @@
           <p:cNvPr id="17" name="Rectangle: Rounded Corners 16">
             <a:extLst>
               <a:ext uri="{FF2B5EF4-FFF2-40B4-BE49-F238E27FC236}">
-                <a16:creationId xmlns:a16="http://schemas.microsoft.com/office/drawing/2014/main" id="{00BAB34D-A6FF-02F6-9D01-98121E3FB40B}"/>
+                <a16:creationId xmlns:a16="http://schemas.microsoft.com/office/drawing/2014/main" id="{595CB593-A0C5-2A50-A323-5C83D3AA3161}"/>
               </a:ext>
             </a:extLst>
           </p:cNvPr>
@@ -5712,7 +5707,7 @@
           <p:cNvPr id="18" name="TextBox 17">
             <a:extLst>
               <a:ext uri="{FF2B5EF4-FFF2-40B4-BE49-F238E27FC236}">
-                <a16:creationId xmlns:a16="http://schemas.microsoft.com/office/drawing/2014/main" id="{7432D9FB-9A97-E8A9-6880-CE92C2B59673}"/>
+                <a16:creationId xmlns:a16="http://schemas.microsoft.com/office/drawing/2014/main" id="{E8A4CF71-A4DC-F028-3924-FAE8FDB9EEA9}"/>
               </a:ext>
             </a:extLst>
           </p:cNvPr>
@@ -5752,7 +5747,7 @@
           <p:cNvPr id="19" name="TextBox 18">
             <a:extLst>
               <a:ext uri="{FF2B5EF4-FFF2-40B4-BE49-F238E27FC236}">
-                <a16:creationId xmlns:a16="http://schemas.microsoft.com/office/drawing/2014/main" id="{E860382A-2683-2A4F-15CB-2D6C83537C58}"/>
+                <a16:creationId xmlns:a16="http://schemas.microsoft.com/office/drawing/2014/main" id="{F617A2BD-3E32-3C63-4BB2-5FEDBE1E7FD5}"/>
               </a:ext>
             </a:extLst>
           </p:cNvPr>
@@ -5794,7 +5789,7 @@
           <p:cNvPr id="20" name="TextBox 19">
             <a:extLst>
               <a:ext uri="{FF2B5EF4-FFF2-40B4-BE49-F238E27FC236}">
-                <a16:creationId xmlns:a16="http://schemas.microsoft.com/office/drawing/2014/main" id="{C0185A55-7BCC-19E7-AA57-63727EE7016B}"/>
+                <a16:creationId xmlns:a16="http://schemas.microsoft.com/office/drawing/2014/main" id="{319A13BE-C8A7-A059-48F6-60B0CD2A291E}"/>
               </a:ext>
             </a:extLst>
           </p:cNvPr>
@@ -5835,7 +5830,7 @@
           <p:cNvPr id="21" name="TextBox 20">
             <a:extLst>
               <a:ext uri="{FF2B5EF4-FFF2-40B4-BE49-F238E27FC236}">
-                <a16:creationId xmlns:a16="http://schemas.microsoft.com/office/drawing/2014/main" id="{A7055DA0-9D96-2829-1ADB-BF83758A61AD}"/>
+                <a16:creationId xmlns:a16="http://schemas.microsoft.com/office/drawing/2014/main" id="{A574EC10-FF19-6C2F-B1D9-DFCEAB87A75B}"/>
               </a:ext>
             </a:extLst>
           </p:cNvPr>
@@ -5875,7 +5870,7 @@
           <p:cNvPr id="22" name="TextBox 21">
             <a:extLst>
               <a:ext uri="{FF2B5EF4-FFF2-40B4-BE49-F238E27FC236}">
-                <a16:creationId xmlns:a16="http://schemas.microsoft.com/office/drawing/2014/main" id="{D7D02A60-B82E-9A0F-D489-1548E957390A}"/>
+                <a16:creationId xmlns:a16="http://schemas.microsoft.com/office/drawing/2014/main" id="{3C432240-CAF7-66B9-818C-76CF28EB8477}"/>
               </a:ext>
             </a:extLst>
           </p:cNvPr>
@@ -5914,7 +5909,7 @@
     </p:spTree>
     <p:extLst>
       <p:ext uri="{BB962C8B-B14F-4D97-AF65-F5344CB8AC3E}">
-        <p14:creationId xmlns:p14="http://schemas.microsoft.com/office/powerpoint/2010/main" val="2207491473"/>
+        <p14:creationId xmlns:p14="http://schemas.microsoft.com/office/powerpoint/2010/main" val="3595746573"/>
       </p:ext>
     </p:extLst>
   </p:cSld>
@@ -5954,7 +5949,7 @@
           <p:cNvPr id="3" name="Picture 2">
             <a:extLst>
               <a:ext uri="{FF2B5EF4-FFF2-40B4-BE49-F238E27FC236}">
-                <a16:creationId xmlns:a16="http://schemas.microsoft.com/office/drawing/2014/main" id="{D582A544-3D51-3905-23ED-CB7DAEFEC259}"/>
+                <a16:creationId xmlns:a16="http://schemas.microsoft.com/office/drawing/2014/main" id="{20EA1430-4669-C9E3-1D48-D35BA70F59B7}"/>
               </a:ext>
             </a:extLst>
           </p:cNvPr>
@@ -5988,7 +5983,7 @@
     </p:spTree>
     <p:extLst>
       <p:ext uri="{BB962C8B-B14F-4D97-AF65-F5344CB8AC3E}">
-        <p14:creationId xmlns:p14="http://schemas.microsoft.com/office/powerpoint/2010/main" val="3736217232"/>
+        <p14:creationId xmlns:p14="http://schemas.microsoft.com/office/powerpoint/2010/main" val="155087575"/>
       </p:ext>
     </p:extLst>
   </p:cSld>
@@ -6028,7 +6023,7 @@
           <p:cNvPr id="2" name="TextBox 1">
             <a:extLst>
               <a:ext uri="{FF2B5EF4-FFF2-40B4-BE49-F238E27FC236}">
-                <a16:creationId xmlns:a16="http://schemas.microsoft.com/office/drawing/2014/main" id="{4410A7A7-FA88-9A9B-B517-CD72BF809D02}"/>
+                <a16:creationId xmlns:a16="http://schemas.microsoft.com/office/drawing/2014/main" id="{061BF05F-5430-1E35-86E4-42727D76DBD2}"/>
               </a:ext>
             </a:extLst>
           </p:cNvPr>
@@ -6068,7 +6063,7 @@
           <p:cNvPr id="3" name="TextBox 2">
             <a:extLst>
               <a:ext uri="{FF2B5EF4-FFF2-40B4-BE49-F238E27FC236}">
-                <a16:creationId xmlns:a16="http://schemas.microsoft.com/office/drawing/2014/main" id="{065B0C2D-5EF2-22A7-411C-4585007CCB0D}"/>
+                <a16:creationId xmlns:a16="http://schemas.microsoft.com/office/drawing/2014/main" id="{F653D0C5-A9F2-1D86-D0A4-F23362277EED}"/>
               </a:ext>
             </a:extLst>
           </p:cNvPr>
@@ -6108,7 +6103,7 @@
           <p:cNvPr id="4" name="Straight Connector 3">
             <a:extLst>
               <a:ext uri="{FF2B5EF4-FFF2-40B4-BE49-F238E27FC236}">
-                <a16:creationId xmlns:a16="http://schemas.microsoft.com/office/drawing/2014/main" id="{EB96A0E3-512F-5E79-83D3-602884C9FE69}"/>
+                <a16:creationId xmlns:a16="http://schemas.microsoft.com/office/drawing/2014/main" id="{3D97626F-4823-E0DF-A021-00B284D0D945}"/>
               </a:ext>
             </a:extLst>
           </p:cNvPr>
@@ -6149,7 +6144,7 @@
           <p:cNvPr id="5" name="Rectangle: Rounded Corners 4">
             <a:extLst>
               <a:ext uri="{FF2B5EF4-FFF2-40B4-BE49-F238E27FC236}">
-                <a16:creationId xmlns:a16="http://schemas.microsoft.com/office/drawing/2014/main" id="{ABAD43A4-E314-7112-BD7B-809716C508C9}"/>
+                <a16:creationId xmlns:a16="http://schemas.microsoft.com/office/drawing/2014/main" id="{924FD4CC-76C5-4422-7E5B-F61372648F54}"/>
               </a:ext>
             </a:extLst>
           </p:cNvPr>
@@ -6203,7 +6198,7 @@
           <p:cNvPr id="6" name="TextBox 5">
             <a:extLst>
               <a:ext uri="{FF2B5EF4-FFF2-40B4-BE49-F238E27FC236}">
-                <a16:creationId xmlns:a16="http://schemas.microsoft.com/office/drawing/2014/main" id="{504ACCF2-7AAC-9DFE-AFE7-A4247A983FC4}"/>
+                <a16:creationId xmlns:a16="http://schemas.microsoft.com/office/drawing/2014/main" id="{15F31216-EFDF-AA49-A739-3C56F2C5A2BC}"/>
               </a:ext>
             </a:extLst>
           </p:cNvPr>
@@ -6244,7 +6239,7 @@
           <p:cNvPr id="7" name="TextBox 6">
             <a:extLst>
               <a:ext uri="{FF2B5EF4-FFF2-40B4-BE49-F238E27FC236}">
-                <a16:creationId xmlns:a16="http://schemas.microsoft.com/office/drawing/2014/main" id="{97BAAACD-2A3A-6F03-883F-0C671274C540}"/>
+                <a16:creationId xmlns:a16="http://schemas.microsoft.com/office/drawing/2014/main" id="{54853AAC-38D0-A341-203A-00FC8A4C1D2C}"/>
               </a:ext>
             </a:extLst>
           </p:cNvPr>
@@ -6285,7 +6280,7 @@
           <p:cNvPr id="8" name="Rectangle: Rounded Corners 7">
             <a:extLst>
               <a:ext uri="{FF2B5EF4-FFF2-40B4-BE49-F238E27FC236}">
-                <a16:creationId xmlns:a16="http://schemas.microsoft.com/office/drawing/2014/main" id="{3820D8AC-AD9A-D8A5-5012-6D6CE585AF5B}"/>
+                <a16:creationId xmlns:a16="http://schemas.microsoft.com/office/drawing/2014/main" id="{FCB53FAC-2CC9-1248-D171-3277EBBA195A}"/>
               </a:ext>
             </a:extLst>
           </p:cNvPr>
@@ -6339,7 +6334,7 @@
           <p:cNvPr id="9" name="TextBox 8">
             <a:extLst>
               <a:ext uri="{FF2B5EF4-FFF2-40B4-BE49-F238E27FC236}">
-                <a16:creationId xmlns:a16="http://schemas.microsoft.com/office/drawing/2014/main" id="{437FFD27-4733-0A44-B577-EBF5322C0594}"/>
+                <a16:creationId xmlns:a16="http://schemas.microsoft.com/office/drawing/2014/main" id="{5AC16371-560C-D25A-94E9-2C44A740C7D1}"/>
               </a:ext>
             </a:extLst>
           </p:cNvPr>
@@ -6380,7 +6375,7 @@
           <p:cNvPr id="10" name="TextBox 9">
             <a:extLst>
               <a:ext uri="{FF2B5EF4-FFF2-40B4-BE49-F238E27FC236}">
-                <a16:creationId xmlns:a16="http://schemas.microsoft.com/office/drawing/2014/main" id="{BC271662-7BD2-E18E-237E-FB9410F24823}"/>
+                <a16:creationId xmlns:a16="http://schemas.microsoft.com/office/drawing/2014/main" id="{62E986DD-38BA-B47F-DE70-4C2F668A3E99}"/>
               </a:ext>
             </a:extLst>
           </p:cNvPr>
@@ -6421,7 +6416,7 @@
           <p:cNvPr id="11" name="Rectangle: Rounded Corners 10">
             <a:extLst>
               <a:ext uri="{FF2B5EF4-FFF2-40B4-BE49-F238E27FC236}">
-                <a16:creationId xmlns:a16="http://schemas.microsoft.com/office/drawing/2014/main" id="{B105A82A-FE33-3EF3-50FC-71AA0D5BA567}"/>
+                <a16:creationId xmlns:a16="http://schemas.microsoft.com/office/drawing/2014/main" id="{E32497AF-898F-25C1-83BE-3C15D76073DE}"/>
               </a:ext>
             </a:extLst>
           </p:cNvPr>
@@ -6475,7 +6470,7 @@
           <p:cNvPr id="12" name="TextBox 11">
             <a:extLst>
               <a:ext uri="{FF2B5EF4-FFF2-40B4-BE49-F238E27FC236}">
-                <a16:creationId xmlns:a16="http://schemas.microsoft.com/office/drawing/2014/main" id="{C0DF0582-4402-C92C-11CC-36A9128E47DF}"/>
+                <a16:creationId xmlns:a16="http://schemas.microsoft.com/office/drawing/2014/main" id="{00FFE8B5-307F-2CD8-8246-D6BA8E83BCA0}"/>
               </a:ext>
             </a:extLst>
           </p:cNvPr>
@@ -6516,7 +6511,7 @@
           <p:cNvPr id="13" name="TextBox 12">
             <a:extLst>
               <a:ext uri="{FF2B5EF4-FFF2-40B4-BE49-F238E27FC236}">
-                <a16:creationId xmlns:a16="http://schemas.microsoft.com/office/drawing/2014/main" id="{DC96CF4C-96B8-9F65-4D01-2DE11361F7F5}"/>
+                <a16:creationId xmlns:a16="http://schemas.microsoft.com/office/drawing/2014/main" id="{EF6DEF66-476E-A04C-29B1-1EA91E3AB6B9}"/>
               </a:ext>
             </a:extLst>
           </p:cNvPr>
@@ -6557,7 +6552,7 @@
           <p:cNvPr id="14" name="Rectangle: Rounded Corners 13">
             <a:extLst>
               <a:ext uri="{FF2B5EF4-FFF2-40B4-BE49-F238E27FC236}">
-                <a16:creationId xmlns:a16="http://schemas.microsoft.com/office/drawing/2014/main" id="{77FE5C33-96AE-CBDD-A560-16A60AE76E01}"/>
+                <a16:creationId xmlns:a16="http://schemas.microsoft.com/office/drawing/2014/main" id="{4752A895-ACB8-1FE8-18C4-ACAB0EE988D8}"/>
               </a:ext>
             </a:extLst>
           </p:cNvPr>
@@ -6611,7 +6606,7 @@
           <p:cNvPr id="15" name="TextBox 14">
             <a:extLst>
               <a:ext uri="{FF2B5EF4-FFF2-40B4-BE49-F238E27FC236}">
-                <a16:creationId xmlns:a16="http://schemas.microsoft.com/office/drawing/2014/main" id="{DA438E9C-40FA-6CE0-461C-37C8CC817214}"/>
+                <a16:creationId xmlns:a16="http://schemas.microsoft.com/office/drawing/2014/main" id="{B6778C66-C763-F891-C006-F1558CC10CBF}"/>
               </a:ext>
             </a:extLst>
           </p:cNvPr>
@@ -6652,7 +6647,7 @@
           <p:cNvPr id="16" name="TextBox 15">
             <a:extLst>
               <a:ext uri="{FF2B5EF4-FFF2-40B4-BE49-F238E27FC236}">
-                <a16:creationId xmlns:a16="http://schemas.microsoft.com/office/drawing/2014/main" id="{F5BDA43B-EEF6-4865-9A3B-A9D078DB273D}"/>
+                <a16:creationId xmlns:a16="http://schemas.microsoft.com/office/drawing/2014/main" id="{38E61F7A-8302-5B4D-B9FC-43C391EB722B}"/>
               </a:ext>
             </a:extLst>
           </p:cNvPr>
@@ -6693,7 +6688,7 @@
           <p:cNvPr id="17" name="Rectangle 16">
             <a:extLst>
               <a:ext uri="{FF2B5EF4-FFF2-40B4-BE49-F238E27FC236}">
-                <a16:creationId xmlns:a16="http://schemas.microsoft.com/office/drawing/2014/main" id="{685DC77B-FB95-DF0A-C229-F327DDAE7AE1}"/>
+                <a16:creationId xmlns:a16="http://schemas.microsoft.com/office/drawing/2014/main" id="{383429C3-9ACF-AA27-FA9B-C9CEE25DF899}"/>
               </a:ext>
             </a:extLst>
           </p:cNvPr>
@@ -6747,7 +6742,7 @@
           <p:cNvPr id="18" name="TextBox 17">
             <a:extLst>
               <a:ext uri="{FF2B5EF4-FFF2-40B4-BE49-F238E27FC236}">
-                <a16:creationId xmlns:a16="http://schemas.microsoft.com/office/drawing/2014/main" id="{BC2AEC61-9D67-1957-B07A-BB89A87977F1}"/>
+                <a16:creationId xmlns:a16="http://schemas.microsoft.com/office/drawing/2014/main" id="{899953CA-3B8E-423C-BEDC-5FB7B0CC0FEE}"/>
               </a:ext>
             </a:extLst>
           </p:cNvPr>
@@ -6787,7 +6782,7 @@
           <p:cNvPr id="19" name="Rectangle 18">
             <a:extLst>
               <a:ext uri="{FF2B5EF4-FFF2-40B4-BE49-F238E27FC236}">
-                <a16:creationId xmlns:a16="http://schemas.microsoft.com/office/drawing/2014/main" id="{946E6DB1-F7C6-0AE7-9A8F-7104165BA562}"/>
+                <a16:creationId xmlns:a16="http://schemas.microsoft.com/office/drawing/2014/main" id="{92BD1EEA-1CEF-E3B8-1A49-7886295AF13D}"/>
               </a:ext>
             </a:extLst>
           </p:cNvPr>
@@ -6841,7 +6836,7 @@
           <p:cNvPr id="20" name="TextBox 19">
             <a:extLst>
               <a:ext uri="{FF2B5EF4-FFF2-40B4-BE49-F238E27FC236}">
-                <a16:creationId xmlns:a16="http://schemas.microsoft.com/office/drawing/2014/main" id="{C2F10BA6-06DD-F11F-F2E9-AC25AE82B0F9}"/>
+                <a16:creationId xmlns:a16="http://schemas.microsoft.com/office/drawing/2014/main" id="{B83241C2-4BFF-F7B9-4CF2-E05CAC48D851}"/>
               </a:ext>
             </a:extLst>
           </p:cNvPr>
@@ -6881,7 +6876,7 @@
           <p:cNvPr id="21" name="Rectangle 20">
             <a:extLst>
               <a:ext uri="{FF2B5EF4-FFF2-40B4-BE49-F238E27FC236}">
-                <a16:creationId xmlns:a16="http://schemas.microsoft.com/office/drawing/2014/main" id="{82F8265E-580E-FED0-5F63-94D635814F3A}"/>
+                <a16:creationId xmlns:a16="http://schemas.microsoft.com/office/drawing/2014/main" id="{A9C59054-B5F7-B8A2-7ED8-346D585CD5DA}"/>
               </a:ext>
             </a:extLst>
           </p:cNvPr>
@@ -6935,7 +6930,7 @@
           <p:cNvPr id="22" name="TextBox 21">
             <a:extLst>
               <a:ext uri="{FF2B5EF4-FFF2-40B4-BE49-F238E27FC236}">
-                <a16:creationId xmlns:a16="http://schemas.microsoft.com/office/drawing/2014/main" id="{B884051A-446C-B1FF-E007-D519D8E44F39}"/>
+                <a16:creationId xmlns:a16="http://schemas.microsoft.com/office/drawing/2014/main" id="{800A81DC-0740-D6EB-C449-4436C7722B87}"/>
               </a:ext>
             </a:extLst>
           </p:cNvPr>
@@ -6975,7 +6970,7 @@
           <p:cNvPr id="23" name="Rectangle 22">
             <a:extLst>
               <a:ext uri="{FF2B5EF4-FFF2-40B4-BE49-F238E27FC236}">
-                <a16:creationId xmlns:a16="http://schemas.microsoft.com/office/drawing/2014/main" id="{853794D0-CB91-EB19-BEA3-D76B42712EF9}"/>
+                <a16:creationId xmlns:a16="http://schemas.microsoft.com/office/drawing/2014/main" id="{256BAC63-73F0-08B9-08F8-2B4728CCA6C5}"/>
               </a:ext>
             </a:extLst>
           </p:cNvPr>
@@ -7029,7 +7024,7 @@
           <p:cNvPr id="24" name="TextBox 23">
             <a:extLst>
               <a:ext uri="{FF2B5EF4-FFF2-40B4-BE49-F238E27FC236}">
-                <a16:creationId xmlns:a16="http://schemas.microsoft.com/office/drawing/2014/main" id="{C58221AF-8E30-D193-9B39-C3F077D98B0C}"/>
+                <a16:creationId xmlns:a16="http://schemas.microsoft.com/office/drawing/2014/main" id="{A48C2C96-8087-EBF9-76F8-77192BE56DBD}"/>
               </a:ext>
             </a:extLst>
           </p:cNvPr>
@@ -7069,7 +7064,7 @@
           <p:cNvPr id="25" name="Rectangle 24">
             <a:extLst>
               <a:ext uri="{FF2B5EF4-FFF2-40B4-BE49-F238E27FC236}">
-                <a16:creationId xmlns:a16="http://schemas.microsoft.com/office/drawing/2014/main" id="{A904E485-5C30-5C53-4E26-BDB820778FAE}"/>
+                <a16:creationId xmlns:a16="http://schemas.microsoft.com/office/drawing/2014/main" id="{5B2D5FF9-8E61-BB35-53E6-7B9890833FB0}"/>
               </a:ext>
             </a:extLst>
           </p:cNvPr>
@@ -7123,7 +7118,7 @@
           <p:cNvPr id="26" name="TextBox 25">
             <a:extLst>
               <a:ext uri="{FF2B5EF4-FFF2-40B4-BE49-F238E27FC236}">
-                <a16:creationId xmlns:a16="http://schemas.microsoft.com/office/drawing/2014/main" id="{1ADBA3A4-4B30-A622-0F98-43C04AAD8B4A}"/>
+                <a16:creationId xmlns:a16="http://schemas.microsoft.com/office/drawing/2014/main" id="{F9A1737E-3FDF-26F4-0048-4ED88C10084F}"/>
               </a:ext>
             </a:extLst>
           </p:cNvPr>
@@ -7163,7 +7158,7 @@
           <p:cNvPr id="27" name="Rectangle 26">
             <a:extLst>
               <a:ext uri="{FF2B5EF4-FFF2-40B4-BE49-F238E27FC236}">
-                <a16:creationId xmlns:a16="http://schemas.microsoft.com/office/drawing/2014/main" id="{A2CD52A9-A1AD-CA81-52EE-B557AC743B91}"/>
+                <a16:creationId xmlns:a16="http://schemas.microsoft.com/office/drawing/2014/main" id="{437F599E-D128-3C0D-E847-FF4E2B8C9C34}"/>
               </a:ext>
             </a:extLst>
           </p:cNvPr>
@@ -7217,7 +7212,7 @@
           <p:cNvPr id="28" name="TextBox 27">
             <a:extLst>
               <a:ext uri="{FF2B5EF4-FFF2-40B4-BE49-F238E27FC236}">
-                <a16:creationId xmlns:a16="http://schemas.microsoft.com/office/drawing/2014/main" id="{DAB6ACE0-2E6A-BFF5-934C-C1781B9F69D0}"/>
+                <a16:creationId xmlns:a16="http://schemas.microsoft.com/office/drawing/2014/main" id="{4087B5BD-7928-F3E1-8005-6C5F27235ABC}"/>
               </a:ext>
             </a:extLst>
           </p:cNvPr>
@@ -7257,7 +7252,7 @@
           <p:cNvPr id="29" name="Rectangle 28">
             <a:extLst>
               <a:ext uri="{FF2B5EF4-FFF2-40B4-BE49-F238E27FC236}">
-                <a16:creationId xmlns:a16="http://schemas.microsoft.com/office/drawing/2014/main" id="{8AE5D1EE-05B3-A131-0AD4-ADC462EF4DCD}"/>
+                <a16:creationId xmlns:a16="http://schemas.microsoft.com/office/drawing/2014/main" id="{9AF9AF25-6159-7B81-4783-09BBC618EE3E}"/>
               </a:ext>
             </a:extLst>
           </p:cNvPr>
@@ -7311,7 +7306,7 @@
           <p:cNvPr id="30" name="TextBox 29">
             <a:extLst>
               <a:ext uri="{FF2B5EF4-FFF2-40B4-BE49-F238E27FC236}">
-                <a16:creationId xmlns:a16="http://schemas.microsoft.com/office/drawing/2014/main" id="{FC9C97F0-C046-987D-043B-F5A376772756}"/>
+                <a16:creationId xmlns:a16="http://schemas.microsoft.com/office/drawing/2014/main" id="{28DAA3E9-2B2E-4251-8CA4-84A58AF86613}"/>
               </a:ext>
             </a:extLst>
           </p:cNvPr>
@@ -7351,7 +7346,7 @@
           <p:cNvPr id="31" name="Rectangle 30">
             <a:extLst>
               <a:ext uri="{FF2B5EF4-FFF2-40B4-BE49-F238E27FC236}">
-                <a16:creationId xmlns:a16="http://schemas.microsoft.com/office/drawing/2014/main" id="{119B92E5-D53F-4DBC-9464-FDF34824D10B}"/>
+                <a16:creationId xmlns:a16="http://schemas.microsoft.com/office/drawing/2014/main" id="{ED8F6265-C2E1-5AF5-B085-2A314BE1CC5F}"/>
               </a:ext>
             </a:extLst>
           </p:cNvPr>
@@ -7405,7 +7400,7 @@
           <p:cNvPr id="32" name="TextBox 31">
             <a:extLst>
               <a:ext uri="{FF2B5EF4-FFF2-40B4-BE49-F238E27FC236}">
-                <a16:creationId xmlns:a16="http://schemas.microsoft.com/office/drawing/2014/main" id="{5B205A33-B49B-223B-FEBF-973852F800C1}"/>
+                <a16:creationId xmlns:a16="http://schemas.microsoft.com/office/drawing/2014/main" id="{B83824CB-7545-A8B6-9F9E-6A97E315A6E4}"/>
               </a:ext>
             </a:extLst>
           </p:cNvPr>
@@ -7445,7 +7440,7 @@
           <p:cNvPr id="33" name="Rectangle 32">
             <a:extLst>
               <a:ext uri="{FF2B5EF4-FFF2-40B4-BE49-F238E27FC236}">
-                <a16:creationId xmlns:a16="http://schemas.microsoft.com/office/drawing/2014/main" id="{93EB7588-DB3A-8DBC-22D9-ADC182ADCE96}"/>
+                <a16:creationId xmlns:a16="http://schemas.microsoft.com/office/drawing/2014/main" id="{2F97BA34-C216-C456-39DB-81F51EA7A9C7}"/>
               </a:ext>
             </a:extLst>
           </p:cNvPr>
@@ -7499,7 +7494,7 @@
           <p:cNvPr id="34" name="TextBox 33">
             <a:extLst>
               <a:ext uri="{FF2B5EF4-FFF2-40B4-BE49-F238E27FC236}">
-                <a16:creationId xmlns:a16="http://schemas.microsoft.com/office/drawing/2014/main" id="{2A9F894E-F2CB-6290-062F-8F2334CEC072}"/>
+                <a16:creationId xmlns:a16="http://schemas.microsoft.com/office/drawing/2014/main" id="{7E7A88AD-4319-1E51-A0B9-97ACAA1C3A53}"/>
               </a:ext>
             </a:extLst>
           </p:cNvPr>
@@ -7539,7 +7534,7 @@
           <p:cNvPr id="35" name="Rectangle 34">
             <a:extLst>
               <a:ext uri="{FF2B5EF4-FFF2-40B4-BE49-F238E27FC236}">
-                <a16:creationId xmlns:a16="http://schemas.microsoft.com/office/drawing/2014/main" id="{D9265D79-DA9B-792F-C35C-0D3F0D6679AD}"/>
+                <a16:creationId xmlns:a16="http://schemas.microsoft.com/office/drawing/2014/main" id="{86668ADF-3FC4-F269-F5B7-62F044D28A53}"/>
               </a:ext>
             </a:extLst>
           </p:cNvPr>
@@ -7593,7 +7588,7 @@
           <p:cNvPr id="36" name="TextBox 35">
             <a:extLst>
               <a:ext uri="{FF2B5EF4-FFF2-40B4-BE49-F238E27FC236}">
-                <a16:creationId xmlns:a16="http://schemas.microsoft.com/office/drawing/2014/main" id="{2350A3A5-FFCF-1D45-1AF4-95806B8DCD23}"/>
+                <a16:creationId xmlns:a16="http://schemas.microsoft.com/office/drawing/2014/main" id="{787BFF37-3DF4-7FB8-44A0-9B4A08B2D05A}"/>
               </a:ext>
             </a:extLst>
           </p:cNvPr>
@@ -7633,7 +7628,7 @@
           <p:cNvPr id="37" name="Rectangle 36">
             <a:extLst>
               <a:ext uri="{FF2B5EF4-FFF2-40B4-BE49-F238E27FC236}">
-                <a16:creationId xmlns:a16="http://schemas.microsoft.com/office/drawing/2014/main" id="{04082214-AB39-1CCF-DF3C-3C0555000B2B}"/>
+                <a16:creationId xmlns:a16="http://schemas.microsoft.com/office/drawing/2014/main" id="{07B80B17-D74E-FD6F-A949-1A9B41642724}"/>
               </a:ext>
             </a:extLst>
           </p:cNvPr>
@@ -7687,7 +7682,7 @@
           <p:cNvPr id="38" name="TextBox 37">
             <a:extLst>
               <a:ext uri="{FF2B5EF4-FFF2-40B4-BE49-F238E27FC236}">
-                <a16:creationId xmlns:a16="http://schemas.microsoft.com/office/drawing/2014/main" id="{69222CA8-722E-784F-167F-6E8A13D09577}"/>
+                <a16:creationId xmlns:a16="http://schemas.microsoft.com/office/drawing/2014/main" id="{EAF44DC8-DEC8-B158-1B41-4E8B4CB7413E}"/>
               </a:ext>
             </a:extLst>
           </p:cNvPr>
@@ -7727,7 +7722,7 @@
           <p:cNvPr id="39" name="Rectangle 38">
             <a:extLst>
               <a:ext uri="{FF2B5EF4-FFF2-40B4-BE49-F238E27FC236}">
-                <a16:creationId xmlns:a16="http://schemas.microsoft.com/office/drawing/2014/main" id="{890FB80E-0DA8-F522-498F-8894394B86FE}"/>
+                <a16:creationId xmlns:a16="http://schemas.microsoft.com/office/drawing/2014/main" id="{C3C897A5-F8DC-1F58-DC44-B93BD2801E72}"/>
               </a:ext>
             </a:extLst>
           </p:cNvPr>
@@ -7781,7 +7776,7 @@
           <p:cNvPr id="40" name="TextBox 39">
             <a:extLst>
               <a:ext uri="{FF2B5EF4-FFF2-40B4-BE49-F238E27FC236}">
-                <a16:creationId xmlns:a16="http://schemas.microsoft.com/office/drawing/2014/main" id="{B4143F75-894E-6F20-7960-9F4174DC882F}"/>
+                <a16:creationId xmlns:a16="http://schemas.microsoft.com/office/drawing/2014/main" id="{AED29C25-C9C9-41AB-0EFC-4CB2ADA98920}"/>
               </a:ext>
             </a:extLst>
           </p:cNvPr>
@@ -7821,7 +7816,7 @@
           <p:cNvPr id="41" name="Rectangle 40">
             <a:extLst>
               <a:ext uri="{FF2B5EF4-FFF2-40B4-BE49-F238E27FC236}">
-                <a16:creationId xmlns:a16="http://schemas.microsoft.com/office/drawing/2014/main" id="{CAFE334A-292A-6744-3E62-BA3A2228E597}"/>
+                <a16:creationId xmlns:a16="http://schemas.microsoft.com/office/drawing/2014/main" id="{78A96108-269E-CB86-5A43-ECB13A53D23F}"/>
               </a:ext>
             </a:extLst>
           </p:cNvPr>
@@ -7875,7 +7870,7 @@
           <p:cNvPr id="42" name="TextBox 41">
             <a:extLst>
               <a:ext uri="{FF2B5EF4-FFF2-40B4-BE49-F238E27FC236}">
-                <a16:creationId xmlns:a16="http://schemas.microsoft.com/office/drawing/2014/main" id="{7E485E68-BBCB-FCA3-4E91-80C701731952}"/>
+                <a16:creationId xmlns:a16="http://schemas.microsoft.com/office/drawing/2014/main" id="{A22AEF11-C54F-B3AC-B5B7-4E5268DE7DA9}"/>
               </a:ext>
             </a:extLst>
           </p:cNvPr>
@@ -7915,7 +7910,7 @@
           <p:cNvPr id="43" name="Rectangle 42">
             <a:extLst>
               <a:ext uri="{FF2B5EF4-FFF2-40B4-BE49-F238E27FC236}">
-                <a16:creationId xmlns:a16="http://schemas.microsoft.com/office/drawing/2014/main" id="{31AA14D7-7D3C-0181-2875-AF4A4E1C315D}"/>
+                <a16:creationId xmlns:a16="http://schemas.microsoft.com/office/drawing/2014/main" id="{03E82E60-25F3-1F5A-2072-ED1675C1C2AD}"/>
               </a:ext>
             </a:extLst>
           </p:cNvPr>
@@ -7969,7 +7964,7 @@
           <p:cNvPr id="44" name="TextBox 43">
             <a:extLst>
               <a:ext uri="{FF2B5EF4-FFF2-40B4-BE49-F238E27FC236}">
-                <a16:creationId xmlns:a16="http://schemas.microsoft.com/office/drawing/2014/main" id="{071CD091-12D3-084B-DE8E-9B9BEFCAB75B}"/>
+                <a16:creationId xmlns:a16="http://schemas.microsoft.com/office/drawing/2014/main" id="{190EDC65-79C2-E6BE-F760-B72D0E636F42}"/>
               </a:ext>
             </a:extLst>
           </p:cNvPr>
@@ -8009,7 +8004,7 @@
           <p:cNvPr id="45" name="Rectangle 44">
             <a:extLst>
               <a:ext uri="{FF2B5EF4-FFF2-40B4-BE49-F238E27FC236}">
-                <a16:creationId xmlns:a16="http://schemas.microsoft.com/office/drawing/2014/main" id="{5EA0B7D4-9FAA-1178-4566-8265386EF627}"/>
+                <a16:creationId xmlns:a16="http://schemas.microsoft.com/office/drawing/2014/main" id="{05A8EEA7-2011-B8C3-0551-B3B1DF239C93}"/>
               </a:ext>
             </a:extLst>
           </p:cNvPr>
@@ -8063,7 +8058,7 @@
           <p:cNvPr id="46" name="TextBox 45">
             <a:extLst>
               <a:ext uri="{FF2B5EF4-FFF2-40B4-BE49-F238E27FC236}">
-                <a16:creationId xmlns:a16="http://schemas.microsoft.com/office/drawing/2014/main" id="{FB24194D-BFC3-486C-100C-58D157E2CBD0}"/>
+                <a16:creationId xmlns:a16="http://schemas.microsoft.com/office/drawing/2014/main" id="{07816D56-54DB-2C0E-0971-3090309659AD}"/>
               </a:ext>
             </a:extLst>
           </p:cNvPr>
@@ -8103,7 +8098,7 @@
           <p:cNvPr id="47" name="Rectangle 46">
             <a:extLst>
               <a:ext uri="{FF2B5EF4-FFF2-40B4-BE49-F238E27FC236}">
-                <a16:creationId xmlns:a16="http://schemas.microsoft.com/office/drawing/2014/main" id="{1F797527-411A-10AA-9C10-EE8BC0669C09}"/>
+                <a16:creationId xmlns:a16="http://schemas.microsoft.com/office/drawing/2014/main" id="{6C9F29DE-AC7D-1FD2-DAC0-3618E7AF760E}"/>
               </a:ext>
             </a:extLst>
           </p:cNvPr>
@@ -8157,7 +8152,7 @@
           <p:cNvPr id="48" name="TextBox 47">
             <a:extLst>
               <a:ext uri="{FF2B5EF4-FFF2-40B4-BE49-F238E27FC236}">
-                <a16:creationId xmlns:a16="http://schemas.microsoft.com/office/drawing/2014/main" id="{95C25B7E-B83F-ECC7-D179-20655A2537AE}"/>
+                <a16:creationId xmlns:a16="http://schemas.microsoft.com/office/drawing/2014/main" id="{A77DADD0-A6EF-3979-2F86-48ABDEBB3BBB}"/>
               </a:ext>
             </a:extLst>
           </p:cNvPr>
@@ -8197,7 +8192,7 @@
           <p:cNvPr id="49" name="Rectangle 48">
             <a:extLst>
               <a:ext uri="{FF2B5EF4-FFF2-40B4-BE49-F238E27FC236}">
-                <a16:creationId xmlns:a16="http://schemas.microsoft.com/office/drawing/2014/main" id="{3DE60C09-0E6C-738D-2AC5-787AD39B1135}"/>
+                <a16:creationId xmlns:a16="http://schemas.microsoft.com/office/drawing/2014/main" id="{E5358BDA-83C1-E470-038F-C27BEE779CE6}"/>
               </a:ext>
             </a:extLst>
           </p:cNvPr>
@@ -8251,7 +8246,7 @@
           <p:cNvPr id="50" name="TextBox 49">
             <a:extLst>
               <a:ext uri="{FF2B5EF4-FFF2-40B4-BE49-F238E27FC236}">
-                <a16:creationId xmlns:a16="http://schemas.microsoft.com/office/drawing/2014/main" id="{E74A37C8-0C9F-81BE-1E6C-0181B844C8AE}"/>
+                <a16:creationId xmlns:a16="http://schemas.microsoft.com/office/drawing/2014/main" id="{F54E6BC0-6E6B-55FB-DDD5-823457ED33F0}"/>
               </a:ext>
             </a:extLst>
           </p:cNvPr>
@@ -8291,7 +8286,7 @@
           <p:cNvPr id="51" name="Rectangle 50">
             <a:extLst>
               <a:ext uri="{FF2B5EF4-FFF2-40B4-BE49-F238E27FC236}">
-                <a16:creationId xmlns:a16="http://schemas.microsoft.com/office/drawing/2014/main" id="{B885B471-3620-A6D4-8D8B-32B592DC2526}"/>
+                <a16:creationId xmlns:a16="http://schemas.microsoft.com/office/drawing/2014/main" id="{6FBAB29C-FC3C-F28B-10EE-6F5AB44C9C82}"/>
               </a:ext>
             </a:extLst>
           </p:cNvPr>
@@ -8345,7 +8340,7 @@
           <p:cNvPr id="52" name="TextBox 51">
             <a:extLst>
               <a:ext uri="{FF2B5EF4-FFF2-40B4-BE49-F238E27FC236}">
-                <a16:creationId xmlns:a16="http://schemas.microsoft.com/office/drawing/2014/main" id="{619627B4-8D39-6B3E-72C0-AEC1FF2E637B}"/>
+                <a16:creationId xmlns:a16="http://schemas.microsoft.com/office/drawing/2014/main" id="{C29A76DE-D22F-D6C4-0C7E-6716E6D4E118}"/>
               </a:ext>
             </a:extLst>
           </p:cNvPr>
@@ -8385,7 +8380,7 @@
           <p:cNvPr id="53" name="Rectangle 52">
             <a:extLst>
               <a:ext uri="{FF2B5EF4-FFF2-40B4-BE49-F238E27FC236}">
-                <a16:creationId xmlns:a16="http://schemas.microsoft.com/office/drawing/2014/main" id="{88C5784C-E2F6-0EF9-87F4-108778AC4417}"/>
+                <a16:creationId xmlns:a16="http://schemas.microsoft.com/office/drawing/2014/main" id="{97D4F287-A379-C7E1-38E7-4790CD403799}"/>
               </a:ext>
             </a:extLst>
           </p:cNvPr>
@@ -8439,7 +8434,7 @@
           <p:cNvPr id="54" name="TextBox 53">
             <a:extLst>
               <a:ext uri="{FF2B5EF4-FFF2-40B4-BE49-F238E27FC236}">
-                <a16:creationId xmlns:a16="http://schemas.microsoft.com/office/drawing/2014/main" id="{F3F797BD-909F-9254-0600-B1C5C7888545}"/>
+                <a16:creationId xmlns:a16="http://schemas.microsoft.com/office/drawing/2014/main" id="{EE49D71A-2A50-EABD-CD14-C31F82F8BE62}"/>
               </a:ext>
             </a:extLst>
           </p:cNvPr>
@@ -8479,7 +8474,7 @@
           <p:cNvPr id="55" name="Rectangle 54">
             <a:extLst>
               <a:ext uri="{FF2B5EF4-FFF2-40B4-BE49-F238E27FC236}">
-                <a16:creationId xmlns:a16="http://schemas.microsoft.com/office/drawing/2014/main" id="{781067F9-41D6-67B9-9B98-EA769ECE6800}"/>
+                <a16:creationId xmlns:a16="http://schemas.microsoft.com/office/drawing/2014/main" id="{B8DA0A9C-D5CE-B884-6890-DA5573061CF0}"/>
               </a:ext>
             </a:extLst>
           </p:cNvPr>
@@ -8533,7 +8528,7 @@
           <p:cNvPr id="56" name="TextBox 55">
             <a:extLst>
               <a:ext uri="{FF2B5EF4-FFF2-40B4-BE49-F238E27FC236}">
-                <a16:creationId xmlns:a16="http://schemas.microsoft.com/office/drawing/2014/main" id="{8C40577B-EADA-31D9-2DC7-DA14F4DD27BC}"/>
+                <a16:creationId xmlns:a16="http://schemas.microsoft.com/office/drawing/2014/main" id="{F5424895-BAA7-BDED-33A9-2344C7E64EC8}"/>
               </a:ext>
             </a:extLst>
           </p:cNvPr>
@@ -8573,7 +8568,7 @@
           <p:cNvPr id="57" name="Rectangle 56">
             <a:extLst>
               <a:ext uri="{FF2B5EF4-FFF2-40B4-BE49-F238E27FC236}">
-                <a16:creationId xmlns:a16="http://schemas.microsoft.com/office/drawing/2014/main" id="{AA234454-1DBF-E641-DE0B-75BC5D7B710B}"/>
+                <a16:creationId xmlns:a16="http://schemas.microsoft.com/office/drawing/2014/main" id="{ACD29C85-DB95-086D-5B2D-728F5BA27328}"/>
               </a:ext>
             </a:extLst>
           </p:cNvPr>
@@ -8627,7 +8622,7 @@
           <p:cNvPr id="58" name="TextBox 57">
             <a:extLst>
               <a:ext uri="{FF2B5EF4-FFF2-40B4-BE49-F238E27FC236}">
-                <a16:creationId xmlns:a16="http://schemas.microsoft.com/office/drawing/2014/main" id="{73F09EE6-67DB-9423-A49D-AC34D5C04F21}"/>
+                <a16:creationId xmlns:a16="http://schemas.microsoft.com/office/drawing/2014/main" id="{539BD590-691B-6C41-D82C-B5475B1E3A45}"/>
               </a:ext>
             </a:extLst>
           </p:cNvPr>
@@ -8667,7 +8662,7 @@
           <p:cNvPr id="59" name="Rectangle 58">
             <a:extLst>
               <a:ext uri="{FF2B5EF4-FFF2-40B4-BE49-F238E27FC236}">
-                <a16:creationId xmlns:a16="http://schemas.microsoft.com/office/drawing/2014/main" id="{D4FA1879-676E-CFF0-D3AC-F48140ACC696}"/>
+                <a16:creationId xmlns:a16="http://schemas.microsoft.com/office/drawing/2014/main" id="{AE4DF60B-8665-AECC-D089-280D65D3BF47}"/>
               </a:ext>
             </a:extLst>
           </p:cNvPr>
@@ -8721,7 +8716,7 @@
           <p:cNvPr id="60" name="TextBox 59">
             <a:extLst>
               <a:ext uri="{FF2B5EF4-FFF2-40B4-BE49-F238E27FC236}">
-                <a16:creationId xmlns:a16="http://schemas.microsoft.com/office/drawing/2014/main" id="{A16A92AC-5C27-4853-A475-0F83B3CC2CFF}"/>
+                <a16:creationId xmlns:a16="http://schemas.microsoft.com/office/drawing/2014/main" id="{D6D2ACC4-14FB-A39F-F314-BE344A1C623E}"/>
               </a:ext>
             </a:extLst>
           </p:cNvPr>
@@ -8761,7 +8756,7 @@
           <p:cNvPr id="61" name="Rectangle 60">
             <a:extLst>
               <a:ext uri="{FF2B5EF4-FFF2-40B4-BE49-F238E27FC236}">
-                <a16:creationId xmlns:a16="http://schemas.microsoft.com/office/drawing/2014/main" id="{EC286302-9E07-973F-ADA6-43AABE6F8F83}"/>
+                <a16:creationId xmlns:a16="http://schemas.microsoft.com/office/drawing/2014/main" id="{6A196CB0-FBFA-593B-C232-61A2966621E8}"/>
               </a:ext>
             </a:extLst>
           </p:cNvPr>
@@ -8815,7 +8810,7 @@
           <p:cNvPr id="62" name="TextBox 61">
             <a:extLst>
               <a:ext uri="{FF2B5EF4-FFF2-40B4-BE49-F238E27FC236}">
-                <a16:creationId xmlns:a16="http://schemas.microsoft.com/office/drawing/2014/main" id="{16DB33AD-9705-ED0A-CDE7-1FECECA3276F}"/>
+                <a16:creationId xmlns:a16="http://schemas.microsoft.com/office/drawing/2014/main" id="{8D2EE614-1170-8507-4433-DABDFE976028}"/>
               </a:ext>
             </a:extLst>
           </p:cNvPr>
@@ -8855,7 +8850,7 @@
           <p:cNvPr id="63" name="Rectangle 62">
             <a:extLst>
               <a:ext uri="{FF2B5EF4-FFF2-40B4-BE49-F238E27FC236}">
-                <a16:creationId xmlns:a16="http://schemas.microsoft.com/office/drawing/2014/main" id="{557B73DE-813F-C44D-F04D-769FC3C04510}"/>
+                <a16:creationId xmlns:a16="http://schemas.microsoft.com/office/drawing/2014/main" id="{B37A7950-9768-AB46-9CFC-AFAE29AEDD9F}"/>
               </a:ext>
             </a:extLst>
           </p:cNvPr>
@@ -8909,7 +8904,7 @@
           <p:cNvPr id="64" name="TextBox 63">
             <a:extLst>
               <a:ext uri="{FF2B5EF4-FFF2-40B4-BE49-F238E27FC236}">
-                <a16:creationId xmlns:a16="http://schemas.microsoft.com/office/drawing/2014/main" id="{ED5960A7-F8BB-40D9-D908-2A9A0282B98C}"/>
+                <a16:creationId xmlns:a16="http://schemas.microsoft.com/office/drawing/2014/main" id="{EE1847AF-60E1-0098-7D10-6504C8B67F2F}"/>
               </a:ext>
             </a:extLst>
           </p:cNvPr>
@@ -8949,7 +8944,7 @@
           <p:cNvPr id="65" name="Rectangle 64">
             <a:extLst>
               <a:ext uri="{FF2B5EF4-FFF2-40B4-BE49-F238E27FC236}">
-                <a16:creationId xmlns:a16="http://schemas.microsoft.com/office/drawing/2014/main" id="{DE0127B1-72F1-D82E-D2C7-FAF1C7F88DD4}"/>
+                <a16:creationId xmlns:a16="http://schemas.microsoft.com/office/drawing/2014/main" id="{B589749A-BD08-7839-F263-9B13AC8D6A45}"/>
               </a:ext>
             </a:extLst>
           </p:cNvPr>
@@ -9003,7 +8998,7 @@
           <p:cNvPr id="66" name="TextBox 65">
             <a:extLst>
               <a:ext uri="{FF2B5EF4-FFF2-40B4-BE49-F238E27FC236}">
-                <a16:creationId xmlns:a16="http://schemas.microsoft.com/office/drawing/2014/main" id="{2319052D-B056-3F0B-A0B4-0E6F70A5194A}"/>
+                <a16:creationId xmlns:a16="http://schemas.microsoft.com/office/drawing/2014/main" id="{B274AE35-CEC3-A63B-2F53-48818C393F3E}"/>
               </a:ext>
             </a:extLst>
           </p:cNvPr>
@@ -9043,7 +9038,7 @@
           <p:cNvPr id="67" name="Rectangle 66">
             <a:extLst>
               <a:ext uri="{FF2B5EF4-FFF2-40B4-BE49-F238E27FC236}">
-                <a16:creationId xmlns:a16="http://schemas.microsoft.com/office/drawing/2014/main" id="{6D50AF87-07C2-D29C-24C8-AB4F63CBA17E}"/>
+                <a16:creationId xmlns:a16="http://schemas.microsoft.com/office/drawing/2014/main" id="{920A3F64-7E64-AA88-D3F1-E5BE74564080}"/>
               </a:ext>
             </a:extLst>
           </p:cNvPr>
@@ -9097,7 +9092,7 @@
           <p:cNvPr id="68" name="TextBox 67">
             <a:extLst>
               <a:ext uri="{FF2B5EF4-FFF2-40B4-BE49-F238E27FC236}">
-                <a16:creationId xmlns:a16="http://schemas.microsoft.com/office/drawing/2014/main" id="{CD54518F-7B50-5B05-1D91-E93BE5DA4D06}"/>
+                <a16:creationId xmlns:a16="http://schemas.microsoft.com/office/drawing/2014/main" id="{525741BC-81FB-9CCC-63C5-9A55AE4D91BC}"/>
               </a:ext>
             </a:extLst>
           </p:cNvPr>
@@ -9137,7 +9132,7 @@
           <p:cNvPr id="69" name="Rectangle 68">
             <a:extLst>
               <a:ext uri="{FF2B5EF4-FFF2-40B4-BE49-F238E27FC236}">
-                <a16:creationId xmlns:a16="http://schemas.microsoft.com/office/drawing/2014/main" id="{BC80008C-60BA-0867-3AE4-2A4455607510}"/>
+                <a16:creationId xmlns:a16="http://schemas.microsoft.com/office/drawing/2014/main" id="{DC3CA7A2-21C5-C7AE-2082-9DF8541986CC}"/>
               </a:ext>
             </a:extLst>
           </p:cNvPr>
@@ -9191,7 +9186,7 @@
           <p:cNvPr id="70" name="TextBox 69">
             <a:extLst>
               <a:ext uri="{FF2B5EF4-FFF2-40B4-BE49-F238E27FC236}">
-                <a16:creationId xmlns:a16="http://schemas.microsoft.com/office/drawing/2014/main" id="{7D83C746-BD60-5B28-63DD-78A83186C89E}"/>
+                <a16:creationId xmlns:a16="http://schemas.microsoft.com/office/drawing/2014/main" id="{60692BA2-1FEF-37B9-B888-79E6721A716C}"/>
               </a:ext>
             </a:extLst>
           </p:cNvPr>
@@ -9231,7 +9226,7 @@
           <p:cNvPr id="71" name="Rectangle 70">
             <a:extLst>
               <a:ext uri="{FF2B5EF4-FFF2-40B4-BE49-F238E27FC236}">
-                <a16:creationId xmlns:a16="http://schemas.microsoft.com/office/drawing/2014/main" id="{0DE87367-6FA6-ECFF-62E9-D936626210ED}"/>
+                <a16:creationId xmlns:a16="http://schemas.microsoft.com/office/drawing/2014/main" id="{1A274E5F-594B-1AB1-C4D7-DD1246ABE798}"/>
               </a:ext>
             </a:extLst>
           </p:cNvPr>
@@ -9285,7 +9280,7 @@
           <p:cNvPr id="72" name="TextBox 71">
             <a:extLst>
               <a:ext uri="{FF2B5EF4-FFF2-40B4-BE49-F238E27FC236}">
-                <a16:creationId xmlns:a16="http://schemas.microsoft.com/office/drawing/2014/main" id="{6D3B7843-0F3F-C1CE-A409-107DBA040060}"/>
+                <a16:creationId xmlns:a16="http://schemas.microsoft.com/office/drawing/2014/main" id="{82BBEB5B-DE92-0E0C-08A9-DC438236DC13}"/>
               </a:ext>
             </a:extLst>
           </p:cNvPr>
@@ -9325,7 +9320,7 @@
           <p:cNvPr id="73" name="Rectangle 72">
             <a:extLst>
               <a:ext uri="{FF2B5EF4-FFF2-40B4-BE49-F238E27FC236}">
-                <a16:creationId xmlns:a16="http://schemas.microsoft.com/office/drawing/2014/main" id="{18AD67F3-CE52-2AA7-70FB-F1DF0AD10074}"/>
+                <a16:creationId xmlns:a16="http://schemas.microsoft.com/office/drawing/2014/main" id="{E0512146-4B40-098F-4AEB-2C4AC5FBFC91}"/>
               </a:ext>
             </a:extLst>
           </p:cNvPr>
@@ -9379,7 +9374,7 @@
           <p:cNvPr id="74" name="TextBox 73">
             <a:extLst>
               <a:ext uri="{FF2B5EF4-FFF2-40B4-BE49-F238E27FC236}">
-                <a16:creationId xmlns:a16="http://schemas.microsoft.com/office/drawing/2014/main" id="{2C868159-C6BF-09E8-7003-1A473F1A238B}"/>
+                <a16:creationId xmlns:a16="http://schemas.microsoft.com/office/drawing/2014/main" id="{E2D7E504-3CC8-8596-46B6-EF07ED66F88D}"/>
               </a:ext>
             </a:extLst>
           </p:cNvPr>
@@ -9419,7 +9414,7 @@
           <p:cNvPr id="75" name="Rectangle 74">
             <a:extLst>
               <a:ext uri="{FF2B5EF4-FFF2-40B4-BE49-F238E27FC236}">
-                <a16:creationId xmlns:a16="http://schemas.microsoft.com/office/drawing/2014/main" id="{8FC081CC-8BA7-5A63-3483-F239B8E37DD3}"/>
+                <a16:creationId xmlns:a16="http://schemas.microsoft.com/office/drawing/2014/main" id="{46D83A7D-2BCE-5918-C49D-1C56F1C76681}"/>
               </a:ext>
             </a:extLst>
           </p:cNvPr>
@@ -9473,7 +9468,7 @@
           <p:cNvPr id="76" name="TextBox 75">
             <a:extLst>
               <a:ext uri="{FF2B5EF4-FFF2-40B4-BE49-F238E27FC236}">
-                <a16:creationId xmlns:a16="http://schemas.microsoft.com/office/drawing/2014/main" id="{6007E0F6-70AC-8FD6-68B9-1066FBABE992}"/>
+                <a16:creationId xmlns:a16="http://schemas.microsoft.com/office/drawing/2014/main" id="{40F32807-2C19-64CB-0CC9-AC4AF57FDCE0}"/>
               </a:ext>
             </a:extLst>
           </p:cNvPr>
@@ -9513,7 +9508,7 @@
           <p:cNvPr id="77" name="Rectangle: Rounded Corners 76">
             <a:extLst>
               <a:ext uri="{FF2B5EF4-FFF2-40B4-BE49-F238E27FC236}">
-                <a16:creationId xmlns:a16="http://schemas.microsoft.com/office/drawing/2014/main" id="{AA9B427E-9C4C-DC01-9777-FE1BE6849D9C}"/>
+                <a16:creationId xmlns:a16="http://schemas.microsoft.com/office/drawing/2014/main" id="{639A0346-9346-A989-C883-296E0C0D9401}"/>
               </a:ext>
             </a:extLst>
           </p:cNvPr>
@@ -9567,7 +9562,7 @@
           <p:cNvPr id="78" name="TextBox 77">
             <a:extLst>
               <a:ext uri="{FF2B5EF4-FFF2-40B4-BE49-F238E27FC236}">
-                <a16:creationId xmlns:a16="http://schemas.microsoft.com/office/drawing/2014/main" id="{06799781-3511-AE40-EC62-8752B430B89B}"/>
+                <a16:creationId xmlns:a16="http://schemas.microsoft.com/office/drawing/2014/main" id="{1C225A16-D3AA-2FA9-4423-A1987F31EBDB}"/>
               </a:ext>
             </a:extLst>
           </p:cNvPr>
@@ -9607,7 +9602,7 @@
           <p:cNvPr id="79" name="TextBox 78">
             <a:extLst>
               <a:ext uri="{FF2B5EF4-FFF2-40B4-BE49-F238E27FC236}">
-                <a16:creationId xmlns:a16="http://schemas.microsoft.com/office/drawing/2014/main" id="{34F4A990-8CD0-04F8-63E0-18B600F46D06}"/>
+                <a16:creationId xmlns:a16="http://schemas.microsoft.com/office/drawing/2014/main" id="{A78B93F4-AFBB-1791-DE1A-0C5808AE4C99}"/>
               </a:ext>
             </a:extLst>
           </p:cNvPr>
@@ -9647,7 +9642,7 @@
           <p:cNvPr id="80" name="TextBox 79">
             <a:extLst>
               <a:ext uri="{FF2B5EF4-FFF2-40B4-BE49-F238E27FC236}">
-                <a16:creationId xmlns:a16="http://schemas.microsoft.com/office/drawing/2014/main" id="{9BB6AC19-1EF8-ABB0-ADD9-F0688D6FC934}"/>
+                <a16:creationId xmlns:a16="http://schemas.microsoft.com/office/drawing/2014/main" id="{552E51F6-E355-FB71-A132-2F44E05DD08E}"/>
               </a:ext>
             </a:extLst>
           </p:cNvPr>
@@ -9686,7 +9681,7 @@
     </p:spTree>
     <p:extLst>
       <p:ext uri="{BB962C8B-B14F-4D97-AF65-F5344CB8AC3E}">
-        <p14:creationId xmlns:p14="http://schemas.microsoft.com/office/powerpoint/2010/main" val="4090275558"/>
+        <p14:creationId xmlns:p14="http://schemas.microsoft.com/office/powerpoint/2010/main" val="2775887913"/>
       </p:ext>
     </p:extLst>
   </p:cSld>
@@ -9726,7 +9721,7 @@
           <p:cNvPr id="2" name="TextBox 1">
             <a:extLst>
               <a:ext uri="{FF2B5EF4-FFF2-40B4-BE49-F238E27FC236}">
-                <a16:creationId xmlns:a16="http://schemas.microsoft.com/office/drawing/2014/main" id="{7DE45A8A-40A0-5388-F546-C1BA81F42D66}"/>
+                <a16:creationId xmlns:a16="http://schemas.microsoft.com/office/drawing/2014/main" id="{675ECA94-8A2F-4CA5-52B2-7772ED73634E}"/>
               </a:ext>
             </a:extLst>
           </p:cNvPr>
@@ -9766,7 +9761,7 @@
           <p:cNvPr id="3" name="TextBox 2">
             <a:extLst>
               <a:ext uri="{FF2B5EF4-FFF2-40B4-BE49-F238E27FC236}">
-                <a16:creationId xmlns:a16="http://schemas.microsoft.com/office/drawing/2014/main" id="{F1D7D3E9-9307-CAFE-FDCC-465BB2BA918D}"/>
+                <a16:creationId xmlns:a16="http://schemas.microsoft.com/office/drawing/2014/main" id="{27CC1846-096B-41C0-A7B1-4AFE6E591B9C}"/>
               </a:ext>
             </a:extLst>
           </p:cNvPr>
@@ -9806,7 +9801,7 @@
           <p:cNvPr id="4" name="Straight Connector 3">
             <a:extLst>
               <a:ext uri="{FF2B5EF4-FFF2-40B4-BE49-F238E27FC236}">
-                <a16:creationId xmlns:a16="http://schemas.microsoft.com/office/drawing/2014/main" id="{E2B10B84-F850-C353-A29C-532D71CD86D7}"/>
+                <a16:creationId xmlns:a16="http://schemas.microsoft.com/office/drawing/2014/main" id="{7D649162-3100-04D8-D187-A4CBF29F75D1}"/>
               </a:ext>
             </a:extLst>
           </p:cNvPr>
@@ -9847,7 +9842,7 @@
           <p:cNvPr id="5" name="Rectangle: Rounded Corners 4">
             <a:extLst>
               <a:ext uri="{FF2B5EF4-FFF2-40B4-BE49-F238E27FC236}">
-                <a16:creationId xmlns:a16="http://schemas.microsoft.com/office/drawing/2014/main" id="{476D0C36-4FB1-C293-A1FE-0472751770D8}"/>
+                <a16:creationId xmlns:a16="http://schemas.microsoft.com/office/drawing/2014/main" id="{70CB3E24-B796-84D7-1CBF-B54C66835BDA}"/>
               </a:ext>
             </a:extLst>
           </p:cNvPr>
@@ -9901,7 +9896,7 @@
           <p:cNvPr id="6" name="TextBox 5">
             <a:extLst>
               <a:ext uri="{FF2B5EF4-FFF2-40B4-BE49-F238E27FC236}">
-                <a16:creationId xmlns:a16="http://schemas.microsoft.com/office/drawing/2014/main" id="{4B61639F-F901-86C4-B0D1-CA692DB52796}"/>
+                <a16:creationId xmlns:a16="http://schemas.microsoft.com/office/drawing/2014/main" id="{F2A9FACF-0C83-C8BF-A56E-54A388A74433}"/>
               </a:ext>
             </a:extLst>
           </p:cNvPr>
@@ -9942,7 +9937,7 @@
           <p:cNvPr id="7" name="TextBox 6">
             <a:extLst>
               <a:ext uri="{FF2B5EF4-FFF2-40B4-BE49-F238E27FC236}">
-                <a16:creationId xmlns:a16="http://schemas.microsoft.com/office/drawing/2014/main" id="{59729ABB-E487-027C-4BCE-B5FFA5BA07D2}"/>
+                <a16:creationId xmlns:a16="http://schemas.microsoft.com/office/drawing/2014/main" id="{7B75D1D1-4CA0-93B4-96A9-694EE3BED51A}"/>
               </a:ext>
             </a:extLst>
           </p:cNvPr>
@@ -9983,7 +9978,7 @@
           <p:cNvPr id="8" name="Rectangle: Rounded Corners 7">
             <a:extLst>
               <a:ext uri="{FF2B5EF4-FFF2-40B4-BE49-F238E27FC236}">
-                <a16:creationId xmlns:a16="http://schemas.microsoft.com/office/drawing/2014/main" id="{48F61204-B0A7-8101-FA4D-C93D5BB439C9}"/>
+                <a16:creationId xmlns:a16="http://schemas.microsoft.com/office/drawing/2014/main" id="{2BAF6785-3C4B-A052-D23F-C865B5177806}"/>
               </a:ext>
             </a:extLst>
           </p:cNvPr>
@@ -10037,7 +10032,7 @@
           <p:cNvPr id="9" name="TextBox 8">
             <a:extLst>
               <a:ext uri="{FF2B5EF4-FFF2-40B4-BE49-F238E27FC236}">
-                <a16:creationId xmlns:a16="http://schemas.microsoft.com/office/drawing/2014/main" id="{C4F33673-28D9-6C17-6E37-0D13A25EF725}"/>
+                <a16:creationId xmlns:a16="http://schemas.microsoft.com/office/drawing/2014/main" id="{32C524D1-A869-7B60-4A69-A06520B6F85C}"/>
               </a:ext>
             </a:extLst>
           </p:cNvPr>
@@ -10078,7 +10073,7 @@
           <p:cNvPr id="10" name="TextBox 9">
             <a:extLst>
               <a:ext uri="{FF2B5EF4-FFF2-40B4-BE49-F238E27FC236}">
-                <a16:creationId xmlns:a16="http://schemas.microsoft.com/office/drawing/2014/main" id="{D0442101-3E52-35DA-BE31-6F935A4E051A}"/>
+                <a16:creationId xmlns:a16="http://schemas.microsoft.com/office/drawing/2014/main" id="{95813EFD-85A3-F99D-8107-220BC1484197}"/>
               </a:ext>
             </a:extLst>
           </p:cNvPr>
@@ -10119,7 +10114,7 @@
           <p:cNvPr id="11" name="Rectangle: Rounded Corners 10">
             <a:extLst>
               <a:ext uri="{FF2B5EF4-FFF2-40B4-BE49-F238E27FC236}">
-                <a16:creationId xmlns:a16="http://schemas.microsoft.com/office/drawing/2014/main" id="{0E406D89-FC88-5C33-C8EA-C7DFDC0C9BEE}"/>
+                <a16:creationId xmlns:a16="http://schemas.microsoft.com/office/drawing/2014/main" id="{F231EF0A-4618-AC34-B726-961C58F66881}"/>
               </a:ext>
             </a:extLst>
           </p:cNvPr>
@@ -10173,7 +10168,7 @@
           <p:cNvPr id="12" name="TextBox 11">
             <a:extLst>
               <a:ext uri="{FF2B5EF4-FFF2-40B4-BE49-F238E27FC236}">
-                <a16:creationId xmlns:a16="http://schemas.microsoft.com/office/drawing/2014/main" id="{7CE5DD90-089A-D921-3A6B-12BB91EF45EB}"/>
+                <a16:creationId xmlns:a16="http://schemas.microsoft.com/office/drawing/2014/main" id="{D6C06E81-3078-6848-06FD-DB08BB794368}"/>
               </a:ext>
             </a:extLst>
           </p:cNvPr>
@@ -10214,7 +10209,7 @@
           <p:cNvPr id="13" name="TextBox 12">
             <a:extLst>
               <a:ext uri="{FF2B5EF4-FFF2-40B4-BE49-F238E27FC236}">
-                <a16:creationId xmlns:a16="http://schemas.microsoft.com/office/drawing/2014/main" id="{0ACAA60C-DFB8-B3E5-CA86-2B75F4692077}"/>
+                <a16:creationId xmlns:a16="http://schemas.microsoft.com/office/drawing/2014/main" id="{0177FBFF-6D41-992A-CEA5-E6747B8851E6}"/>
               </a:ext>
             </a:extLst>
           </p:cNvPr>
@@ -10255,7 +10250,7 @@
           <p:cNvPr id="14" name="Rectangle: Rounded Corners 13">
             <a:extLst>
               <a:ext uri="{FF2B5EF4-FFF2-40B4-BE49-F238E27FC236}">
-                <a16:creationId xmlns:a16="http://schemas.microsoft.com/office/drawing/2014/main" id="{4D5C0795-AAAD-7B29-2546-509CE3D0677E}"/>
+                <a16:creationId xmlns:a16="http://schemas.microsoft.com/office/drawing/2014/main" id="{730E4437-6F5B-2BC4-F101-C48114BEA09B}"/>
               </a:ext>
             </a:extLst>
           </p:cNvPr>
@@ -10309,7 +10304,7 @@
           <p:cNvPr id="15" name="TextBox 14">
             <a:extLst>
               <a:ext uri="{FF2B5EF4-FFF2-40B4-BE49-F238E27FC236}">
-                <a16:creationId xmlns:a16="http://schemas.microsoft.com/office/drawing/2014/main" id="{489FF54D-B5ED-8061-0576-B890800EA0E7}"/>
+                <a16:creationId xmlns:a16="http://schemas.microsoft.com/office/drawing/2014/main" id="{649A6B8D-E4C5-26DA-E6DF-DA84B8112EDB}"/>
               </a:ext>
             </a:extLst>
           </p:cNvPr>
@@ -10350,7 +10345,7 @@
           <p:cNvPr id="16" name="TextBox 15">
             <a:extLst>
               <a:ext uri="{FF2B5EF4-FFF2-40B4-BE49-F238E27FC236}">
-                <a16:creationId xmlns:a16="http://schemas.microsoft.com/office/drawing/2014/main" id="{C89449B2-E25E-ECB2-34C2-0A2D9A6D87EE}"/>
+                <a16:creationId xmlns:a16="http://schemas.microsoft.com/office/drawing/2014/main" id="{11E70F9F-50A1-57DF-DDF2-1B54FEDE5714}"/>
               </a:ext>
             </a:extLst>
           </p:cNvPr>
@@ -10391,7 +10386,7 @@
           <p:cNvPr id="17" name="Rectangle 16">
             <a:extLst>
               <a:ext uri="{FF2B5EF4-FFF2-40B4-BE49-F238E27FC236}">
-                <a16:creationId xmlns:a16="http://schemas.microsoft.com/office/drawing/2014/main" id="{CFFB57A9-10CE-B998-5EFE-6AE0A4BEADCD}"/>
+                <a16:creationId xmlns:a16="http://schemas.microsoft.com/office/drawing/2014/main" id="{8551809D-6EE4-8EF3-79B7-909E916B4844}"/>
               </a:ext>
             </a:extLst>
           </p:cNvPr>
@@ -10445,7 +10440,7 @@
           <p:cNvPr id="18" name="TextBox 17">
             <a:extLst>
               <a:ext uri="{FF2B5EF4-FFF2-40B4-BE49-F238E27FC236}">
-                <a16:creationId xmlns:a16="http://schemas.microsoft.com/office/drawing/2014/main" id="{F9695EBB-6C0E-FA58-4454-971B34C4DE05}"/>
+                <a16:creationId xmlns:a16="http://schemas.microsoft.com/office/drawing/2014/main" id="{9981EFB8-F022-C89B-1BFA-0FAA265CFCFD}"/>
               </a:ext>
             </a:extLst>
           </p:cNvPr>
@@ -10485,7 +10480,7 @@
           <p:cNvPr id="19" name="Rectangle 18">
             <a:extLst>
               <a:ext uri="{FF2B5EF4-FFF2-40B4-BE49-F238E27FC236}">
-                <a16:creationId xmlns:a16="http://schemas.microsoft.com/office/drawing/2014/main" id="{34A7F5C3-4596-F14B-342B-244E80A56F31}"/>
+                <a16:creationId xmlns:a16="http://schemas.microsoft.com/office/drawing/2014/main" id="{847581B3-4085-D0A0-CF4D-DE1692CD4943}"/>
               </a:ext>
             </a:extLst>
           </p:cNvPr>
@@ -10539,7 +10534,7 @@
           <p:cNvPr id="20" name="TextBox 19">
             <a:extLst>
               <a:ext uri="{FF2B5EF4-FFF2-40B4-BE49-F238E27FC236}">
-                <a16:creationId xmlns:a16="http://schemas.microsoft.com/office/drawing/2014/main" id="{D89A19AB-4680-DD1B-279C-B5B9441A3267}"/>
+                <a16:creationId xmlns:a16="http://schemas.microsoft.com/office/drawing/2014/main" id="{BE61B4DA-B642-9769-D1A1-372AE6904B4D}"/>
               </a:ext>
             </a:extLst>
           </p:cNvPr>
@@ -10579,7 +10574,7 @@
           <p:cNvPr id="21" name="Rectangle 20">
             <a:extLst>
               <a:ext uri="{FF2B5EF4-FFF2-40B4-BE49-F238E27FC236}">
-                <a16:creationId xmlns:a16="http://schemas.microsoft.com/office/drawing/2014/main" id="{69EBC6BA-5EFF-87FB-0433-9E26F376DFAC}"/>
+                <a16:creationId xmlns:a16="http://schemas.microsoft.com/office/drawing/2014/main" id="{D43417F9-17B5-9AE7-D688-8F293F09AB31}"/>
               </a:ext>
             </a:extLst>
           </p:cNvPr>
@@ -10633,7 +10628,7 @@
           <p:cNvPr id="22" name="TextBox 21">
             <a:extLst>
               <a:ext uri="{FF2B5EF4-FFF2-40B4-BE49-F238E27FC236}">
-                <a16:creationId xmlns:a16="http://schemas.microsoft.com/office/drawing/2014/main" id="{F1E6D379-74F7-1B0F-09A3-B2836B618A55}"/>
+                <a16:creationId xmlns:a16="http://schemas.microsoft.com/office/drawing/2014/main" id="{57FEF100-E9B7-013E-FEF1-2A5B22F71A72}"/>
               </a:ext>
             </a:extLst>
           </p:cNvPr>
@@ -10673,7 +10668,7 @@
           <p:cNvPr id="23" name="Rectangle 22">
             <a:extLst>
               <a:ext uri="{FF2B5EF4-FFF2-40B4-BE49-F238E27FC236}">
-                <a16:creationId xmlns:a16="http://schemas.microsoft.com/office/drawing/2014/main" id="{244DD464-D214-95AE-4E14-6A4EA4CA20AE}"/>
+                <a16:creationId xmlns:a16="http://schemas.microsoft.com/office/drawing/2014/main" id="{30754E22-6146-0D5F-0AE3-3F15494E0942}"/>
               </a:ext>
             </a:extLst>
           </p:cNvPr>
@@ -10727,7 +10722,7 @@
           <p:cNvPr id="24" name="TextBox 23">
             <a:extLst>
               <a:ext uri="{FF2B5EF4-FFF2-40B4-BE49-F238E27FC236}">
-                <a16:creationId xmlns:a16="http://schemas.microsoft.com/office/drawing/2014/main" id="{C551ABBC-6D13-CC27-EB83-4DBD63C23E7D}"/>
+                <a16:creationId xmlns:a16="http://schemas.microsoft.com/office/drawing/2014/main" id="{2851B1D9-965A-6EA4-3B30-73BB6F6648EE}"/>
               </a:ext>
             </a:extLst>
           </p:cNvPr>
@@ -10767,7 +10762,7 @@
           <p:cNvPr id="25" name="Rectangle 24">
             <a:extLst>
               <a:ext uri="{FF2B5EF4-FFF2-40B4-BE49-F238E27FC236}">
-                <a16:creationId xmlns:a16="http://schemas.microsoft.com/office/drawing/2014/main" id="{F8D7488D-CD34-056F-44FB-6288CA1F177D}"/>
+                <a16:creationId xmlns:a16="http://schemas.microsoft.com/office/drawing/2014/main" id="{09998FB3-5D90-9CA6-A091-404B5102E753}"/>
               </a:ext>
             </a:extLst>
           </p:cNvPr>
@@ -10821,7 +10816,7 @@
           <p:cNvPr id="26" name="TextBox 25">
             <a:extLst>
               <a:ext uri="{FF2B5EF4-FFF2-40B4-BE49-F238E27FC236}">
-                <a16:creationId xmlns:a16="http://schemas.microsoft.com/office/drawing/2014/main" id="{01C18E03-0F8C-35E1-CE14-E21F0B76E38F}"/>
+                <a16:creationId xmlns:a16="http://schemas.microsoft.com/office/drawing/2014/main" id="{E8DBBCAB-C36C-40A8-88D9-96438842349F}"/>
               </a:ext>
             </a:extLst>
           </p:cNvPr>
@@ -10861,7 +10856,7 @@
           <p:cNvPr id="27" name="Rectangle 26">
             <a:extLst>
               <a:ext uri="{FF2B5EF4-FFF2-40B4-BE49-F238E27FC236}">
-                <a16:creationId xmlns:a16="http://schemas.microsoft.com/office/drawing/2014/main" id="{90AB163C-231A-0065-1F72-2663F5EE3535}"/>
+                <a16:creationId xmlns:a16="http://schemas.microsoft.com/office/drawing/2014/main" id="{43608C59-EAC1-474E-E50B-2E66A048CCCB}"/>
               </a:ext>
             </a:extLst>
           </p:cNvPr>
@@ -10915,7 +10910,7 @@
           <p:cNvPr id="28" name="TextBox 27">
             <a:extLst>
               <a:ext uri="{FF2B5EF4-FFF2-40B4-BE49-F238E27FC236}">
-                <a16:creationId xmlns:a16="http://schemas.microsoft.com/office/drawing/2014/main" id="{D77BBEB2-C891-100F-B17C-A85D5AD17999}"/>
+                <a16:creationId xmlns:a16="http://schemas.microsoft.com/office/drawing/2014/main" id="{20C3AB69-9B80-3254-78A7-87C9D14F899C}"/>
               </a:ext>
             </a:extLst>
           </p:cNvPr>
@@ -10955,7 +10950,7 @@
           <p:cNvPr id="29" name="Rectangle 28">
             <a:extLst>
               <a:ext uri="{FF2B5EF4-FFF2-40B4-BE49-F238E27FC236}">
-                <a16:creationId xmlns:a16="http://schemas.microsoft.com/office/drawing/2014/main" id="{9C91C5E0-E701-C6AD-F718-694D1FF90098}"/>
+                <a16:creationId xmlns:a16="http://schemas.microsoft.com/office/drawing/2014/main" id="{38DDB0F5-4BE5-C113-D599-584E025233BB}"/>
               </a:ext>
             </a:extLst>
           </p:cNvPr>
@@ -11009,7 +11004,7 @@
           <p:cNvPr id="30" name="TextBox 29">
             <a:extLst>
               <a:ext uri="{FF2B5EF4-FFF2-40B4-BE49-F238E27FC236}">
-                <a16:creationId xmlns:a16="http://schemas.microsoft.com/office/drawing/2014/main" id="{E27D6661-0A4D-3047-B550-594D5EAF275E}"/>
+                <a16:creationId xmlns:a16="http://schemas.microsoft.com/office/drawing/2014/main" id="{4C102499-3323-FBA6-7A3D-2807F87008AD}"/>
               </a:ext>
             </a:extLst>
           </p:cNvPr>
@@ -11049,7 +11044,7 @@
           <p:cNvPr id="31" name="Rectangle 30">
             <a:extLst>
               <a:ext uri="{FF2B5EF4-FFF2-40B4-BE49-F238E27FC236}">
-                <a16:creationId xmlns:a16="http://schemas.microsoft.com/office/drawing/2014/main" id="{38E5813F-AEA2-5A80-1713-2B9646DF6582}"/>
+                <a16:creationId xmlns:a16="http://schemas.microsoft.com/office/drawing/2014/main" id="{2A24890C-7600-9B00-D056-9C63432ED2E1}"/>
               </a:ext>
             </a:extLst>
           </p:cNvPr>
@@ -11103,7 +11098,7 @@
           <p:cNvPr id="32" name="TextBox 31">
             <a:extLst>
               <a:ext uri="{FF2B5EF4-FFF2-40B4-BE49-F238E27FC236}">
-                <a16:creationId xmlns:a16="http://schemas.microsoft.com/office/drawing/2014/main" id="{2896D754-78B3-FC2B-E394-490624111005}"/>
+                <a16:creationId xmlns:a16="http://schemas.microsoft.com/office/drawing/2014/main" id="{ABEE61E0-DF6A-B1BA-8E02-D6F75B9A3F5A}"/>
               </a:ext>
             </a:extLst>
           </p:cNvPr>
@@ -11143,7 +11138,7 @@
           <p:cNvPr id="33" name="Rectangle 32">
             <a:extLst>
               <a:ext uri="{FF2B5EF4-FFF2-40B4-BE49-F238E27FC236}">
-                <a16:creationId xmlns:a16="http://schemas.microsoft.com/office/drawing/2014/main" id="{4892D2B6-D49A-65E8-8868-87D9E4D4FBCC}"/>
+                <a16:creationId xmlns:a16="http://schemas.microsoft.com/office/drawing/2014/main" id="{36651395-C437-AC8E-95E9-0C52DB39ABE5}"/>
               </a:ext>
             </a:extLst>
           </p:cNvPr>
@@ -11197,7 +11192,7 @@
           <p:cNvPr id="34" name="TextBox 33">
             <a:extLst>
               <a:ext uri="{FF2B5EF4-FFF2-40B4-BE49-F238E27FC236}">
-                <a16:creationId xmlns:a16="http://schemas.microsoft.com/office/drawing/2014/main" id="{15A60A57-74E9-33E1-2DBC-4E01ED002988}"/>
+                <a16:creationId xmlns:a16="http://schemas.microsoft.com/office/drawing/2014/main" id="{BD1A87BE-C4C5-E056-90D1-8E3F482E5FA5}"/>
               </a:ext>
             </a:extLst>
           </p:cNvPr>
@@ -11237,7 +11232,7 @@
           <p:cNvPr id="35" name="Rectangle 34">
             <a:extLst>
               <a:ext uri="{FF2B5EF4-FFF2-40B4-BE49-F238E27FC236}">
-                <a16:creationId xmlns:a16="http://schemas.microsoft.com/office/drawing/2014/main" id="{A6ACAC45-1F52-7547-9F48-0C91EAA8D392}"/>
+                <a16:creationId xmlns:a16="http://schemas.microsoft.com/office/drawing/2014/main" id="{E745B17E-5A3F-2B5E-4DFD-F59AA670B42C}"/>
               </a:ext>
             </a:extLst>
           </p:cNvPr>
@@ -11291,7 +11286,7 @@
           <p:cNvPr id="36" name="TextBox 35">
             <a:extLst>
               <a:ext uri="{FF2B5EF4-FFF2-40B4-BE49-F238E27FC236}">
-                <a16:creationId xmlns:a16="http://schemas.microsoft.com/office/drawing/2014/main" id="{5F8B1A1B-FE2E-B90B-1EEE-95EA5AAA44ED}"/>
+                <a16:creationId xmlns:a16="http://schemas.microsoft.com/office/drawing/2014/main" id="{E0D8CF99-32FF-D7C3-21A5-F4EA0C45A54B}"/>
               </a:ext>
             </a:extLst>
           </p:cNvPr>
@@ -11331,7 +11326,7 @@
           <p:cNvPr id="37" name="Rectangle 36">
             <a:extLst>
               <a:ext uri="{FF2B5EF4-FFF2-40B4-BE49-F238E27FC236}">
-                <a16:creationId xmlns:a16="http://schemas.microsoft.com/office/drawing/2014/main" id="{FB4AE4FE-942A-EE9B-45A8-C4995A8F1775}"/>
+                <a16:creationId xmlns:a16="http://schemas.microsoft.com/office/drawing/2014/main" id="{350D615C-172A-859E-8449-F55DB225E043}"/>
               </a:ext>
             </a:extLst>
           </p:cNvPr>
@@ -11385,7 +11380,7 @@
           <p:cNvPr id="38" name="TextBox 37">
             <a:extLst>
               <a:ext uri="{FF2B5EF4-FFF2-40B4-BE49-F238E27FC236}">
-                <a16:creationId xmlns:a16="http://schemas.microsoft.com/office/drawing/2014/main" id="{F6258D8A-5F36-38C7-FD5D-10B93CEDF196}"/>
+                <a16:creationId xmlns:a16="http://schemas.microsoft.com/office/drawing/2014/main" id="{A8F68D84-5565-726F-DCEA-1F215C4398C7}"/>
               </a:ext>
             </a:extLst>
           </p:cNvPr>
@@ -11425,7 +11420,7 @@
           <p:cNvPr id="39" name="Rectangle 38">
             <a:extLst>
               <a:ext uri="{FF2B5EF4-FFF2-40B4-BE49-F238E27FC236}">
-                <a16:creationId xmlns:a16="http://schemas.microsoft.com/office/drawing/2014/main" id="{E393656F-A562-FF29-C441-4C8D4B414A23}"/>
+                <a16:creationId xmlns:a16="http://schemas.microsoft.com/office/drawing/2014/main" id="{FC0008D3-55CF-1E25-C197-993212808CE6}"/>
               </a:ext>
             </a:extLst>
           </p:cNvPr>
@@ -11479,7 +11474,7 @@
           <p:cNvPr id="40" name="TextBox 39">
             <a:extLst>
               <a:ext uri="{FF2B5EF4-FFF2-40B4-BE49-F238E27FC236}">
-                <a16:creationId xmlns:a16="http://schemas.microsoft.com/office/drawing/2014/main" id="{10118821-8459-35B7-1D08-2362F0635ADF}"/>
+                <a16:creationId xmlns:a16="http://schemas.microsoft.com/office/drawing/2014/main" id="{EF5E3D4F-0B45-1CFE-8AAC-3B4395776ADA}"/>
               </a:ext>
             </a:extLst>
           </p:cNvPr>
@@ -11519,7 +11514,7 @@
           <p:cNvPr id="41" name="Rectangle 40">
             <a:extLst>
               <a:ext uri="{FF2B5EF4-FFF2-40B4-BE49-F238E27FC236}">
-                <a16:creationId xmlns:a16="http://schemas.microsoft.com/office/drawing/2014/main" id="{1E8A3198-5060-18BA-C1F1-A79E519D0638}"/>
+                <a16:creationId xmlns:a16="http://schemas.microsoft.com/office/drawing/2014/main" id="{BCC48D92-D740-3628-D4A4-0F3D7DEB0FFB}"/>
               </a:ext>
             </a:extLst>
           </p:cNvPr>
@@ -11573,7 +11568,7 @@
           <p:cNvPr id="42" name="TextBox 41">
             <a:extLst>
               <a:ext uri="{FF2B5EF4-FFF2-40B4-BE49-F238E27FC236}">
-                <a16:creationId xmlns:a16="http://schemas.microsoft.com/office/drawing/2014/main" id="{BE6C3817-F81C-4F97-A3B9-83B8D067D450}"/>
+                <a16:creationId xmlns:a16="http://schemas.microsoft.com/office/drawing/2014/main" id="{AAB5FF75-6B06-4B7C-AD0F-6C4AAFE55373}"/>
               </a:ext>
             </a:extLst>
           </p:cNvPr>
@@ -11613,7 +11608,7 @@
           <p:cNvPr id="43" name="Rectangle 42">
             <a:extLst>
               <a:ext uri="{FF2B5EF4-FFF2-40B4-BE49-F238E27FC236}">
-                <a16:creationId xmlns:a16="http://schemas.microsoft.com/office/drawing/2014/main" id="{A6F6171D-ACEF-9177-DEB1-9F9EFDDC87DA}"/>
+                <a16:creationId xmlns:a16="http://schemas.microsoft.com/office/drawing/2014/main" id="{97D8D5AC-42F0-826A-D6E3-FE0900308186}"/>
               </a:ext>
             </a:extLst>
           </p:cNvPr>
@@ -11667,7 +11662,7 @@
           <p:cNvPr id="44" name="TextBox 43">
             <a:extLst>
               <a:ext uri="{FF2B5EF4-FFF2-40B4-BE49-F238E27FC236}">
-                <a16:creationId xmlns:a16="http://schemas.microsoft.com/office/drawing/2014/main" id="{CDE429BD-17F1-AD94-E4F1-FD3A73EFA889}"/>
+                <a16:creationId xmlns:a16="http://schemas.microsoft.com/office/drawing/2014/main" id="{85E31261-B1D6-F985-0D00-6AD001E48B0D}"/>
               </a:ext>
             </a:extLst>
           </p:cNvPr>
@@ -11707,7 +11702,7 @@
           <p:cNvPr id="45" name="Rectangle 44">
             <a:extLst>
               <a:ext uri="{FF2B5EF4-FFF2-40B4-BE49-F238E27FC236}">
-                <a16:creationId xmlns:a16="http://schemas.microsoft.com/office/drawing/2014/main" id="{9569BAED-89C8-C15E-6EAC-9DABD25BA368}"/>
+                <a16:creationId xmlns:a16="http://schemas.microsoft.com/office/drawing/2014/main" id="{B75C0BBD-3410-8B59-AB08-6E5A9CCC2A91}"/>
               </a:ext>
             </a:extLst>
           </p:cNvPr>
@@ -11761,7 +11756,7 @@
           <p:cNvPr id="46" name="TextBox 45">
             <a:extLst>
               <a:ext uri="{FF2B5EF4-FFF2-40B4-BE49-F238E27FC236}">
-                <a16:creationId xmlns:a16="http://schemas.microsoft.com/office/drawing/2014/main" id="{DA0E3FDE-5A6F-18C0-1E93-BADE27D4C9A7}"/>
+                <a16:creationId xmlns:a16="http://schemas.microsoft.com/office/drawing/2014/main" id="{C3B50832-584D-ED45-EEBB-9B9C02E56E27}"/>
               </a:ext>
             </a:extLst>
           </p:cNvPr>
@@ -11801,7 +11796,7 @@
           <p:cNvPr id="47" name="Rectangle 46">
             <a:extLst>
               <a:ext uri="{FF2B5EF4-FFF2-40B4-BE49-F238E27FC236}">
-                <a16:creationId xmlns:a16="http://schemas.microsoft.com/office/drawing/2014/main" id="{9DE12A03-8B3A-62AD-E582-6E79F6AAF676}"/>
+                <a16:creationId xmlns:a16="http://schemas.microsoft.com/office/drawing/2014/main" id="{D10B71AB-BFA8-F085-F128-02FA4E1AAADB}"/>
               </a:ext>
             </a:extLst>
           </p:cNvPr>
@@ -11855,7 +11850,7 @@
           <p:cNvPr id="48" name="TextBox 47">
             <a:extLst>
               <a:ext uri="{FF2B5EF4-FFF2-40B4-BE49-F238E27FC236}">
-                <a16:creationId xmlns:a16="http://schemas.microsoft.com/office/drawing/2014/main" id="{BAF9D1BF-8563-93D9-7A4D-E1966AED5CDB}"/>
+                <a16:creationId xmlns:a16="http://schemas.microsoft.com/office/drawing/2014/main" id="{5D369A58-791E-812F-5179-EA89326844AF}"/>
               </a:ext>
             </a:extLst>
           </p:cNvPr>
@@ -11895,7 +11890,7 @@
           <p:cNvPr id="49" name="Rectangle 48">
             <a:extLst>
               <a:ext uri="{FF2B5EF4-FFF2-40B4-BE49-F238E27FC236}">
-                <a16:creationId xmlns:a16="http://schemas.microsoft.com/office/drawing/2014/main" id="{E3B02DA8-88A1-D236-05E9-1758FDEE248B}"/>
+                <a16:creationId xmlns:a16="http://schemas.microsoft.com/office/drawing/2014/main" id="{2A37AA93-98F4-A41B-6FE4-1353DC605F58}"/>
               </a:ext>
             </a:extLst>
           </p:cNvPr>
@@ -11949,7 +11944,7 @@
           <p:cNvPr id="50" name="TextBox 49">
             <a:extLst>
               <a:ext uri="{FF2B5EF4-FFF2-40B4-BE49-F238E27FC236}">
-                <a16:creationId xmlns:a16="http://schemas.microsoft.com/office/drawing/2014/main" id="{4B218132-8174-3460-47F7-D25191D0927A}"/>
+                <a16:creationId xmlns:a16="http://schemas.microsoft.com/office/drawing/2014/main" id="{4905D2D1-25CF-F126-10E3-B060D6747686}"/>
               </a:ext>
             </a:extLst>
           </p:cNvPr>
@@ -11989,7 +11984,7 @@
           <p:cNvPr id="51" name="Rectangle 50">
             <a:extLst>
               <a:ext uri="{FF2B5EF4-FFF2-40B4-BE49-F238E27FC236}">
-                <a16:creationId xmlns:a16="http://schemas.microsoft.com/office/drawing/2014/main" id="{807801E9-281B-794D-EAED-9861CD7F6958}"/>
+                <a16:creationId xmlns:a16="http://schemas.microsoft.com/office/drawing/2014/main" id="{016595DB-866E-BBEE-17DF-81B15DBFA211}"/>
               </a:ext>
             </a:extLst>
           </p:cNvPr>
@@ -12043,7 +12038,7 @@
           <p:cNvPr id="52" name="TextBox 51">
             <a:extLst>
               <a:ext uri="{FF2B5EF4-FFF2-40B4-BE49-F238E27FC236}">
-                <a16:creationId xmlns:a16="http://schemas.microsoft.com/office/drawing/2014/main" id="{963E4A93-3F1E-7D30-F63E-CB7479D9FBFD}"/>
+                <a16:creationId xmlns:a16="http://schemas.microsoft.com/office/drawing/2014/main" id="{C9ADE2F2-F7B4-97D3-92C2-1FF24210EA7A}"/>
               </a:ext>
             </a:extLst>
           </p:cNvPr>
@@ -12083,7 +12078,7 @@
           <p:cNvPr id="53" name="Rectangle 52">
             <a:extLst>
               <a:ext uri="{FF2B5EF4-FFF2-40B4-BE49-F238E27FC236}">
-                <a16:creationId xmlns:a16="http://schemas.microsoft.com/office/drawing/2014/main" id="{0BB125F1-6E33-BAD3-A1E2-12A2035F613B}"/>
+                <a16:creationId xmlns:a16="http://schemas.microsoft.com/office/drawing/2014/main" id="{7AB36B25-A641-B436-449C-AA228A2DEF7B}"/>
               </a:ext>
             </a:extLst>
           </p:cNvPr>
@@ -12137,7 +12132,7 @@
           <p:cNvPr id="54" name="TextBox 53">
             <a:extLst>
               <a:ext uri="{FF2B5EF4-FFF2-40B4-BE49-F238E27FC236}">
-                <a16:creationId xmlns:a16="http://schemas.microsoft.com/office/drawing/2014/main" id="{72435F50-DBB5-8E6D-1C8A-F3F10DFF5199}"/>
+                <a16:creationId xmlns:a16="http://schemas.microsoft.com/office/drawing/2014/main" id="{60B754A3-31CD-0A9A-E059-2ECBC0F47F50}"/>
               </a:ext>
             </a:extLst>
           </p:cNvPr>
@@ -12177,7 +12172,7 @@
           <p:cNvPr id="55" name="Rectangle 54">
             <a:extLst>
               <a:ext uri="{FF2B5EF4-FFF2-40B4-BE49-F238E27FC236}">
-                <a16:creationId xmlns:a16="http://schemas.microsoft.com/office/drawing/2014/main" id="{E45F67EC-3CA2-F8AE-180A-D82BBCCF3249}"/>
+                <a16:creationId xmlns:a16="http://schemas.microsoft.com/office/drawing/2014/main" id="{F50B3CC3-4D51-8D00-144B-9A07BEC563BC}"/>
               </a:ext>
             </a:extLst>
           </p:cNvPr>
@@ -12231,7 +12226,7 @@
           <p:cNvPr id="56" name="TextBox 55">
             <a:extLst>
               <a:ext uri="{FF2B5EF4-FFF2-40B4-BE49-F238E27FC236}">
-                <a16:creationId xmlns:a16="http://schemas.microsoft.com/office/drawing/2014/main" id="{896C4BC5-3E11-F77E-DB92-86401E1772EB}"/>
+                <a16:creationId xmlns:a16="http://schemas.microsoft.com/office/drawing/2014/main" id="{7D52083F-C793-69B6-6CEF-7B3B1B51849F}"/>
               </a:ext>
             </a:extLst>
           </p:cNvPr>
@@ -12271,7 +12266,7 @@
           <p:cNvPr id="57" name="Rectangle 56">
             <a:extLst>
               <a:ext uri="{FF2B5EF4-FFF2-40B4-BE49-F238E27FC236}">
-                <a16:creationId xmlns:a16="http://schemas.microsoft.com/office/drawing/2014/main" id="{0FCBB309-C8AC-A3A5-D817-F144D27F9703}"/>
+                <a16:creationId xmlns:a16="http://schemas.microsoft.com/office/drawing/2014/main" id="{09B0683C-7423-74A0-69BF-660D79F7353F}"/>
               </a:ext>
             </a:extLst>
           </p:cNvPr>
@@ -12325,7 +12320,7 @@
           <p:cNvPr id="58" name="TextBox 57">
             <a:extLst>
               <a:ext uri="{FF2B5EF4-FFF2-40B4-BE49-F238E27FC236}">
-                <a16:creationId xmlns:a16="http://schemas.microsoft.com/office/drawing/2014/main" id="{6CFD3DDA-292A-AAA4-A8DE-AACA7986B656}"/>
+                <a16:creationId xmlns:a16="http://schemas.microsoft.com/office/drawing/2014/main" id="{D8BE29F1-72F3-E62F-36CE-6AC6576D723B}"/>
               </a:ext>
             </a:extLst>
           </p:cNvPr>
@@ -12365,7 +12360,7 @@
           <p:cNvPr id="59" name="Rectangle 58">
             <a:extLst>
               <a:ext uri="{FF2B5EF4-FFF2-40B4-BE49-F238E27FC236}">
-                <a16:creationId xmlns:a16="http://schemas.microsoft.com/office/drawing/2014/main" id="{3A5EEE37-8866-47F0-C2D0-870F2801E1B9}"/>
+                <a16:creationId xmlns:a16="http://schemas.microsoft.com/office/drawing/2014/main" id="{DBDEC368-37A7-E51C-124D-947AD35CF9A9}"/>
               </a:ext>
             </a:extLst>
           </p:cNvPr>
@@ -12419,7 +12414,7 @@
           <p:cNvPr id="60" name="TextBox 59">
             <a:extLst>
               <a:ext uri="{FF2B5EF4-FFF2-40B4-BE49-F238E27FC236}">
-                <a16:creationId xmlns:a16="http://schemas.microsoft.com/office/drawing/2014/main" id="{791BB7E2-334E-DBFA-1896-25220A27B1D6}"/>
+                <a16:creationId xmlns:a16="http://schemas.microsoft.com/office/drawing/2014/main" id="{7AF6417D-9ADC-5F3D-DD0B-9BEFD39D70A2}"/>
               </a:ext>
             </a:extLst>
           </p:cNvPr>
@@ -12459,7 +12454,7 @@
           <p:cNvPr id="61" name="Rectangle 60">
             <a:extLst>
               <a:ext uri="{FF2B5EF4-FFF2-40B4-BE49-F238E27FC236}">
-                <a16:creationId xmlns:a16="http://schemas.microsoft.com/office/drawing/2014/main" id="{EEB664F4-9D6F-60CF-969A-FD24831F12E2}"/>
+                <a16:creationId xmlns:a16="http://schemas.microsoft.com/office/drawing/2014/main" id="{E98D6013-DE47-C2BE-6340-6165BC1F5F78}"/>
               </a:ext>
             </a:extLst>
           </p:cNvPr>
@@ -12513,7 +12508,7 @@
           <p:cNvPr id="62" name="TextBox 61">
             <a:extLst>
               <a:ext uri="{FF2B5EF4-FFF2-40B4-BE49-F238E27FC236}">
-                <a16:creationId xmlns:a16="http://schemas.microsoft.com/office/drawing/2014/main" id="{9E46D749-850B-5F5F-86C9-D40C3185B236}"/>
+                <a16:creationId xmlns:a16="http://schemas.microsoft.com/office/drawing/2014/main" id="{19FBBDF6-5D66-074F-0F87-F69888EBEF28}"/>
               </a:ext>
             </a:extLst>
           </p:cNvPr>
@@ -12553,7 +12548,7 @@
           <p:cNvPr id="63" name="Rectangle 62">
             <a:extLst>
               <a:ext uri="{FF2B5EF4-FFF2-40B4-BE49-F238E27FC236}">
-                <a16:creationId xmlns:a16="http://schemas.microsoft.com/office/drawing/2014/main" id="{8632F688-C8C7-7A2E-B70C-DF082BAE4EA6}"/>
+                <a16:creationId xmlns:a16="http://schemas.microsoft.com/office/drawing/2014/main" id="{9EF88659-5939-3975-87B7-DF5532D28DE0}"/>
               </a:ext>
             </a:extLst>
           </p:cNvPr>
@@ -12607,7 +12602,7 @@
           <p:cNvPr id="64" name="TextBox 63">
             <a:extLst>
               <a:ext uri="{FF2B5EF4-FFF2-40B4-BE49-F238E27FC236}">
-                <a16:creationId xmlns:a16="http://schemas.microsoft.com/office/drawing/2014/main" id="{9981FCA7-ADEC-9E74-1078-1C1B3FB89BF0}"/>
+                <a16:creationId xmlns:a16="http://schemas.microsoft.com/office/drawing/2014/main" id="{95CCBA8B-28E2-E04D-B169-D9413A4F0A9F}"/>
               </a:ext>
             </a:extLst>
           </p:cNvPr>
@@ -12647,7 +12642,7 @@
           <p:cNvPr id="65" name="Rectangle 64">
             <a:extLst>
               <a:ext uri="{FF2B5EF4-FFF2-40B4-BE49-F238E27FC236}">
-                <a16:creationId xmlns:a16="http://schemas.microsoft.com/office/drawing/2014/main" id="{AE0F9669-2491-C66B-50C3-0807963094BB}"/>
+                <a16:creationId xmlns:a16="http://schemas.microsoft.com/office/drawing/2014/main" id="{AE97915B-2F5A-2B3E-F3E5-72E0D3B68648}"/>
               </a:ext>
             </a:extLst>
           </p:cNvPr>
@@ -12701,7 +12696,7 @@
           <p:cNvPr id="66" name="TextBox 65">
             <a:extLst>
               <a:ext uri="{FF2B5EF4-FFF2-40B4-BE49-F238E27FC236}">
-                <a16:creationId xmlns:a16="http://schemas.microsoft.com/office/drawing/2014/main" id="{029E294B-6043-E145-06AC-1252F5010224}"/>
+                <a16:creationId xmlns:a16="http://schemas.microsoft.com/office/drawing/2014/main" id="{A29CE90C-8F1D-4A03-2644-DC04E10338E6}"/>
               </a:ext>
             </a:extLst>
           </p:cNvPr>
@@ -12741,7 +12736,7 @@
           <p:cNvPr id="67" name="Rectangle 66">
             <a:extLst>
               <a:ext uri="{FF2B5EF4-FFF2-40B4-BE49-F238E27FC236}">
-                <a16:creationId xmlns:a16="http://schemas.microsoft.com/office/drawing/2014/main" id="{637B1C34-9815-CB9C-8DFA-1F39EC9EBC6C}"/>
+                <a16:creationId xmlns:a16="http://schemas.microsoft.com/office/drawing/2014/main" id="{5FC838CE-F2D1-1FD4-8E7F-B68BBA9D7C91}"/>
               </a:ext>
             </a:extLst>
           </p:cNvPr>
@@ -12795,7 +12790,7 @@
           <p:cNvPr id="68" name="TextBox 67">
             <a:extLst>
               <a:ext uri="{FF2B5EF4-FFF2-40B4-BE49-F238E27FC236}">
-                <a16:creationId xmlns:a16="http://schemas.microsoft.com/office/drawing/2014/main" id="{616EB2A5-BBDD-6F1F-933A-5C303E32467A}"/>
+                <a16:creationId xmlns:a16="http://schemas.microsoft.com/office/drawing/2014/main" id="{0801CE15-B36B-36AB-14DC-701736A8C732}"/>
               </a:ext>
             </a:extLst>
           </p:cNvPr>
@@ -12835,7 +12830,7 @@
           <p:cNvPr id="69" name="Rectangle 68">
             <a:extLst>
               <a:ext uri="{FF2B5EF4-FFF2-40B4-BE49-F238E27FC236}">
-                <a16:creationId xmlns:a16="http://schemas.microsoft.com/office/drawing/2014/main" id="{DF3BCFF9-5BA5-2E81-5806-566540B4CCED}"/>
+                <a16:creationId xmlns:a16="http://schemas.microsoft.com/office/drawing/2014/main" id="{8186558C-C8E7-701D-8D48-7B855369699D}"/>
               </a:ext>
             </a:extLst>
           </p:cNvPr>
@@ -12889,7 +12884,7 @@
           <p:cNvPr id="70" name="TextBox 69">
             <a:extLst>
               <a:ext uri="{FF2B5EF4-FFF2-40B4-BE49-F238E27FC236}">
-                <a16:creationId xmlns:a16="http://schemas.microsoft.com/office/drawing/2014/main" id="{19E0129D-2910-F750-213C-C104009A4788}"/>
+                <a16:creationId xmlns:a16="http://schemas.microsoft.com/office/drawing/2014/main" id="{04B35578-8B9E-41AA-8062-08A29E711660}"/>
               </a:ext>
             </a:extLst>
           </p:cNvPr>
@@ -12929,7 +12924,7 @@
           <p:cNvPr id="71" name="Rectangle 70">
             <a:extLst>
               <a:ext uri="{FF2B5EF4-FFF2-40B4-BE49-F238E27FC236}">
-                <a16:creationId xmlns:a16="http://schemas.microsoft.com/office/drawing/2014/main" id="{7CE856DF-A991-09BE-A85A-8DD1A8CEA595}"/>
+                <a16:creationId xmlns:a16="http://schemas.microsoft.com/office/drawing/2014/main" id="{C138B1E2-E9DC-CCF8-8D41-CA7625628C16}"/>
               </a:ext>
             </a:extLst>
           </p:cNvPr>
@@ -12983,7 +12978,7 @@
           <p:cNvPr id="72" name="TextBox 71">
             <a:extLst>
               <a:ext uri="{FF2B5EF4-FFF2-40B4-BE49-F238E27FC236}">
-                <a16:creationId xmlns:a16="http://schemas.microsoft.com/office/drawing/2014/main" id="{845A56A7-C422-4BA4-70C2-A4B1643BDD64}"/>
+                <a16:creationId xmlns:a16="http://schemas.microsoft.com/office/drawing/2014/main" id="{7DC06EF5-6377-F0B6-730C-F9CCAC62AC9A}"/>
               </a:ext>
             </a:extLst>
           </p:cNvPr>
@@ -13023,7 +13018,7 @@
           <p:cNvPr id="73" name="Rectangle 72">
             <a:extLst>
               <a:ext uri="{FF2B5EF4-FFF2-40B4-BE49-F238E27FC236}">
-                <a16:creationId xmlns:a16="http://schemas.microsoft.com/office/drawing/2014/main" id="{A77BA0F3-C19A-1EA7-8D5A-E5310679D440}"/>
+                <a16:creationId xmlns:a16="http://schemas.microsoft.com/office/drawing/2014/main" id="{77C9D5A4-034B-E55E-91E1-1A8F6D03B3F2}"/>
               </a:ext>
             </a:extLst>
           </p:cNvPr>
@@ -13077,7 +13072,7 @@
           <p:cNvPr id="74" name="TextBox 73">
             <a:extLst>
               <a:ext uri="{FF2B5EF4-FFF2-40B4-BE49-F238E27FC236}">
-                <a16:creationId xmlns:a16="http://schemas.microsoft.com/office/drawing/2014/main" id="{C1F9F062-D128-388B-A9D4-BC04394E9DAF}"/>
+                <a16:creationId xmlns:a16="http://schemas.microsoft.com/office/drawing/2014/main" id="{16655001-AB89-3C4F-23D2-020BDE2C721A}"/>
               </a:ext>
             </a:extLst>
           </p:cNvPr>
@@ -13117,7 +13112,7 @@
           <p:cNvPr id="75" name="Rectangle 74">
             <a:extLst>
               <a:ext uri="{FF2B5EF4-FFF2-40B4-BE49-F238E27FC236}">
-                <a16:creationId xmlns:a16="http://schemas.microsoft.com/office/drawing/2014/main" id="{4C3F23C6-6AF5-8D3E-8996-37F168C684D1}"/>
+                <a16:creationId xmlns:a16="http://schemas.microsoft.com/office/drawing/2014/main" id="{08894D1C-A42A-4E57-E932-01E5CF5B67F8}"/>
               </a:ext>
             </a:extLst>
           </p:cNvPr>
@@ -13171,7 +13166,7 @@
           <p:cNvPr id="76" name="TextBox 75">
             <a:extLst>
               <a:ext uri="{FF2B5EF4-FFF2-40B4-BE49-F238E27FC236}">
-                <a16:creationId xmlns:a16="http://schemas.microsoft.com/office/drawing/2014/main" id="{ECF98F67-F032-B83C-AEA5-B5502262B157}"/>
+                <a16:creationId xmlns:a16="http://schemas.microsoft.com/office/drawing/2014/main" id="{5CD365F2-A74E-FFA0-EFC9-47720F644059}"/>
               </a:ext>
             </a:extLst>
           </p:cNvPr>
@@ -13211,7 +13206,7 @@
           <p:cNvPr id="77" name="TextBox 76">
             <a:extLst>
               <a:ext uri="{FF2B5EF4-FFF2-40B4-BE49-F238E27FC236}">
-                <a16:creationId xmlns:a16="http://schemas.microsoft.com/office/drawing/2014/main" id="{2B7F2522-20EC-0A3A-70F5-0A8254C39B52}"/>
+                <a16:creationId xmlns:a16="http://schemas.microsoft.com/office/drawing/2014/main" id="{A10DE64E-376F-91C8-015F-7D10E7207EC8}"/>
               </a:ext>
             </a:extLst>
           </p:cNvPr>
@@ -13252,7 +13247,7 @@
           <p:cNvPr id="78" name="Rectangle: Rounded Corners 77">
             <a:extLst>
               <a:ext uri="{FF2B5EF4-FFF2-40B4-BE49-F238E27FC236}">
-                <a16:creationId xmlns:a16="http://schemas.microsoft.com/office/drawing/2014/main" id="{7319C818-F5A7-EF22-4BC0-B2BF27469D13}"/>
+                <a16:creationId xmlns:a16="http://schemas.microsoft.com/office/drawing/2014/main" id="{457CA913-7728-013E-FD52-F27698E2F018}"/>
               </a:ext>
             </a:extLst>
           </p:cNvPr>
@@ -13306,7 +13301,7 @@
           <p:cNvPr id="79" name="TextBox 78">
             <a:extLst>
               <a:ext uri="{FF2B5EF4-FFF2-40B4-BE49-F238E27FC236}">
-                <a16:creationId xmlns:a16="http://schemas.microsoft.com/office/drawing/2014/main" id="{AF4415B1-FAD2-BE88-099D-1EF7C4E48345}"/>
+                <a16:creationId xmlns:a16="http://schemas.microsoft.com/office/drawing/2014/main" id="{84D569E4-C70C-7C7C-8975-FA823D228DBD}"/>
               </a:ext>
             </a:extLst>
           </p:cNvPr>
@@ -13347,7 +13342,7 @@
           <p:cNvPr id="80" name="TextBox 79">
             <a:extLst>
               <a:ext uri="{FF2B5EF4-FFF2-40B4-BE49-F238E27FC236}">
-                <a16:creationId xmlns:a16="http://schemas.microsoft.com/office/drawing/2014/main" id="{AEEB53DA-386B-BF89-0270-D1EE0B5B22BF}"/>
+                <a16:creationId xmlns:a16="http://schemas.microsoft.com/office/drawing/2014/main" id="{7C4D6E7A-BF7E-9F1A-3CDF-AFD69D820641}"/>
               </a:ext>
             </a:extLst>
           </p:cNvPr>
@@ -13387,7 +13382,7 @@
           <p:cNvPr id="81" name="TextBox 80">
             <a:extLst>
               <a:ext uri="{FF2B5EF4-FFF2-40B4-BE49-F238E27FC236}">
-                <a16:creationId xmlns:a16="http://schemas.microsoft.com/office/drawing/2014/main" id="{6A4A0028-4DDD-72DF-0904-01DFDDEAC467}"/>
+                <a16:creationId xmlns:a16="http://schemas.microsoft.com/office/drawing/2014/main" id="{643F9578-A1D8-7745-A32E-A50C8511D829}"/>
               </a:ext>
             </a:extLst>
           </p:cNvPr>
@@ -13426,7 +13421,7 @@
     </p:spTree>
     <p:extLst>
       <p:ext uri="{BB962C8B-B14F-4D97-AF65-F5344CB8AC3E}">
-        <p14:creationId xmlns:p14="http://schemas.microsoft.com/office/powerpoint/2010/main" val="3109120644"/>
+        <p14:creationId xmlns:p14="http://schemas.microsoft.com/office/powerpoint/2010/main" val="3717774171"/>
       </p:ext>
     </p:extLst>
   </p:cSld>
@@ -13466,7 +13461,7 @@
           <p:cNvPr id="2" name="TextBox 1">
             <a:extLst>
               <a:ext uri="{FF2B5EF4-FFF2-40B4-BE49-F238E27FC236}">
-                <a16:creationId xmlns:a16="http://schemas.microsoft.com/office/drawing/2014/main" id="{E44B2CFA-EEEF-F26C-2E08-8984C97E8BB6}"/>
+                <a16:creationId xmlns:a16="http://schemas.microsoft.com/office/drawing/2014/main" id="{0293ADF2-8CF5-76C7-E3A0-9AE190667DB1}"/>
               </a:ext>
             </a:extLst>
           </p:cNvPr>
@@ -13496,7 +13491,7 @@
                 </a:solidFill>
                 <a:latin typeface="Aptos" panose="020B0004020202020204" pitchFamily="34" charset="0"/>
               </a:rPr>
-              <a:t>4. Backend demo: follow one evidence chain</a:t>
+              <a:t>4. Evidence demo: follow one candidate chain</a:t>
             </a:r>
           </a:p>
         </p:txBody>
@@ -13506,7 +13501,7 @@
           <p:cNvPr id="3" name="TextBox 2">
             <a:extLst>
               <a:ext uri="{FF2B5EF4-FFF2-40B4-BE49-F238E27FC236}">
-                <a16:creationId xmlns:a16="http://schemas.microsoft.com/office/drawing/2014/main" id="{9C8566D8-F1F1-395B-7A5D-0B6FE31BE393}"/>
+                <a16:creationId xmlns:a16="http://schemas.microsoft.com/office/drawing/2014/main" id="{A5EDD953-AECA-BC77-ACEE-3AD13427403A}"/>
               </a:ext>
             </a:extLst>
           </p:cNvPr>
@@ -13536,7 +13531,7 @@
                 </a:solidFill>
                 <a:latin typeface="Aptos" panose="020B0004020202020204" pitchFamily="34" charset="0"/>
               </a:rPr>
-              <a:t>Show saved artifacts at high zoom; do not run a new model experiment</a:t>
+              <a:t>Use the public reference first; open a raw saved artifact only if time allows</a:t>
             </a:r>
           </a:p>
         </p:txBody>
@@ -13546,7 +13541,7 @@
           <p:cNvPr id="4" name="Straight Connector 3">
             <a:extLst>
               <a:ext uri="{FF2B5EF4-FFF2-40B4-BE49-F238E27FC236}">
-                <a16:creationId xmlns:a16="http://schemas.microsoft.com/office/drawing/2014/main" id="{0EECB18E-31BD-BE0B-811F-8F21B2FB8E89}"/>
+                <a16:creationId xmlns:a16="http://schemas.microsoft.com/office/drawing/2014/main" id="{3199D1AC-18E3-DFBF-BCA5-7B503EF52B9C}"/>
               </a:ext>
             </a:extLst>
           </p:cNvPr>
@@ -13587,7 +13582,7 @@
           <p:cNvPr id="5" name="Oval 4">
             <a:extLst>
               <a:ext uri="{FF2B5EF4-FFF2-40B4-BE49-F238E27FC236}">
-                <a16:creationId xmlns:a16="http://schemas.microsoft.com/office/drawing/2014/main" id="{63A58820-DC99-D04E-A8B8-3357C1C8D0C8}"/>
+                <a16:creationId xmlns:a16="http://schemas.microsoft.com/office/drawing/2014/main" id="{FA368071-AB53-4E75-F402-D34ADDC8F09D}"/>
               </a:ext>
             </a:extLst>
           </p:cNvPr>
@@ -13655,7 +13650,7 @@
           <p:cNvPr id="6" name="TextBox 5">
             <a:extLst>
               <a:ext uri="{FF2B5EF4-FFF2-40B4-BE49-F238E27FC236}">
-                <a16:creationId xmlns:a16="http://schemas.microsoft.com/office/drawing/2014/main" id="{611E77A1-DF36-32F8-BE9E-ED0CB0834A20}"/>
+                <a16:creationId xmlns:a16="http://schemas.microsoft.com/office/drawing/2014/main" id="{61BD396A-857E-0F12-1F38-3D37391A3FD9}"/>
               </a:ext>
             </a:extLst>
           </p:cNvPr>
@@ -13696,7 +13691,7 @@
           <p:cNvPr id="7" name="TextBox 6">
             <a:extLst>
               <a:ext uri="{FF2B5EF4-FFF2-40B4-BE49-F238E27FC236}">
-                <a16:creationId xmlns:a16="http://schemas.microsoft.com/office/drawing/2014/main" id="{0FB411CF-B154-87F4-60E0-A37D5EBFD0BF}"/>
+                <a16:creationId xmlns:a16="http://schemas.microsoft.com/office/drawing/2014/main" id="{E37C5516-C10E-1120-012A-1EE83A095767}"/>
               </a:ext>
             </a:extLst>
           </p:cNvPr>
@@ -13736,7 +13731,7 @@
           <p:cNvPr id="8" name="TextBox 7">
             <a:extLst>
               <a:ext uri="{FF2B5EF4-FFF2-40B4-BE49-F238E27FC236}">
-                <a16:creationId xmlns:a16="http://schemas.microsoft.com/office/drawing/2014/main" id="{ABA4B052-E0B2-F7E0-B8D3-39FF2044DB29}"/>
+                <a16:creationId xmlns:a16="http://schemas.microsoft.com/office/drawing/2014/main" id="{83EB2F21-8B87-B7E6-495B-329A737F57B9}"/>
               </a:ext>
             </a:extLst>
           </p:cNvPr>
@@ -13776,7 +13771,7 @@
           <p:cNvPr id="9" name="Straight Connector 8">
             <a:extLst>
               <a:ext uri="{FF2B5EF4-FFF2-40B4-BE49-F238E27FC236}">
-                <a16:creationId xmlns:a16="http://schemas.microsoft.com/office/drawing/2014/main" id="{6E82DB5A-2128-7D3E-FEB3-1D905D2BB681}"/>
+                <a16:creationId xmlns:a16="http://schemas.microsoft.com/office/drawing/2014/main" id="{DE546671-1076-6ED7-0C8D-589D59CBF7BB}"/>
               </a:ext>
             </a:extLst>
           </p:cNvPr>
@@ -13817,7 +13812,7 @@
           <p:cNvPr id="10" name="Oval 9">
             <a:extLst>
               <a:ext uri="{FF2B5EF4-FFF2-40B4-BE49-F238E27FC236}">
-                <a16:creationId xmlns:a16="http://schemas.microsoft.com/office/drawing/2014/main" id="{83F5510D-AB51-1A85-A55C-4CA771F8AC21}"/>
+                <a16:creationId xmlns:a16="http://schemas.microsoft.com/office/drawing/2014/main" id="{D3739F29-10EB-7D82-1855-80B4AF56A8C9}"/>
               </a:ext>
             </a:extLst>
           </p:cNvPr>
@@ -13885,7 +13880,7 @@
           <p:cNvPr id="11" name="TextBox 10">
             <a:extLst>
               <a:ext uri="{FF2B5EF4-FFF2-40B4-BE49-F238E27FC236}">
-                <a16:creationId xmlns:a16="http://schemas.microsoft.com/office/drawing/2014/main" id="{085D1B80-5253-1F2D-F206-BD8CEA3D5B90}"/>
+                <a16:creationId xmlns:a16="http://schemas.microsoft.com/office/drawing/2014/main" id="{EA483C38-8D10-4295-1F77-A76150A6DD54}"/>
               </a:ext>
             </a:extLst>
           </p:cNvPr>
@@ -13926,7 +13921,7 @@
           <p:cNvPr id="12" name="TextBox 11">
             <a:extLst>
               <a:ext uri="{FF2B5EF4-FFF2-40B4-BE49-F238E27FC236}">
-                <a16:creationId xmlns:a16="http://schemas.microsoft.com/office/drawing/2014/main" id="{1F91C880-6ABA-F782-E75A-D8DD9C9BF68B}"/>
+                <a16:creationId xmlns:a16="http://schemas.microsoft.com/office/drawing/2014/main" id="{DD8DA1AA-C3AE-A9BD-CA9B-8B5BC966F788}"/>
               </a:ext>
             </a:extLst>
           </p:cNvPr>
@@ -13966,7 +13961,7 @@
           <p:cNvPr id="13" name="TextBox 12">
             <a:extLst>
               <a:ext uri="{FF2B5EF4-FFF2-40B4-BE49-F238E27FC236}">
-                <a16:creationId xmlns:a16="http://schemas.microsoft.com/office/drawing/2014/main" id="{2CFCB659-9F1D-89DB-7E08-35E302F9A98F}"/>
+                <a16:creationId xmlns:a16="http://schemas.microsoft.com/office/drawing/2014/main" id="{9B2EFF73-CD9A-3908-D469-35EFA0005F5A}"/>
               </a:ext>
             </a:extLst>
           </p:cNvPr>
@@ -14006,7 +14001,7 @@
           <p:cNvPr id="14" name="Straight Connector 13">
             <a:extLst>
               <a:ext uri="{FF2B5EF4-FFF2-40B4-BE49-F238E27FC236}">
-                <a16:creationId xmlns:a16="http://schemas.microsoft.com/office/drawing/2014/main" id="{6C56ECC3-471A-16D3-C559-ED9DBEAC900E}"/>
+                <a16:creationId xmlns:a16="http://schemas.microsoft.com/office/drawing/2014/main" id="{9DC2AF2B-484F-4AA5-E5F7-E7297E13DBA5}"/>
               </a:ext>
             </a:extLst>
           </p:cNvPr>
@@ -14047,7 +14042,7 @@
           <p:cNvPr id="15" name="Oval 14">
             <a:extLst>
               <a:ext uri="{FF2B5EF4-FFF2-40B4-BE49-F238E27FC236}">
-                <a16:creationId xmlns:a16="http://schemas.microsoft.com/office/drawing/2014/main" id="{79D90112-1747-02B8-96C7-04CE30F1DCFA}"/>
+                <a16:creationId xmlns:a16="http://schemas.microsoft.com/office/drawing/2014/main" id="{72391318-A4E5-8372-1BE2-1201B2363DFD}"/>
               </a:ext>
             </a:extLst>
           </p:cNvPr>
@@ -14115,7 +14110,7 @@
           <p:cNvPr id="16" name="TextBox 15">
             <a:extLst>
               <a:ext uri="{FF2B5EF4-FFF2-40B4-BE49-F238E27FC236}">
-                <a16:creationId xmlns:a16="http://schemas.microsoft.com/office/drawing/2014/main" id="{38262E32-F9C9-6EC9-5796-1EB58C12C6C1}"/>
+                <a16:creationId xmlns:a16="http://schemas.microsoft.com/office/drawing/2014/main" id="{E5DE7D8F-2CD0-39F6-5D67-93E0B4F5F3F9}"/>
               </a:ext>
             </a:extLst>
           </p:cNvPr>
@@ -14156,7 +14151,7 @@
           <p:cNvPr id="17" name="TextBox 16">
             <a:extLst>
               <a:ext uri="{FF2B5EF4-FFF2-40B4-BE49-F238E27FC236}">
-                <a16:creationId xmlns:a16="http://schemas.microsoft.com/office/drawing/2014/main" id="{83AECEF7-66F3-59E6-03D0-1867DA2BFF93}"/>
+                <a16:creationId xmlns:a16="http://schemas.microsoft.com/office/drawing/2014/main" id="{2E523A8A-BB93-B931-0778-445D5709D018}"/>
               </a:ext>
             </a:extLst>
           </p:cNvPr>
@@ -14196,7 +14191,7 @@
           <p:cNvPr id="18" name="TextBox 17">
             <a:extLst>
               <a:ext uri="{FF2B5EF4-FFF2-40B4-BE49-F238E27FC236}">
-                <a16:creationId xmlns:a16="http://schemas.microsoft.com/office/drawing/2014/main" id="{3FA1E3C7-A3ED-290B-B341-0BE2284743E1}"/>
+                <a16:creationId xmlns:a16="http://schemas.microsoft.com/office/drawing/2014/main" id="{0A2519CA-C0AD-47BC-3009-754A9EF56748}"/>
               </a:ext>
             </a:extLst>
           </p:cNvPr>
@@ -14236,7 +14231,7 @@
           <p:cNvPr id="19" name="Straight Connector 18">
             <a:extLst>
               <a:ext uri="{FF2B5EF4-FFF2-40B4-BE49-F238E27FC236}">
-                <a16:creationId xmlns:a16="http://schemas.microsoft.com/office/drawing/2014/main" id="{1AD5F832-8A06-C830-DCE1-66F7D48D2B1B}"/>
+                <a16:creationId xmlns:a16="http://schemas.microsoft.com/office/drawing/2014/main" id="{182720FA-E3FB-A6BF-EE93-A1C5368C06AF}"/>
               </a:ext>
             </a:extLst>
           </p:cNvPr>
@@ -14277,7 +14272,7 @@
           <p:cNvPr id="20" name="Oval 19">
             <a:extLst>
               <a:ext uri="{FF2B5EF4-FFF2-40B4-BE49-F238E27FC236}">
-                <a16:creationId xmlns:a16="http://schemas.microsoft.com/office/drawing/2014/main" id="{8B38B290-C766-102B-4A7E-6E50CCD0030F}"/>
+                <a16:creationId xmlns:a16="http://schemas.microsoft.com/office/drawing/2014/main" id="{39C9D96E-EE8A-9D02-A796-71598A5D5F7A}"/>
               </a:ext>
             </a:extLst>
           </p:cNvPr>
@@ -14345,7 +14340,7 @@
           <p:cNvPr id="21" name="TextBox 20">
             <a:extLst>
               <a:ext uri="{FF2B5EF4-FFF2-40B4-BE49-F238E27FC236}">
-                <a16:creationId xmlns:a16="http://schemas.microsoft.com/office/drawing/2014/main" id="{B0BCFB02-FE0C-7FB9-D81B-5F178E4B849D}"/>
+                <a16:creationId xmlns:a16="http://schemas.microsoft.com/office/drawing/2014/main" id="{94FA13DB-4C06-5D17-C316-CD341002211F}"/>
               </a:ext>
             </a:extLst>
           </p:cNvPr>
@@ -14386,7 +14381,7 @@
           <p:cNvPr id="22" name="TextBox 21">
             <a:extLst>
               <a:ext uri="{FF2B5EF4-FFF2-40B4-BE49-F238E27FC236}">
-                <a16:creationId xmlns:a16="http://schemas.microsoft.com/office/drawing/2014/main" id="{4516EFA1-0DB0-0932-3C7F-769AEC4E200B}"/>
+                <a16:creationId xmlns:a16="http://schemas.microsoft.com/office/drawing/2014/main" id="{6C5CF320-6C07-EE31-D70E-A6EF68B59848}"/>
               </a:ext>
             </a:extLst>
           </p:cNvPr>
@@ -14426,7 +14421,7 @@
           <p:cNvPr id="23" name="TextBox 22">
             <a:extLst>
               <a:ext uri="{FF2B5EF4-FFF2-40B4-BE49-F238E27FC236}">
-                <a16:creationId xmlns:a16="http://schemas.microsoft.com/office/drawing/2014/main" id="{DD72C9FF-2B2B-57A7-ED3A-9D05581C08C3}"/>
+                <a16:creationId xmlns:a16="http://schemas.microsoft.com/office/drawing/2014/main" id="{531A6740-C036-DCEC-FA1E-325D5C9F5536}"/>
               </a:ext>
             </a:extLst>
           </p:cNvPr>
@@ -14466,7 +14461,7 @@
           <p:cNvPr id="24" name="Straight Connector 23">
             <a:extLst>
               <a:ext uri="{FF2B5EF4-FFF2-40B4-BE49-F238E27FC236}">
-                <a16:creationId xmlns:a16="http://schemas.microsoft.com/office/drawing/2014/main" id="{397C7149-72FD-2151-417A-36A15AF94607}"/>
+                <a16:creationId xmlns:a16="http://schemas.microsoft.com/office/drawing/2014/main" id="{EFFD94B4-86CD-CE89-9DA9-AF7680156C34}"/>
               </a:ext>
             </a:extLst>
           </p:cNvPr>
@@ -14507,7 +14502,7 @@
           <p:cNvPr id="25" name="Oval 24">
             <a:extLst>
               <a:ext uri="{FF2B5EF4-FFF2-40B4-BE49-F238E27FC236}">
-                <a16:creationId xmlns:a16="http://schemas.microsoft.com/office/drawing/2014/main" id="{469832E2-2428-2822-9CB4-741FC603A4CF}"/>
+                <a16:creationId xmlns:a16="http://schemas.microsoft.com/office/drawing/2014/main" id="{C6C6A98B-F4C6-3A27-5902-79533295CB9E}"/>
               </a:ext>
             </a:extLst>
           </p:cNvPr>
@@ -14575,7 +14570,7 @@
           <p:cNvPr id="26" name="TextBox 25">
             <a:extLst>
               <a:ext uri="{FF2B5EF4-FFF2-40B4-BE49-F238E27FC236}">
-                <a16:creationId xmlns:a16="http://schemas.microsoft.com/office/drawing/2014/main" id="{881DCE9B-5DC8-2113-F28B-8AA6F64939F6}"/>
+                <a16:creationId xmlns:a16="http://schemas.microsoft.com/office/drawing/2014/main" id="{0F369785-ADD0-E540-E8E8-674D2B131458}"/>
               </a:ext>
             </a:extLst>
           </p:cNvPr>
@@ -14616,7 +14611,7 @@
           <p:cNvPr id="27" name="TextBox 26">
             <a:extLst>
               <a:ext uri="{FF2B5EF4-FFF2-40B4-BE49-F238E27FC236}">
-                <a16:creationId xmlns:a16="http://schemas.microsoft.com/office/drawing/2014/main" id="{C5717595-2126-DC15-2C94-815A4DF85F13}"/>
+                <a16:creationId xmlns:a16="http://schemas.microsoft.com/office/drawing/2014/main" id="{A1C5B1D1-1D8F-7BEC-4F42-2465BB33E1CF}"/>
               </a:ext>
             </a:extLst>
           </p:cNvPr>
@@ -14656,7 +14651,7 @@
           <p:cNvPr id="28" name="TextBox 27">
             <a:extLst>
               <a:ext uri="{FF2B5EF4-FFF2-40B4-BE49-F238E27FC236}">
-                <a16:creationId xmlns:a16="http://schemas.microsoft.com/office/drawing/2014/main" id="{E1DFD967-BB42-BE96-7FC3-D2F1B9D736EE}"/>
+                <a16:creationId xmlns:a16="http://schemas.microsoft.com/office/drawing/2014/main" id="{165D99DE-4F12-3805-B3C6-E20CEA55C177}"/>
               </a:ext>
             </a:extLst>
           </p:cNvPr>
@@ -14696,7 +14691,7 @@
           <p:cNvPr id="29" name="Rectangle: Rounded Corners 28">
             <a:extLst>
               <a:ext uri="{FF2B5EF4-FFF2-40B4-BE49-F238E27FC236}">
-                <a16:creationId xmlns:a16="http://schemas.microsoft.com/office/drawing/2014/main" id="{638F248B-9BFF-56F5-7CC4-E08D303F5805}"/>
+                <a16:creationId xmlns:a16="http://schemas.microsoft.com/office/drawing/2014/main" id="{6ADF2BC5-996E-A4C5-7409-44DF003D77A4}"/>
               </a:ext>
             </a:extLst>
           </p:cNvPr>
@@ -14750,7 +14745,7 @@
           <p:cNvPr id="30" name="TextBox 29">
             <a:extLst>
               <a:ext uri="{FF2B5EF4-FFF2-40B4-BE49-F238E27FC236}">
-                <a16:creationId xmlns:a16="http://schemas.microsoft.com/office/drawing/2014/main" id="{F1BA6E82-57A5-C03D-60A9-6A92FE51926C}"/>
+                <a16:creationId xmlns:a16="http://schemas.microsoft.com/office/drawing/2014/main" id="{F6462D05-126A-DDE5-3DD9-02D00CBC7E6C}"/>
               </a:ext>
             </a:extLst>
           </p:cNvPr>
@@ -14790,7 +14785,7 @@
           <p:cNvPr id="31" name="TextBox 30">
             <a:extLst>
               <a:ext uri="{FF2B5EF4-FFF2-40B4-BE49-F238E27FC236}">
-                <a16:creationId xmlns:a16="http://schemas.microsoft.com/office/drawing/2014/main" id="{D6EB5716-1ABE-5D28-1844-5C2575F5ED61}"/>
+                <a16:creationId xmlns:a16="http://schemas.microsoft.com/office/drawing/2014/main" id="{1648140A-C089-1B9F-C132-0AF333FEF5A5}"/>
               </a:ext>
             </a:extLst>
           </p:cNvPr>
@@ -14820,13 +14815,15 @@
                 </a:solidFill>
                 <a:latin typeface="Consolas" panose="020B0609020204030204" pitchFamily="49" charset="0"/>
               </a:rPr>
-              <a:t>data/evaluation/
+              <a:t>fixproof.netlify.app
+  filter: Reflected XSS
+  open: XSS 04
+Local evidence backup:
   trial-plan.json
-ui/primary.html
-XSS attempt-03/
+  XSS attempt-03/
   candidate.patch
   result.json
-XSS attempt-04/
+  XSS attempt-04/
   candidate.patch
   result.json
   follow-up result.json</a:t>
@@ -14839,7 +14836,7 @@
           <p:cNvPr id="32" name="Rectangle: Rounded Corners 31">
             <a:extLst>
               <a:ext uri="{FF2B5EF4-FFF2-40B4-BE49-F238E27FC236}">
-                <a16:creationId xmlns:a16="http://schemas.microsoft.com/office/drawing/2014/main" id="{5B6478E2-3015-1CE2-FF45-3A65646DAFFE}"/>
+                <a16:creationId xmlns:a16="http://schemas.microsoft.com/office/drawing/2014/main" id="{2D333A92-32D9-8166-B2F9-43B4B4316EAE}"/>
               </a:ext>
             </a:extLst>
           </p:cNvPr>
@@ -14893,7 +14890,7 @@
           <p:cNvPr id="33" name="TextBox 32">
             <a:extLst>
               <a:ext uri="{FF2B5EF4-FFF2-40B4-BE49-F238E27FC236}">
-                <a16:creationId xmlns:a16="http://schemas.microsoft.com/office/drawing/2014/main" id="{E9508ED0-8F62-C81B-3C1E-EF3EE0CCDB9E}"/>
+                <a16:creationId xmlns:a16="http://schemas.microsoft.com/office/drawing/2014/main" id="{1CF4C865-BC2A-D525-9480-01C20DE1C908}"/>
               </a:ext>
             </a:extLst>
           </p:cNvPr>
@@ -14924,7 +14921,7 @@
                 </a:solidFill>
                 <a:latin typeface="Aptos" panose="020B0004020202020204" pitchFamily="34" charset="0"/>
               </a:rPr>
-              <a:t>Label the dashboard and JSON as saved evidence. Verification checks bindings; it does not replay historical model calls.</a:t>
+              <a:t>The public site is a sanitized view of saved evidence; it does not replay historical model calls or tests.</a:t>
             </a:r>
           </a:p>
         </p:txBody>
@@ -14934,7 +14931,7 @@
           <p:cNvPr id="34" name="TextBox 33">
             <a:extLst>
               <a:ext uri="{FF2B5EF4-FFF2-40B4-BE49-F238E27FC236}">
-                <a16:creationId xmlns:a16="http://schemas.microsoft.com/office/drawing/2014/main" id="{BF9E4844-91D0-4184-5C66-FB8A2E94DE53}"/>
+                <a16:creationId xmlns:a16="http://schemas.microsoft.com/office/drawing/2014/main" id="{97134E6B-2635-3B50-BD68-3AE1A1DDFCC1}"/>
               </a:ext>
             </a:extLst>
           </p:cNvPr>
@@ -14974,7 +14971,7 @@
           <p:cNvPr id="35" name="TextBox 34">
             <a:extLst>
               <a:ext uri="{FF2B5EF4-FFF2-40B4-BE49-F238E27FC236}">
-                <a16:creationId xmlns:a16="http://schemas.microsoft.com/office/drawing/2014/main" id="{EB842F41-3DEA-3C33-AC9F-946CC9455BBA}"/>
+                <a16:creationId xmlns:a16="http://schemas.microsoft.com/office/drawing/2014/main" id="{33EDA605-5B36-929C-A1B2-D40204056F53}"/>
               </a:ext>
             </a:extLst>
           </p:cNvPr>
@@ -15013,7 +15010,7 @@
     </p:spTree>
     <p:extLst>
       <p:ext uri="{BB962C8B-B14F-4D97-AF65-F5344CB8AC3E}">
-        <p14:creationId xmlns:p14="http://schemas.microsoft.com/office/powerpoint/2010/main" val="4147360398"/>
+        <p14:creationId xmlns:p14="http://schemas.microsoft.com/office/powerpoint/2010/main" val="4076325013"/>
       </p:ext>
     </p:extLst>
   </p:cSld>
@@ -15053,7 +15050,7 @@
           <p:cNvPr id="2" name="TextBox 1">
             <a:extLst>
               <a:ext uri="{FF2B5EF4-FFF2-40B4-BE49-F238E27FC236}">
-                <a16:creationId xmlns:a16="http://schemas.microsoft.com/office/drawing/2014/main" id="{988B24EE-2791-3F38-A105-99863359E430}"/>
+                <a16:creationId xmlns:a16="http://schemas.microsoft.com/office/drawing/2014/main" id="{2DE44F46-6812-5978-409E-C6843908B4DA}"/>
               </a:ext>
             </a:extLst>
           </p:cNvPr>
@@ -15093,7 +15090,7 @@
           <p:cNvPr id="3" name="TextBox 2">
             <a:extLst>
               <a:ext uri="{FF2B5EF4-FFF2-40B4-BE49-F238E27FC236}">
-                <a16:creationId xmlns:a16="http://schemas.microsoft.com/office/drawing/2014/main" id="{E791BEC4-9482-9D31-FE4D-32099963E95D}"/>
+                <a16:creationId xmlns:a16="http://schemas.microsoft.com/office/drawing/2014/main" id="{7F19174E-6812-EB06-2A4A-95F619DCE870}"/>
               </a:ext>
             </a:extLst>
           </p:cNvPr>
@@ -15133,7 +15130,7 @@
           <p:cNvPr id="4" name="Straight Connector 3">
             <a:extLst>
               <a:ext uri="{FF2B5EF4-FFF2-40B4-BE49-F238E27FC236}">
-                <a16:creationId xmlns:a16="http://schemas.microsoft.com/office/drawing/2014/main" id="{9B850F67-7215-80EB-FDD9-A4920BB7F2C9}"/>
+                <a16:creationId xmlns:a16="http://schemas.microsoft.com/office/drawing/2014/main" id="{23862881-C16B-7E9B-1323-9E6C4C36E08C}"/>
               </a:ext>
             </a:extLst>
           </p:cNvPr>
@@ -15174,7 +15171,7 @@
           <p:cNvPr id="5" name="Rectangle: Rounded Corners 4">
             <a:extLst>
               <a:ext uri="{FF2B5EF4-FFF2-40B4-BE49-F238E27FC236}">
-                <a16:creationId xmlns:a16="http://schemas.microsoft.com/office/drawing/2014/main" id="{233418B6-0825-7F8F-7341-2C58A2011A99}"/>
+                <a16:creationId xmlns:a16="http://schemas.microsoft.com/office/drawing/2014/main" id="{1ABD6518-4951-C6AF-F182-5F12D5BB9194}"/>
               </a:ext>
             </a:extLst>
           </p:cNvPr>
@@ -15228,7 +15225,7 @@
           <p:cNvPr id="6" name="Rectangle: Rounded Corners 5">
             <a:extLst>
               <a:ext uri="{FF2B5EF4-FFF2-40B4-BE49-F238E27FC236}">
-                <a16:creationId xmlns:a16="http://schemas.microsoft.com/office/drawing/2014/main" id="{B2E58AEB-D41C-343B-5F80-9EB24025B19D}"/>
+                <a16:creationId xmlns:a16="http://schemas.microsoft.com/office/drawing/2014/main" id="{09354208-0F26-E836-BA07-6436594A58FB}"/>
               </a:ext>
             </a:extLst>
           </p:cNvPr>
@@ -15282,7 +15279,7 @@
           <p:cNvPr id="7" name="TextBox 6">
             <a:extLst>
               <a:ext uri="{FF2B5EF4-FFF2-40B4-BE49-F238E27FC236}">
-                <a16:creationId xmlns:a16="http://schemas.microsoft.com/office/drawing/2014/main" id="{D11A0594-98CA-FC1F-F4AD-51E70145632A}"/>
+                <a16:creationId xmlns:a16="http://schemas.microsoft.com/office/drawing/2014/main" id="{E0A17E0C-CB0E-84C8-FD84-5E4B7AD5AECE}"/>
               </a:ext>
             </a:extLst>
           </p:cNvPr>
@@ -15323,7 +15320,7 @@
           <p:cNvPr id="8" name="TextBox 7">
             <a:extLst>
               <a:ext uri="{FF2B5EF4-FFF2-40B4-BE49-F238E27FC236}">
-                <a16:creationId xmlns:a16="http://schemas.microsoft.com/office/drawing/2014/main" id="{4EF9DBC3-93C0-48ED-EE00-46205C7412F6}"/>
+                <a16:creationId xmlns:a16="http://schemas.microsoft.com/office/drawing/2014/main" id="{ECF68079-20DB-A871-1FBB-80F35E14FCFD}"/>
               </a:ext>
             </a:extLst>
           </p:cNvPr>
@@ -15363,7 +15360,7 @@
           <p:cNvPr id="9" name="Rectangle: Rounded Corners 8">
             <a:extLst>
               <a:ext uri="{FF2B5EF4-FFF2-40B4-BE49-F238E27FC236}">
-                <a16:creationId xmlns:a16="http://schemas.microsoft.com/office/drawing/2014/main" id="{D0185DEC-3AD7-67B3-96AC-EE96A1240737}"/>
+                <a16:creationId xmlns:a16="http://schemas.microsoft.com/office/drawing/2014/main" id="{14A5B9F5-5846-B8EF-72D3-7C9745403D23}"/>
               </a:ext>
             </a:extLst>
           </p:cNvPr>
@@ -15417,7 +15414,7 @@
           <p:cNvPr id="10" name="TextBox 9">
             <a:extLst>
               <a:ext uri="{FF2B5EF4-FFF2-40B4-BE49-F238E27FC236}">
-                <a16:creationId xmlns:a16="http://schemas.microsoft.com/office/drawing/2014/main" id="{F1AFA480-2847-55D5-8EC1-300F93067807}"/>
+                <a16:creationId xmlns:a16="http://schemas.microsoft.com/office/drawing/2014/main" id="{90BA0E7F-2DEF-E49C-386A-B9349837B6B9}"/>
               </a:ext>
             </a:extLst>
           </p:cNvPr>
@@ -15457,7 +15454,7 @@
           <p:cNvPr id="11" name="TextBox 10">
             <a:extLst>
               <a:ext uri="{FF2B5EF4-FFF2-40B4-BE49-F238E27FC236}">
-                <a16:creationId xmlns:a16="http://schemas.microsoft.com/office/drawing/2014/main" id="{E35D4237-2FDE-B7D6-E50D-F9494774082A}"/>
+                <a16:creationId xmlns:a16="http://schemas.microsoft.com/office/drawing/2014/main" id="{01941454-0224-ECCA-FAD3-9D7BC52CE5E2}"/>
               </a:ext>
             </a:extLst>
           </p:cNvPr>
@@ -15497,7 +15494,7 @@
           <p:cNvPr id="12" name="Rectangle: Rounded Corners 11">
             <a:extLst>
               <a:ext uri="{FF2B5EF4-FFF2-40B4-BE49-F238E27FC236}">
-                <a16:creationId xmlns:a16="http://schemas.microsoft.com/office/drawing/2014/main" id="{38998626-7834-4A42-FC1C-E0A129038CCF}"/>
+                <a16:creationId xmlns:a16="http://schemas.microsoft.com/office/drawing/2014/main" id="{92DE9AC8-52EA-01B9-8083-6E6FEC5A6564}"/>
               </a:ext>
             </a:extLst>
           </p:cNvPr>
@@ -15551,7 +15548,7 @@
           <p:cNvPr id="13" name="TextBox 12">
             <a:extLst>
               <a:ext uri="{FF2B5EF4-FFF2-40B4-BE49-F238E27FC236}">
-                <a16:creationId xmlns:a16="http://schemas.microsoft.com/office/drawing/2014/main" id="{FC5F8BDC-6695-CBF5-BA67-FB7582FEA54B}"/>
+                <a16:creationId xmlns:a16="http://schemas.microsoft.com/office/drawing/2014/main" id="{4B67D6D0-BBD1-4CE8-6B07-D2A46003EA2C}"/>
               </a:ext>
             </a:extLst>
           </p:cNvPr>
@@ -15592,7 +15589,7 @@
           <p:cNvPr id="14" name="TextBox 13">
             <a:extLst>
               <a:ext uri="{FF2B5EF4-FFF2-40B4-BE49-F238E27FC236}">
-                <a16:creationId xmlns:a16="http://schemas.microsoft.com/office/drawing/2014/main" id="{9FBAC6E5-0232-ACAE-7026-14FAD940876C}"/>
+                <a16:creationId xmlns:a16="http://schemas.microsoft.com/office/drawing/2014/main" id="{FADA716C-6023-921B-CA5C-0897DDE5DE01}"/>
               </a:ext>
             </a:extLst>
           </p:cNvPr>
@@ -15639,7 +15636,7 @@
           <p:cNvPr id="15" name="Rectangle: Rounded Corners 14">
             <a:extLst>
               <a:ext uri="{FF2B5EF4-FFF2-40B4-BE49-F238E27FC236}">
-                <a16:creationId xmlns:a16="http://schemas.microsoft.com/office/drawing/2014/main" id="{AAA9BC68-4CD1-94C9-25AF-272756E80CC1}"/>
+                <a16:creationId xmlns:a16="http://schemas.microsoft.com/office/drawing/2014/main" id="{678C61F5-E49F-EB0E-97AC-7EFACBDEE208}"/>
               </a:ext>
             </a:extLst>
           </p:cNvPr>
@@ -15693,7 +15690,7 @@
           <p:cNvPr id="16" name="Rectangle: Rounded Corners 15">
             <a:extLst>
               <a:ext uri="{FF2B5EF4-FFF2-40B4-BE49-F238E27FC236}">
-                <a16:creationId xmlns:a16="http://schemas.microsoft.com/office/drawing/2014/main" id="{416CAA92-3339-E063-490C-53B554C74167}"/>
+                <a16:creationId xmlns:a16="http://schemas.microsoft.com/office/drawing/2014/main" id="{DB246DF8-02E5-C49D-1C95-A40D5981C722}"/>
               </a:ext>
             </a:extLst>
           </p:cNvPr>
@@ -15747,7 +15744,7 @@
           <p:cNvPr id="17" name="TextBox 16">
             <a:extLst>
               <a:ext uri="{FF2B5EF4-FFF2-40B4-BE49-F238E27FC236}">
-                <a16:creationId xmlns:a16="http://schemas.microsoft.com/office/drawing/2014/main" id="{1A5B535B-6D1F-1D2F-FD92-A0490FD81DA5}"/>
+                <a16:creationId xmlns:a16="http://schemas.microsoft.com/office/drawing/2014/main" id="{1887A6F8-2153-B81D-8F59-F94D477A6E0F}"/>
               </a:ext>
             </a:extLst>
           </p:cNvPr>
@@ -15788,7 +15785,7 @@
           <p:cNvPr id="18" name="TextBox 17">
             <a:extLst>
               <a:ext uri="{FF2B5EF4-FFF2-40B4-BE49-F238E27FC236}">
-                <a16:creationId xmlns:a16="http://schemas.microsoft.com/office/drawing/2014/main" id="{F2E2D546-BD1D-224B-57E4-ECF7425E9647}"/>
+                <a16:creationId xmlns:a16="http://schemas.microsoft.com/office/drawing/2014/main" id="{B89964AA-BA84-4584-A6CC-F2D17586AB61}"/>
               </a:ext>
             </a:extLst>
           </p:cNvPr>
@@ -15828,7 +15825,7 @@
           <p:cNvPr id="19" name="Rectangle: Rounded Corners 18">
             <a:extLst>
               <a:ext uri="{FF2B5EF4-FFF2-40B4-BE49-F238E27FC236}">
-                <a16:creationId xmlns:a16="http://schemas.microsoft.com/office/drawing/2014/main" id="{066E5532-D010-43FC-1F8A-2C250C781CBA}"/>
+                <a16:creationId xmlns:a16="http://schemas.microsoft.com/office/drawing/2014/main" id="{BD484570-DC39-3669-A55E-AEE93BD8194D}"/>
               </a:ext>
             </a:extLst>
           </p:cNvPr>
@@ -15882,7 +15879,7 @@
           <p:cNvPr id="20" name="TextBox 19">
             <a:extLst>
               <a:ext uri="{FF2B5EF4-FFF2-40B4-BE49-F238E27FC236}">
-                <a16:creationId xmlns:a16="http://schemas.microsoft.com/office/drawing/2014/main" id="{155CAAAD-E450-5237-A977-65D2B26D5B2C}"/>
+                <a16:creationId xmlns:a16="http://schemas.microsoft.com/office/drawing/2014/main" id="{FDCF96DF-5288-F57F-02F8-7F6E57BFA540}"/>
               </a:ext>
             </a:extLst>
           </p:cNvPr>
@@ -15922,7 +15919,7 @@
           <p:cNvPr id="21" name="TextBox 20">
             <a:extLst>
               <a:ext uri="{FF2B5EF4-FFF2-40B4-BE49-F238E27FC236}">
-                <a16:creationId xmlns:a16="http://schemas.microsoft.com/office/drawing/2014/main" id="{17A702C1-2BB7-4E05-8510-EB4376A719BC}"/>
+                <a16:creationId xmlns:a16="http://schemas.microsoft.com/office/drawing/2014/main" id="{8AA031F0-29DD-8D60-0B63-360E200EE49A}"/>
               </a:ext>
             </a:extLst>
           </p:cNvPr>
@@ -15962,7 +15959,7 @@
           <p:cNvPr id="22" name="Rectangle: Rounded Corners 21">
             <a:extLst>
               <a:ext uri="{FF2B5EF4-FFF2-40B4-BE49-F238E27FC236}">
-                <a16:creationId xmlns:a16="http://schemas.microsoft.com/office/drawing/2014/main" id="{A5B458E2-579F-D666-F607-1B8C2B10EBAB}"/>
+                <a16:creationId xmlns:a16="http://schemas.microsoft.com/office/drawing/2014/main" id="{5B0A7B2F-F78D-5C13-B506-C60EE4B47E6F}"/>
               </a:ext>
             </a:extLst>
           </p:cNvPr>
@@ -16016,7 +16013,7 @@
           <p:cNvPr id="23" name="TextBox 22">
             <a:extLst>
               <a:ext uri="{FF2B5EF4-FFF2-40B4-BE49-F238E27FC236}">
-                <a16:creationId xmlns:a16="http://schemas.microsoft.com/office/drawing/2014/main" id="{EE52B086-E346-C338-90C0-CB3DCF547AF4}"/>
+                <a16:creationId xmlns:a16="http://schemas.microsoft.com/office/drawing/2014/main" id="{5FD604C9-CA79-CB53-4370-79E604821166}"/>
               </a:ext>
             </a:extLst>
           </p:cNvPr>
@@ -16057,7 +16054,7 @@
           <p:cNvPr id="24" name="TextBox 23">
             <a:extLst>
               <a:ext uri="{FF2B5EF4-FFF2-40B4-BE49-F238E27FC236}">
-                <a16:creationId xmlns:a16="http://schemas.microsoft.com/office/drawing/2014/main" id="{5579C246-B43B-C044-F7F5-B67D878D36FD}"/>
+                <a16:creationId xmlns:a16="http://schemas.microsoft.com/office/drawing/2014/main" id="{018FB34B-A495-763B-0225-F9041BFF753E}"/>
               </a:ext>
             </a:extLst>
           </p:cNvPr>
@@ -16104,7 +16101,7 @@
           <p:cNvPr id="25" name="Rectangle: Rounded Corners 24">
             <a:extLst>
               <a:ext uri="{FF2B5EF4-FFF2-40B4-BE49-F238E27FC236}">
-                <a16:creationId xmlns:a16="http://schemas.microsoft.com/office/drawing/2014/main" id="{A2807E69-F334-B7C8-D612-F6D8A142A541}"/>
+                <a16:creationId xmlns:a16="http://schemas.microsoft.com/office/drawing/2014/main" id="{B71E1C48-C489-EA9E-EB34-39E3F5794F40}"/>
               </a:ext>
             </a:extLst>
           </p:cNvPr>
@@ -16158,7 +16155,7 @@
           <p:cNvPr id="26" name="TextBox 25">
             <a:extLst>
               <a:ext uri="{FF2B5EF4-FFF2-40B4-BE49-F238E27FC236}">
-                <a16:creationId xmlns:a16="http://schemas.microsoft.com/office/drawing/2014/main" id="{B5C348E8-D455-DCBD-6951-6C4828896A3E}"/>
+                <a16:creationId xmlns:a16="http://schemas.microsoft.com/office/drawing/2014/main" id="{7924FFC2-685A-6ECC-704C-3B054C2026BA}"/>
               </a:ext>
             </a:extLst>
           </p:cNvPr>
@@ -16199,7 +16196,7 @@
           <p:cNvPr id="27" name="TextBox 26">
             <a:extLst>
               <a:ext uri="{FF2B5EF4-FFF2-40B4-BE49-F238E27FC236}">
-                <a16:creationId xmlns:a16="http://schemas.microsoft.com/office/drawing/2014/main" id="{653413CF-06E7-77E2-C47F-02FE7ED4AB98}"/>
+                <a16:creationId xmlns:a16="http://schemas.microsoft.com/office/drawing/2014/main" id="{45A66605-B237-1E01-B4B6-C4B448F572F9}"/>
               </a:ext>
             </a:extLst>
           </p:cNvPr>
@@ -16239,7 +16236,7 @@
           <p:cNvPr id="28" name="TextBox 27">
             <a:extLst>
               <a:ext uri="{FF2B5EF4-FFF2-40B4-BE49-F238E27FC236}">
-                <a16:creationId xmlns:a16="http://schemas.microsoft.com/office/drawing/2014/main" id="{7880274A-9048-4ED4-311F-47EDBC93D278}"/>
+                <a16:creationId xmlns:a16="http://schemas.microsoft.com/office/drawing/2014/main" id="{AF834B38-E052-F9A5-A105-6C827945BDEE}"/>
               </a:ext>
             </a:extLst>
           </p:cNvPr>
@@ -16278,7 +16275,7 @@
     </p:spTree>
     <p:extLst>
       <p:ext uri="{BB962C8B-B14F-4D97-AF65-F5344CB8AC3E}">
-        <p14:creationId xmlns:p14="http://schemas.microsoft.com/office/powerpoint/2010/main" val="1383716307"/>
+        <p14:creationId xmlns:p14="http://schemas.microsoft.com/office/powerpoint/2010/main" val="1867589040"/>
       </p:ext>
     </p:extLst>
   </p:cSld>
@@ -16318,7 +16315,7 @@
           <p:cNvPr id="2" name="TextBox 1">
             <a:extLst>
               <a:ext uri="{FF2B5EF4-FFF2-40B4-BE49-F238E27FC236}">
-                <a16:creationId xmlns:a16="http://schemas.microsoft.com/office/drawing/2014/main" id="{C5AA25CA-5C9D-76A0-FCB5-64C4C8428C29}"/>
+                <a16:creationId xmlns:a16="http://schemas.microsoft.com/office/drawing/2014/main" id="{220A4615-792E-5EAA-BFCF-70CBF3751104}"/>
               </a:ext>
             </a:extLst>
           </p:cNvPr>
@@ -16348,7 +16345,7 @@
                 </a:solidFill>
                 <a:latin typeface="Aptos" panose="020B0004020202020204" pitchFamily="34" charset="0"/>
               </a:rPr>
-              <a:t>6. Human judgment, limits, and next steps</a:t>
+              <a:t>6. Human judgment and next steps</a:t>
             </a:r>
           </a:p>
         </p:txBody>
@@ -16358,7 +16355,7 @@
           <p:cNvPr id="3" name="TextBox 2">
             <a:extLst>
               <a:ext uri="{FF2B5EF4-FFF2-40B4-BE49-F238E27FC236}">
-                <a16:creationId xmlns:a16="http://schemas.microsoft.com/office/drawing/2014/main" id="{A6F542A0-FA62-F5A2-D17D-3FE7775463BB}"/>
+                <a16:creationId xmlns:a16="http://schemas.microsoft.com/office/drawing/2014/main" id="{FCB1E421-E7F4-B2E5-AA86-1AACBEEE8CEB}"/>
               </a:ext>
             </a:extLst>
           </p:cNvPr>
@@ -16398,7 +16395,7 @@
           <p:cNvPr id="4" name="Straight Connector 3">
             <a:extLst>
               <a:ext uri="{FF2B5EF4-FFF2-40B4-BE49-F238E27FC236}">
-                <a16:creationId xmlns:a16="http://schemas.microsoft.com/office/drawing/2014/main" id="{C03D269C-7512-1F3D-5D96-3D2954E3C86F}"/>
+                <a16:creationId xmlns:a16="http://schemas.microsoft.com/office/drawing/2014/main" id="{A7AB8B59-C096-F75C-4630-7BC63260183F}"/>
               </a:ext>
             </a:extLst>
           </p:cNvPr>
@@ -16439,7 +16436,7 @@
           <p:cNvPr id="5" name="Rectangle: Rounded Corners 4">
             <a:extLst>
               <a:ext uri="{FF2B5EF4-FFF2-40B4-BE49-F238E27FC236}">
-                <a16:creationId xmlns:a16="http://schemas.microsoft.com/office/drawing/2014/main" id="{2F75D197-4CE2-DE1A-2E47-07A1EBBA0FFA}"/>
+                <a16:creationId xmlns:a16="http://schemas.microsoft.com/office/drawing/2014/main" id="{EE0585A1-649B-9928-6236-E5EE34938775}"/>
               </a:ext>
             </a:extLst>
           </p:cNvPr>
@@ -16493,7 +16490,7 @@
           <p:cNvPr id="6" name="TextBox 5">
             <a:extLst>
               <a:ext uri="{FF2B5EF4-FFF2-40B4-BE49-F238E27FC236}">
-                <a16:creationId xmlns:a16="http://schemas.microsoft.com/office/drawing/2014/main" id="{C9DFDCC5-D60C-3BCE-24ED-38043819F6A0}"/>
+                <a16:creationId xmlns:a16="http://schemas.microsoft.com/office/drawing/2014/main" id="{3BFC66AE-A4ED-566C-F2FC-C7D1AD2D097F}"/>
               </a:ext>
             </a:extLst>
           </p:cNvPr>
@@ -16534,7 +16531,7 @@
           <p:cNvPr id="7" name="TextBox 6">
             <a:extLst>
               <a:ext uri="{FF2B5EF4-FFF2-40B4-BE49-F238E27FC236}">
-                <a16:creationId xmlns:a16="http://schemas.microsoft.com/office/drawing/2014/main" id="{D3440003-0D4E-364A-FD9C-C4AB300D3B1E}"/>
+                <a16:creationId xmlns:a16="http://schemas.microsoft.com/office/drawing/2014/main" id="{E4066CB1-77F5-B8D2-E6F1-5EAF3CBF0181}"/>
               </a:ext>
             </a:extLst>
           </p:cNvPr>
@@ -16575,7 +16572,7 @@
           <p:cNvPr id="8" name="Rectangle: Rounded Corners 7">
             <a:extLst>
               <a:ext uri="{FF2B5EF4-FFF2-40B4-BE49-F238E27FC236}">
-                <a16:creationId xmlns:a16="http://schemas.microsoft.com/office/drawing/2014/main" id="{45B64E4B-5727-7265-943C-EEF1B4D41B2E}"/>
+                <a16:creationId xmlns:a16="http://schemas.microsoft.com/office/drawing/2014/main" id="{5E04F8C9-A534-B1A5-F249-C879D9E76510}"/>
               </a:ext>
             </a:extLst>
           </p:cNvPr>
@@ -16629,7 +16626,7 @@
           <p:cNvPr id="9" name="TextBox 8">
             <a:extLst>
               <a:ext uri="{FF2B5EF4-FFF2-40B4-BE49-F238E27FC236}">
-                <a16:creationId xmlns:a16="http://schemas.microsoft.com/office/drawing/2014/main" id="{B2F42D69-834E-2740-19DA-4C528F51129B}"/>
+                <a16:creationId xmlns:a16="http://schemas.microsoft.com/office/drawing/2014/main" id="{6E3917ED-DE4B-912D-25E6-40063AE6D320}"/>
               </a:ext>
             </a:extLst>
           </p:cNvPr>
@@ -16670,7 +16667,7 @@
           <p:cNvPr id="10" name="TextBox 9">
             <a:extLst>
               <a:ext uri="{FF2B5EF4-FFF2-40B4-BE49-F238E27FC236}">
-                <a16:creationId xmlns:a16="http://schemas.microsoft.com/office/drawing/2014/main" id="{6F62BC8E-C36F-D69C-5F25-FE35518B988C}"/>
+                <a16:creationId xmlns:a16="http://schemas.microsoft.com/office/drawing/2014/main" id="{AE142D71-2F14-B51B-CB2A-375AD22BA873}"/>
               </a:ext>
             </a:extLst>
           </p:cNvPr>
@@ -16711,7 +16708,7 @@
           <p:cNvPr id="11" name="Rectangle: Rounded Corners 10">
             <a:extLst>
               <a:ext uri="{FF2B5EF4-FFF2-40B4-BE49-F238E27FC236}">
-                <a16:creationId xmlns:a16="http://schemas.microsoft.com/office/drawing/2014/main" id="{7DE82BF7-8299-3D42-6279-262AB85CF258}"/>
+                <a16:creationId xmlns:a16="http://schemas.microsoft.com/office/drawing/2014/main" id="{C2E41D15-3885-5E3A-0248-41291DFA8A12}"/>
               </a:ext>
             </a:extLst>
           </p:cNvPr>
@@ -16765,7 +16762,7 @@
           <p:cNvPr id="12" name="TextBox 11">
             <a:extLst>
               <a:ext uri="{FF2B5EF4-FFF2-40B4-BE49-F238E27FC236}">
-                <a16:creationId xmlns:a16="http://schemas.microsoft.com/office/drawing/2014/main" id="{6BAA221B-DA28-7EA4-62CA-0CCC01B9B1EC}"/>
+                <a16:creationId xmlns:a16="http://schemas.microsoft.com/office/drawing/2014/main" id="{F331D14C-9002-DFD0-FCB8-2DBE08FFAD51}"/>
               </a:ext>
             </a:extLst>
           </p:cNvPr>
@@ -16806,7 +16803,7 @@
           <p:cNvPr id="13" name="TextBox 12">
             <a:extLst>
               <a:ext uri="{FF2B5EF4-FFF2-40B4-BE49-F238E27FC236}">
-                <a16:creationId xmlns:a16="http://schemas.microsoft.com/office/drawing/2014/main" id="{A0AA87B3-D074-33B1-1F05-D4E6667FCF00}"/>
+                <a16:creationId xmlns:a16="http://schemas.microsoft.com/office/drawing/2014/main" id="{AC588AE3-E569-65A5-4544-CA54630348A3}"/>
               </a:ext>
             </a:extLst>
           </p:cNvPr>
@@ -16847,7 +16844,7 @@
           <p:cNvPr id="14" name="Rectangle: Rounded Corners 13">
             <a:extLst>
               <a:ext uri="{FF2B5EF4-FFF2-40B4-BE49-F238E27FC236}">
-                <a16:creationId xmlns:a16="http://schemas.microsoft.com/office/drawing/2014/main" id="{5DBD53E0-EAEB-64BC-9513-413D2D7E5CA5}"/>
+                <a16:creationId xmlns:a16="http://schemas.microsoft.com/office/drawing/2014/main" id="{6AC4FD38-D491-2264-2BE1-842AF66665B1}"/>
               </a:ext>
             </a:extLst>
           </p:cNvPr>
@@ -16901,7 +16898,7 @@
           <p:cNvPr id="15" name="TextBox 14">
             <a:extLst>
               <a:ext uri="{FF2B5EF4-FFF2-40B4-BE49-F238E27FC236}">
-                <a16:creationId xmlns:a16="http://schemas.microsoft.com/office/drawing/2014/main" id="{7A1EC730-9118-BF00-A00A-05E145C4164D}"/>
+                <a16:creationId xmlns:a16="http://schemas.microsoft.com/office/drawing/2014/main" id="{DA776E51-2DF0-08DC-6534-6F67B25BA247}"/>
               </a:ext>
             </a:extLst>
           </p:cNvPr>
@@ -16941,7 +16938,7 @@
           <p:cNvPr id="16" name="TextBox 15">
             <a:extLst>
               <a:ext uri="{FF2B5EF4-FFF2-40B4-BE49-F238E27FC236}">
-                <a16:creationId xmlns:a16="http://schemas.microsoft.com/office/drawing/2014/main" id="{CEE29B16-37B0-BB70-3FB0-B9D2485DCC67}"/>
+                <a16:creationId xmlns:a16="http://schemas.microsoft.com/office/drawing/2014/main" id="{1397E3B7-8337-3458-FDBA-2BE6B84477A2}"/>
               </a:ext>
             </a:extLst>
           </p:cNvPr>
@@ -16985,7 +16982,7 @@
           <p:cNvPr id="17" name="Rectangle: Rounded Corners 16">
             <a:extLst>
               <a:ext uri="{FF2B5EF4-FFF2-40B4-BE49-F238E27FC236}">
-                <a16:creationId xmlns:a16="http://schemas.microsoft.com/office/drawing/2014/main" id="{B89F8C3A-20C6-164B-00BC-C844DB82C708}"/>
+                <a16:creationId xmlns:a16="http://schemas.microsoft.com/office/drawing/2014/main" id="{C2F9B139-BE7E-9CA7-9950-DA84806B5FFF}"/>
               </a:ext>
             </a:extLst>
           </p:cNvPr>
@@ -17039,7 +17036,7 @@
           <p:cNvPr id="18" name="TextBox 17">
             <a:extLst>
               <a:ext uri="{FF2B5EF4-FFF2-40B4-BE49-F238E27FC236}">
-                <a16:creationId xmlns:a16="http://schemas.microsoft.com/office/drawing/2014/main" id="{753009EB-1AE5-C918-F260-A753B8F988EC}"/>
+                <a16:creationId xmlns:a16="http://schemas.microsoft.com/office/drawing/2014/main" id="{C5A975F3-F673-BA52-9226-AAEBF568630C}"/>
               </a:ext>
             </a:extLst>
           </p:cNvPr>
@@ -17079,7 +17076,7 @@
           <p:cNvPr id="19" name="TextBox 18">
             <a:extLst>
               <a:ext uri="{FF2B5EF4-FFF2-40B4-BE49-F238E27FC236}">
-                <a16:creationId xmlns:a16="http://schemas.microsoft.com/office/drawing/2014/main" id="{FFE19B94-FA50-134D-34AC-BBA3775DB68A}"/>
+                <a16:creationId xmlns:a16="http://schemas.microsoft.com/office/drawing/2014/main" id="{70479A0D-8A9C-9B0D-47D8-B4DA23C4C593}"/>
               </a:ext>
             </a:extLst>
           </p:cNvPr>
@@ -17123,7 +17120,7 @@
           <p:cNvPr id="20" name="Rectangle: Rounded Corners 19">
             <a:extLst>
               <a:ext uri="{FF2B5EF4-FFF2-40B4-BE49-F238E27FC236}">
-                <a16:creationId xmlns:a16="http://schemas.microsoft.com/office/drawing/2014/main" id="{80F93CA3-33B1-AA91-9DE7-075AF50F294B}"/>
+                <a16:creationId xmlns:a16="http://schemas.microsoft.com/office/drawing/2014/main" id="{7AEB7A4E-4E7A-8412-BC11-3290F9806255}"/>
               </a:ext>
             </a:extLst>
           </p:cNvPr>
@@ -17177,7 +17174,7 @@
           <p:cNvPr id="21" name="TextBox 20">
             <a:extLst>
               <a:ext uri="{FF2B5EF4-FFF2-40B4-BE49-F238E27FC236}">
-                <a16:creationId xmlns:a16="http://schemas.microsoft.com/office/drawing/2014/main" id="{56B24263-EC0F-517A-976C-76DFF032B69D}"/>
+                <a16:creationId xmlns:a16="http://schemas.microsoft.com/office/drawing/2014/main" id="{F48A9661-EA9B-AC1B-892A-2E6C7392D465}"/>
               </a:ext>
             </a:extLst>
           </p:cNvPr>
@@ -17208,7 +17205,7 @@
                 </a:solidFill>
                 <a:latin typeface="Aptos" panose="020B0004020202020204" pitchFamily="34" charset="0"/>
               </a:rPr>
-              <a:t>Feedback: Would a second reviewer improve confidence more than adding another CWE - or should I prioritize a symlink-capable rerun?</a:t>
+              <a:t>Student reference: fixproof.netlify.app | Feedback: prioritize a second reviewer or a symlink-capable rerun?</a:t>
             </a:r>
           </a:p>
         </p:txBody>
@@ -17218,7 +17215,7 @@
           <p:cNvPr id="22" name="TextBox 21">
             <a:extLst>
               <a:ext uri="{FF2B5EF4-FFF2-40B4-BE49-F238E27FC236}">
-                <a16:creationId xmlns:a16="http://schemas.microsoft.com/office/drawing/2014/main" id="{27BED32F-E570-4842-2A99-7E5ACA2823A9}"/>
+                <a16:creationId xmlns:a16="http://schemas.microsoft.com/office/drawing/2014/main" id="{B19F17B2-D2C4-A10F-5AA3-488EE83A03D7}"/>
               </a:ext>
             </a:extLst>
           </p:cNvPr>
@@ -17258,7 +17255,7 @@
           <p:cNvPr id="23" name="TextBox 22">
             <a:extLst>
               <a:ext uri="{FF2B5EF4-FFF2-40B4-BE49-F238E27FC236}">
-                <a16:creationId xmlns:a16="http://schemas.microsoft.com/office/drawing/2014/main" id="{E1EC52B5-A274-AEF5-4EED-107ED95D5032}"/>
+                <a16:creationId xmlns:a16="http://schemas.microsoft.com/office/drawing/2014/main" id="{58A57BB1-44C1-61EA-F162-1AED0A69478E}"/>
               </a:ext>
             </a:extLst>
           </p:cNvPr>
@@ -17297,7 +17294,7 @@
     </p:spTree>
     <p:extLst>
       <p:ext uri="{BB962C8B-B14F-4D97-AF65-F5344CB8AC3E}">
-        <p14:creationId xmlns:p14="http://schemas.microsoft.com/office/powerpoint/2010/main" val="183979270"/>
+        <p14:creationId xmlns:p14="http://schemas.microsoft.com/office/powerpoint/2010/main" val="4029264865"/>
       </p:ext>
     </p:extLst>
   </p:cSld>
@@ -17337,7 +17334,7 @@
           <p:cNvPr id="2" name="TextBox 1">
             <a:extLst>
               <a:ext uri="{FF2B5EF4-FFF2-40B4-BE49-F238E27FC236}">
-                <a16:creationId xmlns:a16="http://schemas.microsoft.com/office/drawing/2014/main" id="{AA9AC81B-A67D-76CB-865A-EA6D511E5769}"/>
+                <a16:creationId xmlns:a16="http://schemas.microsoft.com/office/drawing/2014/main" id="{4E2559FA-5F80-3CFB-6433-F263CFB09042}"/>
               </a:ext>
             </a:extLst>
           </p:cNvPr>
@@ -17377,7 +17374,7 @@
           <p:cNvPr id="3" name="TextBox 2">
             <a:extLst>
               <a:ext uri="{FF2B5EF4-FFF2-40B4-BE49-F238E27FC236}">
-                <a16:creationId xmlns:a16="http://schemas.microsoft.com/office/drawing/2014/main" id="{A319889C-C340-36C1-6FF9-BA2206CF381A}"/>
+                <a16:creationId xmlns:a16="http://schemas.microsoft.com/office/drawing/2014/main" id="{5128AAF9-4ED5-F55B-742D-93328B633B80}"/>
               </a:ext>
             </a:extLst>
           </p:cNvPr>
@@ -17417,7 +17414,7 @@
           <p:cNvPr id="4" name="Straight Connector 3">
             <a:extLst>
               <a:ext uri="{FF2B5EF4-FFF2-40B4-BE49-F238E27FC236}">
-                <a16:creationId xmlns:a16="http://schemas.microsoft.com/office/drawing/2014/main" id="{1D447650-25A6-C390-1D1B-8F65C4AE3079}"/>
+                <a16:creationId xmlns:a16="http://schemas.microsoft.com/office/drawing/2014/main" id="{6B00D609-C164-625B-228C-1B049D1D969B}"/>
               </a:ext>
             </a:extLst>
           </p:cNvPr>
@@ -17458,7 +17455,7 @@
           <p:cNvPr id="5" name="Rectangle: Rounded Corners 4">
             <a:extLst>
               <a:ext uri="{FF2B5EF4-FFF2-40B4-BE49-F238E27FC236}">
-                <a16:creationId xmlns:a16="http://schemas.microsoft.com/office/drawing/2014/main" id="{6CCCF8ED-F84B-2B2F-81A6-3B030FC45030}"/>
+                <a16:creationId xmlns:a16="http://schemas.microsoft.com/office/drawing/2014/main" id="{14A45F97-36B1-13BE-9F20-F88752BB4001}"/>
               </a:ext>
             </a:extLst>
           </p:cNvPr>
@@ -17512,7 +17509,7 @@
           <p:cNvPr id="6" name="Rectangle: Rounded Corners 5">
             <a:extLst>
               <a:ext uri="{FF2B5EF4-FFF2-40B4-BE49-F238E27FC236}">
-                <a16:creationId xmlns:a16="http://schemas.microsoft.com/office/drawing/2014/main" id="{188CEF83-E71C-681C-9B8E-61282A644FF6}"/>
+                <a16:creationId xmlns:a16="http://schemas.microsoft.com/office/drawing/2014/main" id="{5C6406D4-8115-3AD0-DF45-D08C436646C9}"/>
               </a:ext>
             </a:extLst>
           </p:cNvPr>
@@ -17566,7 +17563,7 @@
           <p:cNvPr id="7" name="TextBox 6">
             <a:extLst>
               <a:ext uri="{FF2B5EF4-FFF2-40B4-BE49-F238E27FC236}">
-                <a16:creationId xmlns:a16="http://schemas.microsoft.com/office/drawing/2014/main" id="{868348F1-89DE-BE34-8C77-000EFDD5040B}"/>
+                <a16:creationId xmlns:a16="http://schemas.microsoft.com/office/drawing/2014/main" id="{FDFD572E-4B31-4791-799E-9289AABAC41E}"/>
               </a:ext>
             </a:extLst>
           </p:cNvPr>
@@ -17607,7 +17604,7 @@
           <p:cNvPr id="8" name="TextBox 7">
             <a:extLst>
               <a:ext uri="{FF2B5EF4-FFF2-40B4-BE49-F238E27FC236}">
-                <a16:creationId xmlns:a16="http://schemas.microsoft.com/office/drawing/2014/main" id="{85FC37BC-684B-2BBF-F8AC-44A2D7678251}"/>
+                <a16:creationId xmlns:a16="http://schemas.microsoft.com/office/drawing/2014/main" id="{00DC96F4-09BA-76BB-EC18-F12D9C0313E7}"/>
               </a:ext>
             </a:extLst>
           </p:cNvPr>
@@ -17654,7 +17651,7 @@
           <p:cNvPr id="9" name="Rectangle: Rounded Corners 8">
             <a:extLst>
               <a:ext uri="{FF2B5EF4-FFF2-40B4-BE49-F238E27FC236}">
-                <a16:creationId xmlns:a16="http://schemas.microsoft.com/office/drawing/2014/main" id="{78CB02F2-FC63-DC2E-45FC-4C01BF9E3DC0}"/>
+                <a16:creationId xmlns:a16="http://schemas.microsoft.com/office/drawing/2014/main" id="{05BDD717-DD61-4325-503F-0D446783B160}"/>
               </a:ext>
             </a:extLst>
           </p:cNvPr>
@@ -17708,7 +17705,7 @@
           <p:cNvPr id="10" name="Rectangle: Rounded Corners 9">
             <a:extLst>
               <a:ext uri="{FF2B5EF4-FFF2-40B4-BE49-F238E27FC236}">
-                <a16:creationId xmlns:a16="http://schemas.microsoft.com/office/drawing/2014/main" id="{5A1E348C-1F21-8DA1-A9D9-18B169C24C3E}"/>
+                <a16:creationId xmlns:a16="http://schemas.microsoft.com/office/drawing/2014/main" id="{AFB0E151-443D-AB73-17CC-0F3312C03B58}"/>
               </a:ext>
             </a:extLst>
           </p:cNvPr>
@@ -17762,7 +17759,7 @@
           <p:cNvPr id="11" name="TextBox 10">
             <a:extLst>
               <a:ext uri="{FF2B5EF4-FFF2-40B4-BE49-F238E27FC236}">
-                <a16:creationId xmlns:a16="http://schemas.microsoft.com/office/drawing/2014/main" id="{8DAD2E73-B0F1-FC53-CEAC-9892C8C328A0}"/>
+                <a16:creationId xmlns:a16="http://schemas.microsoft.com/office/drawing/2014/main" id="{4B56F2C4-577F-6B2D-FF39-63FAC40F5260}"/>
               </a:ext>
             </a:extLst>
           </p:cNvPr>
@@ -17803,7 +17800,7 @@
           <p:cNvPr id="12" name="TextBox 11">
             <a:extLst>
               <a:ext uri="{FF2B5EF4-FFF2-40B4-BE49-F238E27FC236}">
-                <a16:creationId xmlns:a16="http://schemas.microsoft.com/office/drawing/2014/main" id="{EE5BF8F7-F332-737C-6258-030798ED5557}"/>
+                <a16:creationId xmlns:a16="http://schemas.microsoft.com/office/drawing/2014/main" id="{934398DA-3FF9-0562-FB03-7767765AAB8A}"/>
               </a:ext>
             </a:extLst>
           </p:cNvPr>
@@ -17850,7 +17847,7 @@
           <p:cNvPr id="13" name="Rectangle: Rounded Corners 12">
             <a:extLst>
               <a:ext uri="{FF2B5EF4-FFF2-40B4-BE49-F238E27FC236}">
-                <a16:creationId xmlns:a16="http://schemas.microsoft.com/office/drawing/2014/main" id="{09A1A098-1076-54C7-BE72-6513210E530B}"/>
+                <a16:creationId xmlns:a16="http://schemas.microsoft.com/office/drawing/2014/main" id="{7B380F46-2ACC-8C8F-727D-7276B3FBA8C1}"/>
               </a:ext>
             </a:extLst>
           </p:cNvPr>
@@ -17904,7 +17901,7 @@
           <p:cNvPr id="14" name="TextBox 13">
             <a:extLst>
               <a:ext uri="{FF2B5EF4-FFF2-40B4-BE49-F238E27FC236}">
-                <a16:creationId xmlns:a16="http://schemas.microsoft.com/office/drawing/2014/main" id="{6E617EFC-99F8-E579-954E-45534C3E1F1B}"/>
+                <a16:creationId xmlns:a16="http://schemas.microsoft.com/office/drawing/2014/main" id="{3FF03994-9F01-7AC8-3E37-18B7A028265C}"/>
               </a:ext>
             </a:extLst>
           </p:cNvPr>
@@ -17945,7 +17942,7 @@
           <p:cNvPr id="15" name="TextBox 14">
             <a:extLst>
               <a:ext uri="{FF2B5EF4-FFF2-40B4-BE49-F238E27FC236}">
-                <a16:creationId xmlns:a16="http://schemas.microsoft.com/office/drawing/2014/main" id="{9657717C-DCD7-2597-C5EC-9AE759ED933C}"/>
+                <a16:creationId xmlns:a16="http://schemas.microsoft.com/office/drawing/2014/main" id="{C6BF47E4-5EBF-278F-4C80-B4675DD03B2E}"/>
               </a:ext>
             </a:extLst>
           </p:cNvPr>
@@ -17985,7 +17982,7 @@
           <p:cNvPr id="16" name="TextBox 15">
             <a:extLst>
               <a:ext uri="{FF2B5EF4-FFF2-40B4-BE49-F238E27FC236}">
-                <a16:creationId xmlns:a16="http://schemas.microsoft.com/office/drawing/2014/main" id="{E9819102-E666-DEEA-87E8-FC4D14889E2C}"/>
+                <a16:creationId xmlns:a16="http://schemas.microsoft.com/office/drawing/2014/main" id="{3A8A0685-1EC8-1813-4398-8810DC53BED0}"/>
               </a:ext>
             </a:extLst>
           </p:cNvPr>
@@ -18024,7 +18021,7 @@
     </p:spTree>
     <p:extLst>
       <p:ext uri="{BB962C8B-B14F-4D97-AF65-F5344CB8AC3E}">
-        <p14:creationId xmlns:p14="http://schemas.microsoft.com/office/powerpoint/2010/main" val="714364110"/>
+        <p14:creationId xmlns:p14="http://schemas.microsoft.com/office/powerpoint/2010/main" val="2790825941"/>
       </p:ext>
     </p:extLst>
   </p:cSld>

</xml_diff>